<commit_message>
Setup slides: keep one command per line
</commit_message>
<xml_diff>
--- a/02_GROUP_DECK/ADBS_GROUP_DECK.pptx
+++ b/02_GROUP_DECK/ADBS_GROUP_DECK.pptx
@@ -9519,7 +9519,7 @@
               </a:lnSpc>
             </a:pPr>
             <a:r>
-              <a:rPr sz="915" b="0">
+              <a:rPr sz="1735" b="0">
                 <a:solidFill>
                   <a:srgbClr val="E6ECF2"/>
                 </a:solidFill>
@@ -9535,7 +9535,7 @@
               </a:lnSpc>
             </a:pPr>
             <a:r>
-              <a:rPr sz="915" b="0">
+              <a:rPr sz="1735" b="0">
                 <a:solidFill>
                   <a:srgbClr val="E6ECF2"/>
                 </a:solidFill>
@@ -9551,13 +9551,13 @@
               </a:lnSpc>
             </a:pPr>
             <a:r>
-              <a:rPr sz="915" b="0">
+              <a:rPr sz="1735" b="0">
                 <a:solidFill>
                   <a:srgbClr val="E6ECF2"/>
                 </a:solidFill>
                 <a:latin typeface="Courier New"/>
               </a:rPr>
-              <a:t>db.users.insertOne({"_id" : ObjectId("4b2b9f67a1f631733d917a7a"), "name" : "Joe", "friends" : 32, "enemies" : 2})</a:t>
+              <a:t>db.users.insertOne({"_id" : ObjectId("4b2b9f67a1f631733d917a7a"),</a:t>
             </a:r>
           </a:p>
           <a:p>
@@ -9567,13 +9567,13 @@
               </a:lnSpc>
             </a:pPr>
             <a:r>
-              <a:rPr sz="915" b="0">
+              <a:rPr sz="1735" b="0">
                 <a:solidFill>
                   <a:srgbClr val="E6ECF2"/>
                 </a:solidFill>
                 <a:latin typeface="Courier New"/>
               </a:rPr>
-              <a:t>db.users.insertOne({"_id" : ObjectId("4b253b067525f35f94b60a31"), "name" : "John", "age" : 24, "sex" : "male", "location" : "Taytay"})</a:t>
+              <a:t>  "name" : "Joe", "friends" : 32, "enemies" : 2})</a:t>
             </a:r>
           </a:p>
           <a:p>
@@ -9583,13 +9583,13 @@
               </a:lnSpc>
             </a:pPr>
             <a:r>
-              <a:rPr sz="915" b="0">
+              <a:rPr sz="1735" b="0">
                 <a:solidFill>
                   <a:srgbClr val="E6ECF2"/>
                 </a:solidFill>
                 <a:latin typeface="Courier New"/>
               </a:rPr>
-              <a:t>db.books.insertOne({"_id" : ObjectId("4b253b067525f35f94b60a31"), "title" : "MongoDB-2019", "author" : {"name" : "Nicole", "email" : "Nic@example.com"}})</a:t>
+              <a:t>db.users.insertOne({"_id" : ObjectId("4b253b067525f35f94b60a31"),</a:t>
             </a:r>
           </a:p>
           <a:p>
@@ -9599,13 +9599,109 @@
               </a:lnSpc>
             </a:pPr>
             <a:r>
-              <a:rPr sz="915" b="0">
+              <a:rPr sz="1735" b="0">
                 <a:solidFill>
                   <a:srgbClr val="E6ECF2"/>
                 </a:solidFill>
                 <a:latin typeface="Courier New"/>
               </a:rPr>
-              <a:t>db.users.insertMany([{"_id" : 1, "birthday" : "10/13/1978"}, {"_id" : 2, "birthday" : "10/13/1978"}, {"_id" : 3, "birthday" : "10/13/1978"}])</a:t>
+              <a:t>  "name" : "John", "age" : 24, "sex" : "male", "location" : "Taytay"})</a:t>
+            </a:r>
+          </a:p>
+          <a:p>
+            <a:pPr algn="l">
+              <a:lnSpc>
+                <a:spcPct val="100000"/>
+              </a:lnSpc>
+            </a:pPr>
+            <a:r>
+              <a:rPr sz="1735" b="0">
+                <a:solidFill>
+                  <a:srgbClr val="E6ECF2"/>
+                </a:solidFill>
+                <a:latin typeface="Courier New"/>
+              </a:rPr>
+              <a:t>db.books.insertOne({"_id" : ObjectId("4b253b067525f35f94b60a31"),</a:t>
+            </a:r>
+          </a:p>
+          <a:p>
+            <a:pPr algn="l">
+              <a:lnSpc>
+                <a:spcPct val="100000"/>
+              </a:lnSpc>
+            </a:pPr>
+            <a:r>
+              <a:rPr sz="1735" b="0">
+                <a:solidFill>
+                  <a:srgbClr val="E6ECF2"/>
+                </a:solidFill>
+                <a:latin typeface="Courier New"/>
+              </a:rPr>
+              <a:t>  "title" : "MongoDB-2019",</a:t>
+            </a:r>
+          </a:p>
+          <a:p>
+            <a:pPr algn="l">
+              <a:lnSpc>
+                <a:spcPct val="100000"/>
+              </a:lnSpc>
+            </a:pPr>
+            <a:r>
+              <a:rPr sz="1735" b="0">
+                <a:solidFill>
+                  <a:srgbClr val="E6ECF2"/>
+                </a:solidFill>
+                <a:latin typeface="Courier New"/>
+              </a:rPr>
+              <a:t>  "author" : {"name" : "Nicole", "email" : "Nic@example.com"}})</a:t>
+            </a:r>
+          </a:p>
+          <a:p>
+            <a:pPr algn="l">
+              <a:lnSpc>
+                <a:spcPct val="100000"/>
+              </a:lnSpc>
+            </a:pPr>
+            <a:r>
+              <a:rPr sz="1735" b="0">
+                <a:solidFill>
+                  <a:srgbClr val="E6ECF2"/>
+                </a:solidFill>
+                <a:latin typeface="Courier New"/>
+              </a:rPr>
+              <a:t>db.users.insertMany([{"_id" : 1, "birthday" : "10/13/1978"},</a:t>
+            </a:r>
+          </a:p>
+          <a:p>
+            <a:pPr algn="l">
+              <a:lnSpc>
+                <a:spcPct val="100000"/>
+              </a:lnSpc>
+            </a:pPr>
+            <a:r>
+              <a:rPr sz="1735" b="0">
+                <a:solidFill>
+                  <a:srgbClr val="E6ECF2"/>
+                </a:solidFill>
+                <a:latin typeface="Courier New"/>
+              </a:rPr>
+              <a:t>  {"_id" : 2, "birthday" : "10/13/1978"},</a:t>
+            </a:r>
+          </a:p>
+          <a:p>
+            <a:pPr algn="l">
+              <a:lnSpc>
+                <a:spcPct val="100000"/>
+              </a:lnSpc>
+            </a:pPr>
+            <a:r>
+              <a:rPr sz="1735" b="0">
+                <a:solidFill>
+                  <a:srgbClr val="E6ECF2"/>
+                </a:solidFill>
+                <a:latin typeface="Courier New"/>
+              </a:rPr>
+              <a:t>  {"_id" : 3, "birthday" : "10/13/1978"}])</a:t>
             </a:r>
           </a:p>
         </p:txBody>
@@ -15509,7 +15605,7 @@
               </a:lnSpc>
             </a:pPr>
             <a:r>
-              <a:rPr sz="900" b="0">
+              <a:rPr sz="1800" b="0">
                 <a:solidFill>
                   <a:srgbClr val="E6ECF2"/>
                 </a:solidFill>
@@ -15525,7 +15621,7 @@
               </a:lnSpc>
             </a:pPr>
             <a:r>
-              <a:rPr sz="900" b="0">
+              <a:rPr sz="1800" b="0">
                 <a:solidFill>
                   <a:srgbClr val="E6ECF2"/>
                 </a:solidFill>
@@ -15541,13 +15637,77 @@
               </a:lnSpc>
             </a:pPr>
             <a:r>
-              <a:rPr sz="900" b="0">
+              <a:rPr sz="1800" b="0">
                 <a:solidFill>
                   <a:srgbClr val="E6ECF2"/>
                 </a:solidFill>
                 <a:latin typeface="Courier New"/>
               </a:rPr>
-              <a:t>db.users.insertMany([{"_id" : 1, "name" : "Ana", "age" : 17}, {"_id" : 2, "name" : "Ben", "age" : 18}, {"_id" : 3, "name" : "Cara", "age" : 24}, {"_id" : 4, "name" : "Dan", "age" : 30}, {"_id" : 5, "name" : "Eli", "age" : 31}])</a:t>
+              <a:t>db.users.insertMany([{"_id" : 1, "name" : "Ana", "age" : 17},</a:t>
+            </a:r>
+          </a:p>
+          <a:p>
+            <a:pPr algn="l">
+              <a:lnSpc>
+                <a:spcPct val="100000"/>
+              </a:lnSpc>
+            </a:pPr>
+            <a:r>
+              <a:rPr sz="1800" b="0">
+                <a:solidFill>
+                  <a:srgbClr val="E6ECF2"/>
+                </a:solidFill>
+                <a:latin typeface="Courier New"/>
+              </a:rPr>
+              <a:t>  {"_id" : 2, "name" : "Ben", "age" : 18},</a:t>
+            </a:r>
+          </a:p>
+          <a:p>
+            <a:pPr algn="l">
+              <a:lnSpc>
+                <a:spcPct val="100000"/>
+              </a:lnSpc>
+            </a:pPr>
+            <a:r>
+              <a:rPr sz="1800" b="0">
+                <a:solidFill>
+                  <a:srgbClr val="E6ECF2"/>
+                </a:solidFill>
+                <a:latin typeface="Courier New"/>
+              </a:rPr>
+              <a:t>  {"_id" : 3, "name" : "Cara", "age" : 24},</a:t>
+            </a:r>
+          </a:p>
+          <a:p>
+            <a:pPr algn="l">
+              <a:lnSpc>
+                <a:spcPct val="100000"/>
+              </a:lnSpc>
+            </a:pPr>
+            <a:r>
+              <a:rPr sz="1800" b="0">
+                <a:solidFill>
+                  <a:srgbClr val="E6ECF2"/>
+                </a:solidFill>
+                <a:latin typeface="Courier New"/>
+              </a:rPr>
+              <a:t>  {"_id" : 4, "name" : "Dan", "age" : 30},</a:t>
+            </a:r>
+          </a:p>
+          <a:p>
+            <a:pPr algn="l">
+              <a:lnSpc>
+                <a:spcPct val="100000"/>
+              </a:lnSpc>
+            </a:pPr>
+            <a:r>
+              <a:rPr sz="1800" b="0">
+                <a:solidFill>
+                  <a:srgbClr val="E6ECF2"/>
+                </a:solidFill>
+                <a:latin typeface="Courier New"/>
+              </a:rPr>
+              <a:t>  {"_id" : 5, "name" : "Eli", "age" : 31}])</a:t>
             </a:r>
           </a:p>
         </p:txBody>
@@ -18985,7 +19145,7 @@
               </a:lnSpc>
             </a:pPr>
             <a:r>
-              <a:rPr sz="900" b="0">
+              <a:rPr sz="1800" b="0">
                 <a:solidFill>
                   <a:srgbClr val="E6ECF2"/>
                 </a:solidFill>
@@ -19001,7 +19161,7 @@
               </a:lnSpc>
             </a:pPr>
             <a:r>
-              <a:rPr sz="900" b="0">
+              <a:rPr sz="1800" b="0">
                 <a:solidFill>
                   <a:srgbClr val="E6ECF2"/>
                 </a:solidFill>
@@ -19017,13 +19177,13 @@
               </a:lnSpc>
             </a:pPr>
             <a:r>
-              <a:rPr sz="900" b="0">
+              <a:rPr sz="1800" b="0">
                 <a:solidFill>
                   <a:srgbClr val="E6ECF2"/>
                 </a:solidFill>
                 <a:latin typeface="Courier New"/>
               </a:rPr>
-              <a:t>db.raffle.insertMany([{"_id" : 1, "ticket_no" : 725, "winner" : false}, {"_id" : 2, "ticket_no" : 542, "winner" : false}, {"_id" : 3, "ticket_no" : 390, "winner" : false}, {"_id" : 4, "ticket_no" : 111, "winner" : true}, {"_id" : 5, "ticket_no" : 222, "winner" : false}])</a:t>
+              <a:t>db.raffle.insertMany([{"_id" : 1, "ticket_no" : 725, "winner" : false},</a:t>
             </a:r>
           </a:p>
           <a:p>
@@ -19033,13 +19193,109 @@
               </a:lnSpc>
             </a:pPr>
             <a:r>
-              <a:rPr sz="900" b="0">
+              <a:rPr sz="1800" b="0">
                 <a:solidFill>
                   <a:srgbClr val="E6ECF2"/>
                 </a:solidFill>
                 <a:latin typeface="Courier New"/>
               </a:rPr>
-              <a:t>db.users.insertMany([{"_id" : 1, "name" : "Rhea", "salary" : 8000}, {"_id" : 2, "name" : "Mark", "salary" : 10000}, {"_id" : 3, "name" : "Liza", "salary" : 15000}])</a:t>
+              <a:t>  {"_id" : 2, "ticket_no" : 542, "winner" : false},</a:t>
+            </a:r>
+          </a:p>
+          <a:p>
+            <a:pPr algn="l">
+              <a:lnSpc>
+                <a:spcPct val="100000"/>
+              </a:lnSpc>
+            </a:pPr>
+            <a:r>
+              <a:rPr sz="1800" b="0">
+                <a:solidFill>
+                  <a:srgbClr val="E6ECF2"/>
+                </a:solidFill>
+                <a:latin typeface="Courier New"/>
+              </a:rPr>
+              <a:t>  {"_id" : 3, "ticket_no" : 390, "winner" : false},</a:t>
+            </a:r>
+          </a:p>
+          <a:p>
+            <a:pPr algn="l">
+              <a:lnSpc>
+                <a:spcPct val="100000"/>
+              </a:lnSpc>
+            </a:pPr>
+            <a:r>
+              <a:rPr sz="1800" b="0">
+                <a:solidFill>
+                  <a:srgbClr val="E6ECF2"/>
+                </a:solidFill>
+                <a:latin typeface="Courier New"/>
+              </a:rPr>
+              <a:t>  {"_id" : 4, "ticket_no" : 111, "winner" : true},</a:t>
+            </a:r>
+          </a:p>
+          <a:p>
+            <a:pPr algn="l">
+              <a:lnSpc>
+                <a:spcPct val="100000"/>
+              </a:lnSpc>
+            </a:pPr>
+            <a:r>
+              <a:rPr sz="1800" b="0">
+                <a:solidFill>
+                  <a:srgbClr val="E6ECF2"/>
+                </a:solidFill>
+                <a:latin typeface="Courier New"/>
+              </a:rPr>
+              <a:t>  {"_id" : 5, "ticket_no" : 222, "winner" : false}])</a:t>
+            </a:r>
+          </a:p>
+          <a:p>
+            <a:pPr algn="l">
+              <a:lnSpc>
+                <a:spcPct val="100000"/>
+              </a:lnSpc>
+            </a:pPr>
+            <a:r>
+              <a:rPr sz="1800" b="0">
+                <a:solidFill>
+                  <a:srgbClr val="E6ECF2"/>
+                </a:solidFill>
+                <a:latin typeface="Courier New"/>
+              </a:rPr>
+              <a:t>db.users.insertMany([{"_id" : 1, "name" : "Rhea", "salary" : 8000},</a:t>
+            </a:r>
+          </a:p>
+          <a:p>
+            <a:pPr algn="l">
+              <a:lnSpc>
+                <a:spcPct val="100000"/>
+              </a:lnSpc>
+            </a:pPr>
+            <a:r>
+              <a:rPr sz="1800" b="0">
+                <a:solidFill>
+                  <a:srgbClr val="E6ECF2"/>
+                </a:solidFill>
+                <a:latin typeface="Courier New"/>
+              </a:rPr>
+              <a:t>  {"_id" : 2, "name" : "Mark", "salary" : 10000},</a:t>
+            </a:r>
+          </a:p>
+          <a:p>
+            <a:pPr algn="l">
+              <a:lnSpc>
+                <a:spcPct val="100000"/>
+              </a:lnSpc>
+            </a:pPr>
+            <a:r>
+              <a:rPr sz="1800" b="0">
+                <a:solidFill>
+                  <a:srgbClr val="E6ECF2"/>
+                </a:solidFill>
+                <a:latin typeface="Courier New"/>
+              </a:rPr>
+              <a:t>  {"_id" : 3, "name" : "Liza", "salary" : 15000}])</a:t>
             </a:r>
           </a:p>
         </p:txBody>
@@ -26072,7 +26328,7 @@
               </a:lnSpc>
             </a:pPr>
             <a:r>
-              <a:rPr sz="1176" b="0">
+              <a:rPr sz="1800" b="0">
                 <a:solidFill>
                   <a:srgbClr val="E6ECF2"/>
                 </a:solidFill>
@@ -26088,7 +26344,7 @@
               </a:lnSpc>
             </a:pPr>
             <a:r>
-              <a:rPr sz="1176" b="0">
+              <a:rPr sz="1800" b="0">
                 <a:solidFill>
                   <a:srgbClr val="E6ECF2"/>
                 </a:solidFill>
@@ -26104,13 +26360,13 @@
               </a:lnSpc>
             </a:pPr>
             <a:r>
-              <a:rPr sz="1176" b="0">
+              <a:rPr sz="1800" b="0">
                 <a:solidFill>
                   <a:srgbClr val="E6ECF2"/>
                 </a:solidFill>
                 <a:latin typeface="Courier New"/>
               </a:rPr>
-              <a:t>db.blog.posts.insertOne({"_id" : 1, "title" : "ADBS", "comments" : Array.from({length : 40}, (_, i) =&gt; "c" + (i + 1))})</a:t>
+              <a:t>db.blog.posts.insertOne({"_id" : 1, "title" : "ADBS",</a:t>
             </a:r>
           </a:p>
           <a:p>
@@ -26120,13 +26376,45 @@
               </a:lnSpc>
             </a:pPr>
             <a:r>
-              <a:rPr sz="1176" b="0">
+              <a:rPr sz="1800" b="0">
                 <a:solidFill>
                   <a:srgbClr val="E6ECF2"/>
                 </a:solidFill>
                 <a:latin typeface="Courier New"/>
               </a:rPr>
-              <a:t>db.people.insertOne({"_id" : 1, "name" : {"first" : "John", "last" : "Escalona"}, "age" : 45})</a:t>
+              <a:t>  "comments" : Array.from({length : 40}, (_, i) =&gt; "c" + (i + 1))})</a:t>
+            </a:r>
+          </a:p>
+          <a:p>
+            <a:pPr algn="l">
+              <a:lnSpc>
+                <a:spcPct val="100000"/>
+              </a:lnSpc>
+            </a:pPr>
+            <a:r>
+              <a:rPr sz="1800" b="0">
+                <a:solidFill>
+                  <a:srgbClr val="E6ECF2"/>
+                </a:solidFill>
+                <a:latin typeface="Courier New"/>
+              </a:rPr>
+              <a:t>db.people.insertOne({"_id" : 1,</a:t>
+            </a:r>
+          </a:p>
+          <a:p>
+            <a:pPr algn="l">
+              <a:lnSpc>
+                <a:spcPct val="100000"/>
+              </a:lnSpc>
+            </a:pPr>
+            <a:r>
+              <a:rPr sz="1800" b="0">
+                <a:solidFill>
+                  <a:srgbClr val="E6ECF2"/>
+                </a:solidFill>
+                <a:latin typeface="Courier New"/>
+              </a:rPr>
+              <a:t>  "name" : {"first" : "John", "last" : "Escalona"}, "age" : 45})</a:t>
             </a:r>
           </a:p>
         </p:txBody>

</xml_diff>

<commit_message>
Clearer screenshot steps; README for the shared-deck workflow
</commit_message>
<xml_diff>
--- a/02_GROUP_DECK/ADBS_GROUP_DECK.pptx
+++ b/02_GROUP_DECK/ADBS_GROUP_DECK.pptx
@@ -10277,7 +10277,7 @@
                 </a:solidFill>
                 <a:latin typeface="Arial"/>
               </a:rPr>
-              <a:t>3. Click this box, press Delete, then Ctrl + V.</a:t>
+              <a:t>3. Click this box, press Delete, press Ctrl + V, then drag the picture here.</a:t>
             </a:r>
           </a:p>
         </p:txBody>
@@ -10942,7 +10942,7 @@
                 </a:solidFill>
                 <a:latin typeface="Arial"/>
               </a:rPr>
-              <a:t>3. Click this box, press Delete, then Ctrl + V.</a:t>
+              <a:t>3. Click this box, press Delete, press Ctrl + V, then drag the picture here.</a:t>
             </a:r>
           </a:p>
         </p:txBody>
@@ -11559,7 +11559,7 @@
                 </a:solidFill>
                 <a:latin typeface="Arial"/>
               </a:rPr>
-              <a:t>3. Click this box, press Delete, then Ctrl + V.</a:t>
+              <a:t>3. Click this box, press Delete, press Ctrl + V, then drag the picture here.</a:t>
             </a:r>
           </a:p>
         </p:txBody>
@@ -11836,7 +11836,7 @@
                 </a:solidFill>
                 <a:latin typeface="Arial"/>
               </a:rPr>
-              <a:t>3. Click this box, press Delete, then Ctrl + V.</a:t>
+              <a:t>3. Click this box, press Delete, press Ctrl + V, then drag the picture here.</a:t>
             </a:r>
           </a:p>
         </p:txBody>
@@ -12355,7 +12355,7 @@
                 </a:solidFill>
                 <a:latin typeface="Arial"/>
               </a:rPr>
-              <a:t>3. Click this box, press Delete, then Ctrl + V.</a:t>
+              <a:t>3. Click this box, press Delete, press Ctrl + V, then drag the picture here.</a:t>
             </a:r>
           </a:p>
         </p:txBody>
@@ -12972,7 +12972,7 @@
                 </a:solidFill>
                 <a:latin typeface="Arial"/>
               </a:rPr>
-              <a:t>3. Click this box, press Delete, then Ctrl + V.</a:t>
+              <a:t>3. Click this box, press Delete, press Ctrl + V, then drag the picture here.</a:t>
             </a:r>
           </a:p>
         </p:txBody>
@@ -13589,7 +13589,7 @@
                 </a:solidFill>
                 <a:latin typeface="Arial"/>
               </a:rPr>
-              <a:t>3. Click this box, press Delete, then Ctrl + V.</a:t>
+              <a:t>3. Click this box, press Delete, press Ctrl + V, then drag the picture here.</a:t>
             </a:r>
           </a:p>
         </p:txBody>
@@ -14714,7 +14714,7 @@
                 </a:solidFill>
                 <a:latin typeface="Arial"/>
               </a:rPr>
-              <a:t>Win + Shift + S, select the result, then click the orange box → Delete → Ctrl + V.</a:t>
+              <a:t>Win + Shift + S (Mac: Cmd + Shift + 4). Click the orange box → Delete → Ctrl + V → drag the picture into place.</a:t>
             </a:r>
           </a:p>
         </p:txBody>
@@ -16972,7 +16972,7 @@
                 </a:solidFill>
                 <a:latin typeface="Arial"/>
               </a:rPr>
-              <a:t>3. Click this box, press Delete, then Ctrl + V.</a:t>
+              <a:t>3. Click this box, press Delete, press Ctrl + V, then drag the picture here.</a:t>
             </a:r>
           </a:p>
         </p:txBody>
@@ -17201,7 +17201,7 @@
                 </a:solidFill>
                 <a:latin typeface="Arial"/>
               </a:rPr>
-              <a:t>3. Click this box, press Delete, then Ctrl + V.</a:t>
+              <a:t>3. Click this box, press Delete, press Ctrl + V, then drag the picture here.</a:t>
             </a:r>
           </a:p>
         </p:txBody>
@@ -17704,7 +17704,7 @@
                 </a:solidFill>
                 <a:latin typeface="Arial"/>
               </a:rPr>
-              <a:t>3. Click this box, press Delete, then Ctrl + V.</a:t>
+              <a:t>3. Click this box, press Delete, press Ctrl + V, then drag the picture here.</a:t>
             </a:r>
           </a:p>
         </p:txBody>
@@ -17933,7 +17933,7 @@
                 </a:solidFill>
                 <a:latin typeface="Arial"/>
               </a:rPr>
-              <a:t>3. Click this box, press Delete, then Ctrl + V.</a:t>
+              <a:t>3. Click this box, press Delete, press Ctrl + V, then drag the picture here.</a:t>
             </a:r>
           </a:p>
         </p:txBody>
@@ -18436,7 +18436,7 @@
                 </a:solidFill>
                 <a:latin typeface="Arial"/>
               </a:rPr>
-              <a:t>3. Click this box, press Delete, then Ctrl + V.</a:t>
+              <a:t>3. Click this box, press Delete, press Ctrl + V, then drag the picture here.</a:t>
             </a:r>
           </a:p>
         </p:txBody>
@@ -19871,7 +19871,7 @@
                 </a:solidFill>
                 <a:latin typeface="Arial"/>
               </a:rPr>
-              <a:t>3. Click this box, press Delete, then Ctrl + V.</a:t>
+              <a:t>3. Click this box, press Delete, press Ctrl + V, then drag the picture here.</a:t>
             </a:r>
           </a:p>
         </p:txBody>
@@ -20472,7 +20472,7 @@
                 </a:solidFill>
                 <a:latin typeface="Arial"/>
               </a:rPr>
-              <a:t>3. Click this box, press Delete, then Ctrl + V.</a:t>
+              <a:t>3. Click this box, press Delete, press Ctrl + V, then drag the picture here.</a:t>
             </a:r>
           </a:p>
         </p:txBody>
@@ -21860,7 +21860,7 @@
                 </a:solidFill>
                 <a:latin typeface="Arial"/>
               </a:rPr>
-              <a:t>3. Click this box, press Delete, then Ctrl + V.</a:t>
+              <a:t>3. Click this box, press Delete, press Ctrl + V, then drag the picture here.</a:t>
             </a:r>
           </a:p>
         </p:txBody>
@@ -23215,7 +23215,7 @@
                 </a:solidFill>
                 <a:latin typeface="Arial"/>
               </a:rPr>
-              <a:t>3. Click this box, press Delete, then Ctrl + V.</a:t>
+              <a:t>3. Click this box, press Delete, press Ctrl + V, then drag the picture here.</a:t>
             </a:r>
           </a:p>
         </p:txBody>
@@ -23816,7 +23816,7 @@
                 </a:solidFill>
                 <a:latin typeface="Arial"/>
               </a:rPr>
-              <a:t>3. Click this box, press Delete, then Ctrl + V.</a:t>
+              <a:t>3. Click this box, press Delete, press Ctrl + V, then drag the picture here.</a:t>
             </a:r>
           </a:p>
         </p:txBody>
@@ -24417,7 +24417,7 @@
                 </a:solidFill>
                 <a:latin typeface="Arial"/>
               </a:rPr>
-              <a:t>3. Click this box, press Delete, then Ctrl + V.</a:t>
+              <a:t>3. Click this box, press Delete, press Ctrl + V, then drag the picture here.</a:t>
             </a:r>
           </a:p>
         </p:txBody>
@@ -25018,7 +25018,7 @@
                 </a:solidFill>
                 <a:latin typeface="Arial"/>
               </a:rPr>
-              <a:t>3. Click this box, press Delete, then Ctrl + V.</a:t>
+              <a:t>3. Click this box, press Delete, press Ctrl + V, then drag the picture here.</a:t>
             </a:r>
           </a:p>
         </p:txBody>
@@ -25619,7 +25619,7 @@
                 </a:solidFill>
                 <a:latin typeface="Arial"/>
               </a:rPr>
-              <a:t>3. Click this box, press Delete, then Ctrl + V.</a:t>
+              <a:t>3. Click this box, press Delete, press Ctrl + V, then drag the picture here.</a:t>
             </a:r>
           </a:p>
         </p:txBody>
@@ -28497,7 +28497,7 @@
                 </a:solidFill>
                 <a:latin typeface="Arial"/>
               </a:rPr>
-              <a:t>3. Click this box, press Delete, then Ctrl + V.</a:t>
+              <a:t>3. Click this box, press Delete, press Ctrl + V, then drag the picture here.</a:t>
             </a:r>
           </a:p>
         </p:txBody>
@@ -28726,7 +28726,7 @@
                 </a:solidFill>
                 <a:latin typeface="Arial"/>
               </a:rPr>
-              <a:t>3. Click this box, press Delete, then Ctrl + V.</a:t>
+              <a:t>3. Click this box, press Delete, press Ctrl + V, then drag the picture here.</a:t>
             </a:r>
           </a:p>
         </p:txBody>
@@ -29229,7 +29229,7 @@
                 </a:solidFill>
                 <a:latin typeface="Arial"/>
               </a:rPr>
-              <a:t>3. Click this box, press Delete, then Ctrl + V.</a:t>
+              <a:t>3. Click this box, press Delete, press Ctrl + V, then drag the picture here.</a:t>
             </a:r>
           </a:p>
         </p:txBody>
@@ -29830,7 +29830,7 @@
                 </a:solidFill>
                 <a:latin typeface="Arial"/>
               </a:rPr>
-              <a:t>3. Click this box, press Delete, then Ctrl + V.</a:t>
+              <a:t>3. Click this box, press Delete, press Ctrl + V, then drag the picture here.</a:t>
             </a:r>
           </a:p>
         </p:txBody>

</xml_diff>

<commit_message>
Exact 32 pt line pitch (no overflow in any app), balanced slide splits, 'Next' cue, tables fill the space
</commit_message>
<xml_diff>
--- a/02_GROUP_DECK/ADBS_GROUP_DECK.pptx
+++ b/02_GROUP_DECK/ADBS_GROUP_DECK.pptx
@@ -2972,7 +2972,7 @@
           </a:p>
           <a:p>
             <a:r>
-              <a:t>Dollar set can reach inside an embedded document. Author is a document inside the book. We use author dot name, in quotes, to change only the name.</a:t>
+              <a:t>Dollar set can reach inside an embedded document.</a:t>
             </a:r>
           </a:p>
           <a:p/>
@@ -3063,7 +3063,7 @@
           </a:p>
           <a:p>
             <a:r>
-              <a:t>(No new words. Let the class read this slide, then click.)</a:t>
+              <a:t>Author is a document inside the book. We use author dot name, in quotes, to change only the name.</a:t>
             </a:r>
           </a:p>
           <a:p/>
@@ -3245,7 +3245,7 @@
           </a:p>
           <a:p>
             <a:r>
-              <a:t>updateMany works like updateOne and takes the same parameters. The difference is how many documents can change. Three users share the birthday October 13, 1978. Matched 3, modified 3.</a:t>
+              <a:t>updateMany works like updateOne and takes the same parameters.</a:t>
             </a:r>
           </a:p>
           <a:p/>
@@ -3336,7 +3336,7 @@
           </a:p>
           <a:p>
             <a:r>
-              <a:t>(No new words. Let the class read this slide, then click.)</a:t>
+              <a:t>The difference is how many documents can change. Three users share the birthday October 13, 1978. Matched 3, modified 3.</a:t>
             </a:r>
           </a:p>
           <a:p/>
@@ -5488,7 +5488,7 @@
           </a:p>
           <a:p>
             <a:r>
-              <a:t>We insert the handout's three fruit baskets. Square brackets make an array. Before: the food collection is empty. The shell prints the reply of the last insertOne: inserted I D 3.</a:t>
+              <a:t>We insert the handout's three fruit baskets. Square brackets make an array. Before: the food collection is empty.</a:t>
             </a:r>
           </a:p>
           <a:p/>
@@ -5579,7 +5579,7 @@
           </a:p>
           <a:p>
             <a:r>
-              <a:t>(No new words. Let the class read this slide, then click.)</a:t>
+              <a:t>The shell prints the reply of the last insertOne: inserted I D 3.</a:t>
             </a:r>
           </a:p>
           <a:p/>
@@ -11795,7 +11795,7 @@
         <p:spPr>
           <a:xfrm>
             <a:off x="411480" y="1097280"/>
-            <a:ext cx="11368735" cy="1417320"/>
+            <a:ext cx="11368735" cy="1402080"/>
           </a:xfrm>
           <a:prstGeom prst="rect">
             <a:avLst/>
@@ -11894,8 +11894,8 @@
         </p:nvSpPr>
         <p:spPr>
           <a:xfrm>
-            <a:off x="411480" y="2624328"/>
-            <a:ext cx="11368735" cy="3063240"/>
+            <a:off x="411480" y="2609088"/>
+            <a:ext cx="11368735" cy="3027680"/>
           </a:xfrm>
           <a:prstGeom prst="rect">
             <a:avLst/>
@@ -11938,8 +11938,8 @@
         </p:nvSpPr>
         <p:spPr>
           <a:xfrm>
-            <a:off x="557784" y="2715768"/>
-            <a:ext cx="11149279" cy="2953512"/>
+            <a:off x="557784" y="2700528"/>
+            <a:ext cx="11149279" cy="2917951"/>
           </a:xfrm>
           <a:prstGeom prst="rect">
             <a:avLst/>
@@ -11954,7 +11954,7 @@
           <a:p>
             <a:pPr algn="l">
               <a:lnSpc>
-                <a:spcPct val="100000"/>
+                <a:spcPts val="3200"/>
               </a:lnSpc>
             </a:pPr>
             <a:r>
@@ -11970,7 +11970,7 @@
           <a:p>
             <a:pPr algn="l">
               <a:lnSpc>
-                <a:spcPct val="100000"/>
+                <a:spcPts val="3200"/>
               </a:lnSpc>
             </a:pPr>
             <a:r>
@@ -11986,7 +11986,7 @@
           <a:p>
             <a:pPr algn="l">
               <a:lnSpc>
-                <a:spcPct val="100000"/>
+                <a:spcPts val="3200"/>
               </a:lnSpc>
             </a:pPr>
             <a:r>
@@ -12002,7 +12002,7 @@
           <a:p>
             <a:pPr algn="l">
               <a:lnSpc>
-                <a:spcPct val="100000"/>
+                <a:spcPts val="3200"/>
               </a:lnSpc>
             </a:pPr>
             <a:r>
@@ -12018,7 +12018,7 @@
           <a:p>
             <a:pPr algn="l">
               <a:lnSpc>
-                <a:spcPct val="100000"/>
+                <a:spcPts val="3200"/>
               </a:lnSpc>
             </a:pPr>
             <a:r>
@@ -12034,7 +12034,7 @@
           <a:p>
             <a:pPr algn="l">
               <a:lnSpc>
-                <a:spcPct val="100000"/>
+                <a:spcPts val="3200"/>
               </a:lnSpc>
             </a:pPr>
             <a:r>
@@ -12050,7 +12050,7 @@
           <a:p>
             <a:pPr algn="l">
               <a:lnSpc>
-                <a:spcPct val="100000"/>
+                <a:spcPts val="3200"/>
               </a:lnSpc>
             </a:pPr>
             <a:r>
@@ -12300,7 +12300,7 @@
         <p:spPr>
           <a:xfrm>
             <a:off x="411480" y="1097280"/>
-            <a:ext cx="11368735" cy="1828800"/>
+            <a:ext cx="11368735" cy="1808479"/>
           </a:xfrm>
           <a:prstGeom prst="rect">
             <a:avLst/>
@@ -12368,7 +12368,46 @@
       </p:sp>
       <p:sp>
         <p:nvSpPr>
-          <p:cNvPr id="5" name="EXEMPT_FOOTER"/>
+          <p:cNvPr id="5" name="TextBox 4"/>
+          <p:cNvSpPr txBox="1"/>
+          <p:nvPr/>
+        </p:nvSpPr>
+        <p:spPr>
+          <a:xfrm>
+            <a:off x="411480" y="5696712"/>
+            <a:ext cx="11368735" cy="566928"/>
+          </a:xfrm>
+          <a:prstGeom prst="rect">
+            <a:avLst/>
+          </a:prstGeom>
+          <a:noFill/>
+        </p:spPr>
+        <p:txBody>
+          <a:bodyPr wrap="square" anchor="ctr" lIns="164592" rIns="164592" tIns="164592" bIns="164592">
+            <a:spAutoFit/>
+          </a:bodyPr>
+          <a:lstStyle/>
+          <a:p>
+            <a:pPr algn="r">
+              <a:lnSpc>
+                <a:spcPct val="100000"/>
+              </a:lnSpc>
+            </a:pPr>
+            <a:r>
+              <a:rPr sz="2800" b="0">
+                <a:solidFill>
+                  <a:srgbClr val="4A5868"/>
+                </a:solidFill>
+                <a:latin typeface="Arial"/>
+              </a:rPr>
+              <a:t>Next: 3  AFTER  →</a:t>
+            </a:r>
+          </a:p>
+        </p:txBody>
+      </p:sp>
+      <p:sp>
+        <p:nvSpPr>
+          <p:cNvPr id="6" name="EXEMPT_FOOTER"/>
           <p:cNvSpPr txBox="1"/>
           <p:nvPr/>
         </p:nvSpPr>
@@ -12407,7 +12446,7 @@
       </p:sp>
       <p:sp>
         <p:nvSpPr>
-          <p:cNvPr id="6" name="EXEMPT_FOOTER"/>
+          <p:cNvPr id="7" name="EXEMPT_FOOTER"/>
           <p:cNvSpPr txBox="1"/>
           <p:nvPr/>
         </p:nvSpPr>
@@ -12446,7 +12485,7 @@
       </p:sp>
       <p:sp>
         <p:nvSpPr>
-          <p:cNvPr id="7" name="EXEMPT_PROGRESS"/>
+          <p:cNvPr id="8" name="EXEMPT_PROGRESS"/>
           <p:cNvSpPr txBox="1"/>
           <p:nvPr/>
         </p:nvSpPr>
@@ -12601,7 +12640,7 @@
         <p:spPr>
           <a:xfrm>
             <a:off x="411480" y="1097280"/>
-            <a:ext cx="11368735" cy="2651760"/>
+            <a:ext cx="11368735" cy="2621280"/>
           </a:xfrm>
           <a:prstGeom prst="rect">
             <a:avLst/>
@@ -12984,7 +13023,7 @@
         <p:spPr>
           <a:xfrm>
             <a:off x="411480" y="1097280"/>
-            <a:ext cx="11368735" cy="1417320"/>
+            <a:ext cx="11368735" cy="1402080"/>
           </a:xfrm>
           <a:prstGeom prst="rect">
             <a:avLst/>
@@ -13083,8 +13122,8 @@
         </p:nvSpPr>
         <p:spPr>
           <a:xfrm>
-            <a:off x="411480" y="2624328"/>
-            <a:ext cx="11368735" cy="2651760"/>
+            <a:off x="411480" y="2609088"/>
+            <a:ext cx="11368735" cy="2621280"/>
           </a:xfrm>
           <a:prstGeom prst="rect">
             <a:avLst/>
@@ -13127,8 +13166,8 @@
         </p:nvSpPr>
         <p:spPr>
           <a:xfrm>
-            <a:off x="557784" y="2715768"/>
-            <a:ext cx="11149279" cy="2542032"/>
+            <a:off x="557784" y="2700528"/>
+            <a:ext cx="11149279" cy="2511552"/>
           </a:xfrm>
           <a:prstGeom prst="rect">
             <a:avLst/>
@@ -13143,7 +13182,7 @@
           <a:p>
             <a:pPr algn="l">
               <a:lnSpc>
-                <a:spcPct val="100000"/>
+                <a:spcPts val="3200"/>
               </a:lnSpc>
             </a:pPr>
             <a:r>
@@ -13159,7 +13198,7 @@
           <a:p>
             <a:pPr algn="l">
               <a:lnSpc>
-                <a:spcPct val="100000"/>
+                <a:spcPts val="3200"/>
               </a:lnSpc>
             </a:pPr>
             <a:r>
@@ -13175,7 +13214,7 @@
           <a:p>
             <a:pPr algn="l">
               <a:lnSpc>
-                <a:spcPct val="100000"/>
+                <a:spcPts val="3200"/>
               </a:lnSpc>
             </a:pPr>
             <a:r>
@@ -13191,7 +13230,7 @@
           <a:p>
             <a:pPr algn="l">
               <a:lnSpc>
-                <a:spcPct val="100000"/>
+                <a:spcPts val="3200"/>
               </a:lnSpc>
             </a:pPr>
             <a:r>
@@ -13207,7 +13246,7 @@
           <a:p>
             <a:pPr algn="l">
               <a:lnSpc>
-                <a:spcPct val="100000"/>
+                <a:spcPts val="3200"/>
               </a:lnSpc>
             </a:pPr>
             <a:r>
@@ -13223,7 +13262,7 @@
           <a:p>
             <a:pPr algn="l">
               <a:lnSpc>
-                <a:spcPct val="100000"/>
+                <a:spcPts val="3200"/>
               </a:lnSpc>
             </a:pPr>
             <a:r>
@@ -13240,7 +13279,46 @@
       </p:sp>
       <p:sp>
         <p:nvSpPr>
-          <p:cNvPr id="7" name="EXEMPT_FOOTER"/>
+          <p:cNvPr id="7" name="TextBox 6"/>
+          <p:cNvSpPr txBox="1"/>
+          <p:nvPr/>
+        </p:nvSpPr>
+        <p:spPr>
+          <a:xfrm>
+            <a:off x="411480" y="5696712"/>
+            <a:ext cx="11368735" cy="566928"/>
+          </a:xfrm>
+          <a:prstGeom prst="rect">
+            <a:avLst/>
+          </a:prstGeom>
+          <a:noFill/>
+        </p:spPr>
+        <p:txBody>
+          <a:bodyPr wrap="square" anchor="ctr" lIns="164592" rIns="164592" tIns="164592" bIns="164592">
+            <a:spAutoFit/>
+          </a:bodyPr>
+          <a:lstStyle/>
+          <a:p>
+            <a:pPr algn="r">
+              <a:lnSpc>
+                <a:spcPct val="100000"/>
+              </a:lnSpc>
+            </a:pPr>
+            <a:r>
+              <a:rPr sz="2800" b="0">
+                <a:solidFill>
+                  <a:srgbClr val="4A5868"/>
+                </a:solidFill>
+                <a:latin typeface="Arial"/>
+              </a:rPr>
+              <a:t>Next: 2  REPLY  →</a:t>
+            </a:r>
+          </a:p>
+        </p:txBody>
+      </p:sp>
+      <p:sp>
+        <p:nvSpPr>
+          <p:cNvPr id="8" name="EXEMPT_FOOTER"/>
           <p:cNvSpPr txBox="1"/>
           <p:nvPr/>
         </p:nvSpPr>
@@ -13279,7 +13357,7 @@
       </p:sp>
       <p:sp>
         <p:nvSpPr>
-          <p:cNvPr id="8" name="EXEMPT_FOOTER"/>
+          <p:cNvPr id="9" name="EXEMPT_FOOTER"/>
           <p:cNvSpPr txBox="1"/>
           <p:nvPr/>
         </p:nvSpPr>
@@ -13318,7 +13396,7 @@
       </p:sp>
       <p:sp>
         <p:nvSpPr>
-          <p:cNvPr id="9" name="EXEMPT_PROGRESS"/>
+          <p:cNvPr id="10" name="EXEMPT_PROGRESS"/>
           <p:cNvSpPr txBox="1"/>
           <p:nvPr/>
         </p:nvSpPr>
@@ -13473,7 +13551,7 @@
         <p:spPr>
           <a:xfrm>
             <a:off x="411480" y="1097280"/>
-            <a:ext cx="11368735" cy="1828800"/>
+            <a:ext cx="11368735" cy="1808479"/>
           </a:xfrm>
           <a:prstGeom prst="rect">
             <a:avLst/>
@@ -13547,8 +13625,8 @@
         </p:nvSpPr>
         <p:spPr>
           <a:xfrm>
-            <a:off x="411480" y="3035808"/>
-            <a:ext cx="11368735" cy="2240280"/>
+            <a:off x="411480" y="3015487"/>
+            <a:ext cx="11368735" cy="2214880"/>
           </a:xfrm>
           <a:prstGeom prst="rect">
             <a:avLst/>
@@ -13931,7 +14009,7 @@
         <p:spPr>
           <a:xfrm>
             <a:off x="411480" y="1097280"/>
-            <a:ext cx="11368735" cy="2651760"/>
+            <a:ext cx="11368735" cy="2621280"/>
           </a:xfrm>
           <a:prstGeom prst="rect">
             <a:avLst/>
@@ -14030,8 +14108,8 @@
         </p:nvSpPr>
         <p:spPr>
           <a:xfrm>
-            <a:off x="411480" y="3858768"/>
-            <a:ext cx="11368735" cy="1005840"/>
+            <a:off x="411480" y="3828288"/>
+            <a:ext cx="11368735" cy="995679"/>
           </a:xfrm>
           <a:prstGeom prst="rect">
             <a:avLst/>
@@ -14074,8 +14152,8 @@
         </p:nvSpPr>
         <p:spPr>
           <a:xfrm>
-            <a:off x="557784" y="3950208"/>
-            <a:ext cx="11149279" cy="896112"/>
+            <a:off x="557784" y="3919727"/>
+            <a:ext cx="11149279" cy="885951"/>
           </a:xfrm>
           <a:prstGeom prst="rect">
             <a:avLst/>
@@ -14090,7 +14168,7 @@
           <a:p>
             <a:pPr algn="l">
               <a:lnSpc>
-                <a:spcPct val="100000"/>
+                <a:spcPts val="3200"/>
               </a:lnSpc>
             </a:pPr>
             <a:r>
@@ -14106,7 +14184,7 @@
           <a:p>
             <a:pPr algn="l">
               <a:lnSpc>
-                <a:spcPct val="100000"/>
+                <a:spcPts val="3200"/>
               </a:lnSpc>
             </a:pPr>
             <a:r>
@@ -14123,7 +14201,46 @@
       </p:sp>
       <p:sp>
         <p:nvSpPr>
-          <p:cNvPr id="7" name="EXEMPT_FOOTER"/>
+          <p:cNvPr id="7" name="TextBox 6"/>
+          <p:cNvSpPr txBox="1"/>
+          <p:nvPr/>
+        </p:nvSpPr>
+        <p:spPr>
+          <a:xfrm>
+            <a:off x="411480" y="5696712"/>
+            <a:ext cx="11368735" cy="566928"/>
+          </a:xfrm>
+          <a:prstGeom prst="rect">
+            <a:avLst/>
+          </a:prstGeom>
+          <a:noFill/>
+        </p:spPr>
+        <p:txBody>
+          <a:bodyPr wrap="square" anchor="ctr" lIns="164592" rIns="164592" tIns="164592" bIns="164592">
+            <a:spAutoFit/>
+          </a:bodyPr>
+          <a:lstStyle/>
+          <a:p>
+            <a:pPr algn="r">
+              <a:lnSpc>
+                <a:spcPct val="100000"/>
+              </a:lnSpc>
+            </a:pPr>
+            <a:r>
+              <a:rPr sz="2800" b="0">
+                <a:solidFill>
+                  <a:srgbClr val="4A5868"/>
+                </a:solidFill>
+                <a:latin typeface="Arial"/>
+              </a:rPr>
+              <a:t>Next: 2  REPLY  →</a:t>
+            </a:r>
+          </a:p>
+        </p:txBody>
+      </p:sp>
+      <p:sp>
+        <p:nvSpPr>
+          <p:cNvPr id="8" name="EXEMPT_FOOTER"/>
           <p:cNvSpPr txBox="1"/>
           <p:nvPr/>
         </p:nvSpPr>
@@ -14162,7 +14279,7 @@
       </p:sp>
       <p:sp>
         <p:nvSpPr>
-          <p:cNvPr id="8" name="EXEMPT_FOOTER"/>
+          <p:cNvPr id="9" name="EXEMPT_FOOTER"/>
           <p:cNvSpPr txBox="1"/>
           <p:nvPr/>
         </p:nvSpPr>
@@ -14201,7 +14318,7 @@
       </p:sp>
       <p:sp>
         <p:nvSpPr>
-          <p:cNvPr id="9" name="EXEMPT_PROGRESS"/>
+          <p:cNvPr id="10" name="EXEMPT_PROGRESS"/>
           <p:cNvSpPr txBox="1"/>
           <p:nvPr/>
         </p:nvSpPr>
@@ -14356,7 +14473,7 @@
         <p:spPr>
           <a:xfrm>
             <a:off x="411480" y="1097280"/>
-            <a:ext cx="11368735" cy="1417320"/>
+            <a:ext cx="11368735" cy="1402080"/>
           </a:xfrm>
           <a:prstGeom prst="rect">
             <a:avLst/>
@@ -14430,8 +14547,8 @@
         </p:nvSpPr>
         <p:spPr>
           <a:xfrm>
-            <a:off x="411480" y="2624328"/>
-            <a:ext cx="11368735" cy="2240280"/>
+            <a:off x="411480" y="2609088"/>
+            <a:ext cx="11368735" cy="2214880"/>
           </a:xfrm>
           <a:prstGeom prst="rect">
             <a:avLst/>
@@ -14814,7 +14931,7 @@
         <p:spPr>
           <a:xfrm>
             <a:off x="411480" y="1097280"/>
-            <a:ext cx="11368735" cy="3474720"/>
+            <a:ext cx="11368735" cy="3434080"/>
           </a:xfrm>
           <a:prstGeom prst="rect">
             <a:avLst/>
@@ -14913,8 +15030,8 @@
         </p:nvSpPr>
         <p:spPr>
           <a:xfrm>
-            <a:off x="411480" y="4681728"/>
-            <a:ext cx="11368735" cy="1005840"/>
+            <a:off x="411480" y="4641088"/>
+            <a:ext cx="11368735" cy="995679"/>
           </a:xfrm>
           <a:prstGeom prst="rect">
             <a:avLst/>
@@ -14957,8 +15074,8 @@
         </p:nvSpPr>
         <p:spPr>
           <a:xfrm>
-            <a:off x="557784" y="4773168"/>
-            <a:ext cx="11149279" cy="896112"/>
+            <a:off x="557784" y="4732528"/>
+            <a:ext cx="11149279" cy="885951"/>
           </a:xfrm>
           <a:prstGeom prst="rect">
             <a:avLst/>
@@ -14973,7 +15090,7 @@
           <a:p>
             <a:pPr algn="l">
               <a:lnSpc>
-                <a:spcPct val="100000"/>
+                <a:spcPts val="3200"/>
               </a:lnSpc>
             </a:pPr>
             <a:r>
@@ -14989,7 +15106,7 @@
           <a:p>
             <a:pPr algn="l">
               <a:lnSpc>
-                <a:spcPct val="100000"/>
+                <a:spcPts val="3200"/>
               </a:lnSpc>
             </a:pPr>
             <a:r>
@@ -15239,7 +15356,7 @@
         <p:spPr>
           <a:xfrm>
             <a:off x="411480" y="1097280"/>
-            <a:ext cx="11368735" cy="1417320"/>
+            <a:ext cx="11368735" cy="1402080"/>
           </a:xfrm>
           <a:prstGeom prst="rect">
             <a:avLst/>
@@ -15313,8 +15430,8 @@
         </p:nvSpPr>
         <p:spPr>
           <a:xfrm>
-            <a:off x="411480" y="2624328"/>
-            <a:ext cx="11368735" cy="1417320"/>
+            <a:off x="411480" y="2609088"/>
+            <a:ext cx="11368735" cy="1402080"/>
           </a:xfrm>
           <a:prstGeom prst="rect">
             <a:avLst/>
@@ -17671,7 +17788,7 @@
         <p:spPr>
           <a:xfrm>
             <a:off x="411480" y="1097280"/>
-            <a:ext cx="11368735" cy="1005840"/>
+            <a:ext cx="11368735" cy="995679"/>
           </a:xfrm>
           <a:prstGeom prst="rect">
             <a:avLst/>
@@ -17715,7 +17832,7 @@
         <p:spPr>
           <a:xfrm>
             <a:off x="557784" y="1188720"/>
-            <a:ext cx="11149279" cy="896112"/>
+            <a:ext cx="11149279" cy="885951"/>
           </a:xfrm>
           <a:prstGeom prst="rect">
             <a:avLst/>
@@ -17730,7 +17847,7 @@
           <a:p>
             <a:pPr algn="l">
               <a:lnSpc>
-                <a:spcPct val="100000"/>
+                <a:spcPts val="3200"/>
               </a:lnSpc>
             </a:pPr>
             <a:r>
@@ -17746,7 +17863,7 @@
           <a:p>
             <a:pPr algn="l">
               <a:lnSpc>
-                <a:spcPct val="100000"/>
+                <a:spcPts val="3200"/>
               </a:lnSpc>
             </a:pPr>
             <a:r>
@@ -17769,8 +17886,8 @@
         </p:nvSpPr>
         <p:spPr>
           <a:xfrm>
-            <a:off x="411480" y="2212848"/>
-            <a:ext cx="11368735" cy="3063240"/>
+            <a:off x="411480" y="2202688"/>
+            <a:ext cx="11368735" cy="3027680"/>
           </a:xfrm>
           <a:prstGeom prst="rect">
             <a:avLst/>
@@ -18089,7 +18206,7 @@
         <p:spPr>
           <a:xfrm>
             <a:off x="411480" y="1097280"/>
-            <a:ext cx="11368735" cy="3063240"/>
+            <a:ext cx="11368735" cy="3027680"/>
           </a:xfrm>
           <a:prstGeom prst="rect">
             <a:avLst/>
@@ -18182,7 +18299,46 @@
       </p:sp>
       <p:sp>
         <p:nvSpPr>
-          <p:cNvPr id="5" name="EXEMPT_FOOTER"/>
+          <p:cNvPr id="5" name="TextBox 4"/>
+          <p:cNvSpPr txBox="1"/>
+          <p:nvPr/>
+        </p:nvSpPr>
+        <p:spPr>
+          <a:xfrm>
+            <a:off x="411480" y="5696712"/>
+            <a:ext cx="11368735" cy="566928"/>
+          </a:xfrm>
+          <a:prstGeom prst="rect">
+            <a:avLst/>
+          </a:prstGeom>
+          <a:noFill/>
+        </p:spPr>
+        <p:txBody>
+          <a:bodyPr wrap="square" anchor="ctr" lIns="164592" rIns="164592" tIns="164592" bIns="164592">
+            <a:spAutoFit/>
+          </a:bodyPr>
+          <a:lstStyle/>
+          <a:p>
+            <a:pPr algn="r">
+              <a:lnSpc>
+                <a:spcPct val="100000"/>
+              </a:lnSpc>
+            </a:pPr>
+            <a:r>
+              <a:rPr sz="2800" b="0">
+                <a:solidFill>
+                  <a:srgbClr val="4A5868"/>
+                </a:solidFill>
+                <a:latin typeface="Arial"/>
+              </a:rPr>
+              <a:t>Next: 2  COMMAND  →</a:t>
+            </a:r>
+          </a:p>
+        </p:txBody>
+      </p:sp>
+      <p:sp>
+        <p:nvSpPr>
+          <p:cNvPr id="6" name="EXEMPT_FOOTER"/>
           <p:cNvSpPr txBox="1"/>
           <p:nvPr/>
         </p:nvSpPr>
@@ -18221,7 +18377,7 @@
       </p:sp>
       <p:sp>
         <p:nvSpPr>
-          <p:cNvPr id="6" name="EXEMPT_PROGRESS"/>
+          <p:cNvPr id="7" name="EXEMPT_PROGRESS"/>
           <p:cNvSpPr txBox="1"/>
           <p:nvPr/>
         </p:nvSpPr>
@@ -18376,7 +18532,7 @@
         <p:spPr>
           <a:xfrm>
             <a:off x="411480" y="1097280"/>
-            <a:ext cx="11368735" cy="3474720"/>
+            <a:ext cx="11368735" cy="3434080"/>
           </a:xfrm>
           <a:prstGeom prst="rect">
             <a:avLst/>
@@ -18420,7 +18576,7 @@
         <p:spPr>
           <a:xfrm>
             <a:off x="557784" y="1188720"/>
-            <a:ext cx="11149279" cy="3364992"/>
+            <a:ext cx="11149279" cy="3324352"/>
           </a:xfrm>
           <a:prstGeom prst="rect">
             <a:avLst/>
@@ -18435,7 +18591,7 @@
           <a:p>
             <a:pPr algn="l">
               <a:lnSpc>
-                <a:spcPct val="100000"/>
+                <a:spcPts val="3200"/>
               </a:lnSpc>
             </a:pPr>
             <a:r>
@@ -18451,7 +18607,7 @@
           <a:p>
             <a:pPr algn="l">
               <a:lnSpc>
-                <a:spcPct val="100000"/>
+                <a:spcPts val="3200"/>
               </a:lnSpc>
             </a:pPr>
             <a:r>
@@ -18467,7 +18623,7 @@
           <a:p>
             <a:pPr algn="l">
               <a:lnSpc>
-                <a:spcPct val="100000"/>
+                <a:spcPts val="3200"/>
               </a:lnSpc>
             </a:pPr>
             <a:r>
@@ -18483,7 +18639,7 @@
           <a:p>
             <a:pPr algn="l">
               <a:lnSpc>
-                <a:spcPct val="100000"/>
+                <a:spcPts val="3200"/>
               </a:lnSpc>
             </a:pPr>
             <a:r>
@@ -18499,7 +18655,7 @@
           <a:p>
             <a:pPr algn="l">
               <a:lnSpc>
-                <a:spcPct val="100000"/>
+                <a:spcPts val="3200"/>
               </a:lnSpc>
             </a:pPr>
             <a:r>
@@ -18515,7 +18671,7 @@
           <a:p>
             <a:pPr algn="l">
               <a:lnSpc>
-                <a:spcPct val="100000"/>
+                <a:spcPts val="3200"/>
               </a:lnSpc>
             </a:pPr>
             <a:r>
@@ -18531,7 +18687,7 @@
           <a:p>
             <a:pPr algn="l">
               <a:lnSpc>
-                <a:spcPct val="100000"/>
+                <a:spcPts val="3200"/>
               </a:lnSpc>
             </a:pPr>
             <a:r>
@@ -18547,7 +18703,7 @@
           <a:p>
             <a:pPr algn="l">
               <a:lnSpc>
-                <a:spcPct val="100000"/>
+                <a:spcPts val="3200"/>
               </a:lnSpc>
             </a:pPr>
             <a:r>
@@ -18564,7 +18720,46 @@
       </p:sp>
       <p:sp>
         <p:nvSpPr>
-          <p:cNvPr id="6" name="EXEMPT_FOOTER"/>
+          <p:cNvPr id="6" name="TextBox 5"/>
+          <p:cNvSpPr txBox="1"/>
+          <p:nvPr/>
+        </p:nvSpPr>
+        <p:spPr>
+          <a:xfrm>
+            <a:off x="411480" y="5696712"/>
+            <a:ext cx="11368735" cy="566928"/>
+          </a:xfrm>
+          <a:prstGeom prst="rect">
+            <a:avLst/>
+          </a:prstGeom>
+          <a:noFill/>
+        </p:spPr>
+        <p:txBody>
+          <a:bodyPr wrap="square" anchor="ctr" lIns="164592" rIns="164592" tIns="164592" bIns="164592">
+            <a:spAutoFit/>
+          </a:bodyPr>
+          <a:lstStyle/>
+          <a:p>
+            <a:pPr algn="r">
+              <a:lnSpc>
+                <a:spcPct val="100000"/>
+              </a:lnSpc>
+            </a:pPr>
+            <a:r>
+              <a:rPr sz="2800" b="0">
+                <a:solidFill>
+                  <a:srgbClr val="4A5868"/>
+                </a:solidFill>
+                <a:latin typeface="Arial"/>
+              </a:rPr>
+              <a:t>Next: 2  REPLY  →</a:t>
+            </a:r>
+          </a:p>
+        </p:txBody>
+      </p:sp>
+      <p:sp>
+        <p:nvSpPr>
+          <p:cNvPr id="7" name="EXEMPT_FOOTER"/>
           <p:cNvSpPr txBox="1"/>
           <p:nvPr/>
         </p:nvSpPr>
@@ -18603,7 +18798,7 @@
       </p:sp>
       <p:sp>
         <p:nvSpPr>
-          <p:cNvPr id="7" name="EXEMPT_PROGRESS"/>
+          <p:cNvPr id="8" name="EXEMPT_PROGRESS"/>
           <p:cNvSpPr txBox="1"/>
           <p:nvPr/>
         </p:nvSpPr>
@@ -18758,7 +18953,7 @@
         <p:spPr>
           <a:xfrm>
             <a:off x="411480" y="1097280"/>
-            <a:ext cx="11368735" cy="1828800"/>
+            <a:ext cx="11368735" cy="1808479"/>
           </a:xfrm>
           <a:prstGeom prst="rect">
             <a:avLst/>
@@ -18826,7 +19021,46 @@
       </p:sp>
       <p:sp>
         <p:nvSpPr>
-          <p:cNvPr id="5" name="EXEMPT_FOOTER"/>
+          <p:cNvPr id="5" name="TextBox 4"/>
+          <p:cNvSpPr txBox="1"/>
+          <p:nvPr/>
+        </p:nvSpPr>
+        <p:spPr>
+          <a:xfrm>
+            <a:off x="411480" y="5696712"/>
+            <a:ext cx="11368735" cy="566928"/>
+          </a:xfrm>
+          <a:prstGeom prst="rect">
+            <a:avLst/>
+          </a:prstGeom>
+          <a:noFill/>
+        </p:spPr>
+        <p:txBody>
+          <a:bodyPr wrap="square" anchor="ctr" lIns="164592" rIns="164592" tIns="164592" bIns="164592">
+            <a:spAutoFit/>
+          </a:bodyPr>
+          <a:lstStyle/>
+          <a:p>
+            <a:pPr algn="r">
+              <a:lnSpc>
+                <a:spcPct val="100000"/>
+              </a:lnSpc>
+            </a:pPr>
+            <a:r>
+              <a:rPr sz="2800" b="0">
+                <a:solidFill>
+                  <a:srgbClr val="4A5868"/>
+                </a:solidFill>
+                <a:latin typeface="Arial"/>
+              </a:rPr>
+              <a:t>Next: 3  AFTER  →</a:t>
+            </a:r>
+          </a:p>
+        </p:txBody>
+      </p:sp>
+      <p:sp>
+        <p:nvSpPr>
+          <p:cNvPr id="6" name="EXEMPT_FOOTER"/>
           <p:cNvSpPr txBox="1"/>
           <p:nvPr/>
         </p:nvSpPr>
@@ -18865,7 +19099,7 @@
       </p:sp>
       <p:sp>
         <p:nvSpPr>
-          <p:cNvPr id="6" name="EXEMPT_PROGRESS"/>
+          <p:cNvPr id="7" name="EXEMPT_PROGRESS"/>
           <p:cNvSpPr txBox="1"/>
           <p:nvPr/>
         </p:nvSpPr>
@@ -19020,7 +19254,7 @@
         <p:spPr>
           <a:xfrm>
             <a:off x="411480" y="1097280"/>
-            <a:ext cx="11368735" cy="2651760"/>
+            <a:ext cx="11368735" cy="2621280"/>
           </a:xfrm>
           <a:prstGeom prst="rect">
             <a:avLst/>
@@ -19364,7 +19598,7 @@
         <p:spPr>
           <a:xfrm>
             <a:off x="411480" y="1097280"/>
-            <a:ext cx="11368735" cy="3063240"/>
+            <a:ext cx="11368735" cy="3027680"/>
           </a:xfrm>
           <a:prstGeom prst="rect">
             <a:avLst/>
@@ -19457,58 +19691,14 @@
       </p:sp>
       <p:sp>
         <p:nvSpPr>
-          <p:cNvPr id="5" name="Rectangle 4"/>
-          <p:cNvSpPr/>
-          <p:nvPr/>
-        </p:nvSpPr>
-        <p:spPr>
-          <a:xfrm>
-            <a:off x="411480" y="4270248"/>
-            <a:ext cx="11368735" cy="1828800"/>
-          </a:xfrm>
-          <a:prstGeom prst="rect">
-            <a:avLst/>
-          </a:prstGeom>
-          <a:solidFill>
-            <a:srgbClr val="16212E"/>
-          </a:solidFill>
-          <a:ln>
-            <a:noFill/>
-          </a:ln>
-          <a:effectLst/>
-        </p:spPr>
-        <p:style>
-          <a:lnRef idx="1">
-            <a:schemeClr val="accent1"/>
-          </a:lnRef>
-          <a:fillRef idx="3">
-            <a:schemeClr val="accent1"/>
-          </a:fillRef>
-          <a:effectRef idx="2">
-            <a:schemeClr val="accent1"/>
-          </a:effectRef>
-          <a:fontRef idx="minor">
-            <a:schemeClr val="lt1"/>
-          </a:fontRef>
-        </p:style>
-        <p:txBody>
-          <a:bodyPr rtlCol="0" anchor="ctr"/>
-          <a:lstStyle/>
-          <a:p>
-            <a:pPr algn="ctr"/>
-          </a:p>
-        </p:txBody>
-      </p:sp>
-      <p:sp>
-        <p:nvSpPr>
-          <p:cNvPr id="6" name="TextBox 5"/>
+          <p:cNvPr id="5" name="TextBox 4"/>
           <p:cNvSpPr txBox="1"/>
           <p:nvPr/>
         </p:nvSpPr>
         <p:spPr>
           <a:xfrm>
-            <a:off x="557784" y="4361688"/>
-            <a:ext cx="11149279" cy="1719072"/>
+            <a:off x="411480" y="5696712"/>
+            <a:ext cx="11368735" cy="566928"/>
           </a:xfrm>
           <a:prstGeom prst="rect">
             <a:avLst/>
@@ -19516,28 +19706,12 @@
           <a:noFill/>
         </p:spPr>
         <p:txBody>
-          <a:bodyPr wrap="none" anchor="t" lIns="0" rIns="0" tIns="0" bIns="0">
+          <a:bodyPr wrap="square" anchor="ctr" lIns="164592" rIns="164592" tIns="164592" bIns="164592">
             <a:spAutoFit/>
           </a:bodyPr>
           <a:lstStyle/>
           <a:p>
-            <a:pPr algn="l">
-              <a:lnSpc>
-                <a:spcPct val="100000"/>
-              </a:lnSpc>
-            </a:pPr>
-            <a:r>
-              <a:rPr sz="2800" b="1">
-                <a:solidFill>
-                  <a:srgbClr val="F2B27A"/>
-                </a:solidFill>
-                <a:latin typeface="Arial"/>
-              </a:rPr>
-              <a:t>2  COMMAND</a:t>
-            </a:r>
-          </a:p>
-          <a:p>
-            <a:pPr algn="l">
+            <a:pPr algn="r">
               <a:lnSpc>
                 <a:spcPct val="100000"/>
               </a:lnSpc>
@@ -19545,50 +19719,18 @@
             <a:r>
               <a:rPr sz="2800" b="0">
                 <a:solidFill>
-                  <a:srgbClr val="E6ECF2"/>
-                </a:solidFill>
-                <a:latin typeface="Courier New"/>
-              </a:rPr>
-              <a:t>db.users.updateOne({"name" : "John"},</a:t>
-            </a:r>
-          </a:p>
-          <a:p>
-            <a:pPr algn="l">
-              <a:lnSpc>
-                <a:spcPct val="100000"/>
-              </a:lnSpc>
-            </a:pPr>
-            <a:r>
-              <a:rPr sz="2800" b="0">
-                <a:solidFill>
-                  <a:srgbClr val="E6ECF2"/>
-                </a:solidFill>
-                <a:latin typeface="Courier New"/>
-              </a:rPr>
-              <a:t>  {"$set" : {"favorite book" :</a:t>
-            </a:r>
-          </a:p>
-          <a:p>
-            <a:pPr algn="l">
-              <a:lnSpc>
-                <a:spcPct val="100000"/>
-              </a:lnSpc>
-            </a:pPr>
-            <a:r>
-              <a:rPr sz="2800" b="0">
-                <a:solidFill>
-                  <a:srgbClr val="E6ECF2"/>
-                </a:solidFill>
-                <a:latin typeface="Courier New"/>
-              </a:rPr>
-              <a:t>    "Green Eggs and Ham"}})</a:t>
-            </a:r>
-          </a:p>
-        </p:txBody>
-      </p:sp>
-      <p:sp>
-        <p:nvSpPr>
-          <p:cNvPr id="7" name="EXEMPT_FOOTER"/>
+                  <a:srgbClr val="4A5868"/>
+                </a:solidFill>
+                <a:latin typeface="Arial"/>
+              </a:rPr>
+              <a:t>Next: 2  COMMAND  →</a:t>
+            </a:r>
+          </a:p>
+        </p:txBody>
+      </p:sp>
+      <p:sp>
+        <p:nvSpPr>
+          <p:cNvPr id="6" name="EXEMPT_FOOTER"/>
           <p:cNvSpPr txBox="1"/>
           <p:nvPr/>
         </p:nvSpPr>
@@ -19627,7 +19769,7 @@
       </p:sp>
       <p:sp>
         <p:nvSpPr>
-          <p:cNvPr id="8" name="EXEMPT_PROGRESS"/>
+          <p:cNvPr id="7" name="EXEMPT_PROGRESS"/>
           <p:cNvSpPr txBox="1"/>
           <p:nvPr/>
         </p:nvSpPr>
@@ -19775,14 +19917,145 @@
       </p:sp>
       <p:sp>
         <p:nvSpPr>
-          <p:cNvPr id="4" name="EXEMPT_PASTE"/>
+          <p:cNvPr id="4" name="Rectangle 3"/>
           <p:cNvSpPr/>
           <p:nvPr/>
         </p:nvSpPr>
         <p:spPr>
           <a:xfrm>
             <a:off x="411480" y="1097280"/>
-            <a:ext cx="11368735" cy="1828800"/>
+            <a:ext cx="11368735" cy="1808479"/>
+          </a:xfrm>
+          <a:prstGeom prst="rect">
+            <a:avLst/>
+          </a:prstGeom>
+          <a:solidFill>
+            <a:srgbClr val="16212E"/>
+          </a:solidFill>
+          <a:ln>
+            <a:noFill/>
+          </a:ln>
+          <a:effectLst/>
+        </p:spPr>
+        <p:style>
+          <a:lnRef idx="1">
+            <a:schemeClr val="accent1"/>
+          </a:lnRef>
+          <a:fillRef idx="3">
+            <a:schemeClr val="accent1"/>
+          </a:fillRef>
+          <a:effectRef idx="2">
+            <a:schemeClr val="accent1"/>
+          </a:effectRef>
+          <a:fontRef idx="minor">
+            <a:schemeClr val="lt1"/>
+          </a:fontRef>
+        </p:style>
+        <p:txBody>
+          <a:bodyPr rtlCol="0" anchor="ctr"/>
+          <a:lstStyle/>
+          <a:p>
+            <a:pPr algn="ctr"/>
+          </a:p>
+        </p:txBody>
+      </p:sp>
+      <p:sp>
+        <p:nvSpPr>
+          <p:cNvPr id="5" name="TextBox 4"/>
+          <p:cNvSpPr txBox="1"/>
+          <p:nvPr/>
+        </p:nvSpPr>
+        <p:spPr>
+          <a:xfrm>
+            <a:off x="557784" y="1188720"/>
+            <a:ext cx="11149279" cy="1698752"/>
+          </a:xfrm>
+          <a:prstGeom prst="rect">
+            <a:avLst/>
+          </a:prstGeom>
+          <a:noFill/>
+        </p:spPr>
+        <p:txBody>
+          <a:bodyPr wrap="none" anchor="t" lIns="0" rIns="0" tIns="0" bIns="0">
+            <a:spAutoFit/>
+          </a:bodyPr>
+          <a:lstStyle/>
+          <a:p>
+            <a:pPr algn="l">
+              <a:lnSpc>
+                <a:spcPts val="3200"/>
+              </a:lnSpc>
+            </a:pPr>
+            <a:r>
+              <a:rPr sz="2800" b="1">
+                <a:solidFill>
+                  <a:srgbClr val="F2B27A"/>
+                </a:solidFill>
+                <a:latin typeface="Arial"/>
+              </a:rPr>
+              <a:t>2  COMMAND</a:t>
+            </a:r>
+          </a:p>
+          <a:p>
+            <a:pPr algn="l">
+              <a:lnSpc>
+                <a:spcPts val="3200"/>
+              </a:lnSpc>
+            </a:pPr>
+            <a:r>
+              <a:rPr sz="2800" b="0">
+                <a:solidFill>
+                  <a:srgbClr val="E6ECF2"/>
+                </a:solidFill>
+                <a:latin typeface="Courier New"/>
+              </a:rPr>
+              <a:t>db.users.updateOne({"name" : "John"},</a:t>
+            </a:r>
+          </a:p>
+          <a:p>
+            <a:pPr algn="l">
+              <a:lnSpc>
+                <a:spcPts val="3200"/>
+              </a:lnSpc>
+            </a:pPr>
+            <a:r>
+              <a:rPr sz="2800" b="0">
+                <a:solidFill>
+                  <a:srgbClr val="E6ECF2"/>
+                </a:solidFill>
+                <a:latin typeface="Courier New"/>
+              </a:rPr>
+              <a:t>  {"$set" : {"favorite book" :</a:t>
+            </a:r>
+          </a:p>
+          <a:p>
+            <a:pPr algn="l">
+              <a:lnSpc>
+                <a:spcPts val="3200"/>
+              </a:lnSpc>
+            </a:pPr>
+            <a:r>
+              <a:rPr sz="2800" b="0">
+                <a:solidFill>
+                  <a:srgbClr val="E6ECF2"/>
+                </a:solidFill>
+                <a:latin typeface="Courier New"/>
+              </a:rPr>
+              <a:t>    "Green Eggs and Ham"}})</a:t>
+            </a:r>
+          </a:p>
+        </p:txBody>
+      </p:sp>
+      <p:sp>
+        <p:nvSpPr>
+          <p:cNvPr id="6" name="EXEMPT_PASTE"/>
+          <p:cNvSpPr/>
+          <p:nvPr/>
+        </p:nvSpPr>
+        <p:spPr>
+          <a:xfrm>
+            <a:off x="411480" y="3015487"/>
+            <a:ext cx="11368735" cy="1808479"/>
           </a:xfrm>
           <a:prstGeom prst="rect">
             <a:avLst/>
@@ -19850,7 +20123,46 @@
       </p:sp>
       <p:sp>
         <p:nvSpPr>
-          <p:cNvPr id="5" name="EXEMPT_FOOTER"/>
+          <p:cNvPr id="7" name="TextBox 6"/>
+          <p:cNvSpPr txBox="1"/>
+          <p:nvPr/>
+        </p:nvSpPr>
+        <p:spPr>
+          <a:xfrm>
+            <a:off x="411480" y="5696712"/>
+            <a:ext cx="11368735" cy="566928"/>
+          </a:xfrm>
+          <a:prstGeom prst="rect">
+            <a:avLst/>
+          </a:prstGeom>
+          <a:noFill/>
+        </p:spPr>
+        <p:txBody>
+          <a:bodyPr wrap="square" anchor="ctr" lIns="164592" rIns="164592" tIns="164592" bIns="164592">
+            <a:spAutoFit/>
+          </a:bodyPr>
+          <a:lstStyle/>
+          <a:p>
+            <a:pPr algn="r">
+              <a:lnSpc>
+                <a:spcPct val="100000"/>
+              </a:lnSpc>
+            </a:pPr>
+            <a:r>
+              <a:rPr sz="2800" b="0">
+                <a:solidFill>
+                  <a:srgbClr val="4A5868"/>
+                </a:solidFill>
+                <a:latin typeface="Arial"/>
+              </a:rPr>
+              <a:t>Next: 3  AFTER  →</a:t>
+            </a:r>
+          </a:p>
+        </p:txBody>
+      </p:sp>
+      <p:sp>
+        <p:nvSpPr>
+          <p:cNvPr id="8" name="EXEMPT_FOOTER"/>
           <p:cNvSpPr txBox="1"/>
           <p:nvPr/>
         </p:nvSpPr>
@@ -19889,7 +20201,7 @@
       </p:sp>
       <p:sp>
         <p:nvSpPr>
-          <p:cNvPr id="6" name="EXEMPT_PROGRESS"/>
+          <p:cNvPr id="9" name="EXEMPT_PROGRESS"/>
           <p:cNvSpPr txBox="1"/>
           <p:nvPr/>
         </p:nvSpPr>
@@ -20044,7 +20356,7 @@
         <p:spPr>
           <a:xfrm>
             <a:off x="411480" y="1097280"/>
-            <a:ext cx="11368735" cy="3474720"/>
+            <a:ext cx="11368735" cy="3434080"/>
           </a:xfrm>
           <a:prstGeom prst="rect">
             <a:avLst/>
@@ -20388,7 +20700,7 @@
         <p:spPr>
           <a:xfrm>
             <a:off x="411480" y="1097280"/>
-            <a:ext cx="11368735" cy="3474720"/>
+            <a:ext cx="11368735" cy="3434080"/>
           </a:xfrm>
           <a:prstGeom prst="rect">
             <a:avLst/>
@@ -20481,7 +20793,46 @@
       </p:sp>
       <p:sp>
         <p:nvSpPr>
-          <p:cNvPr id="5" name="EXEMPT_FOOTER"/>
+          <p:cNvPr id="5" name="TextBox 4"/>
+          <p:cNvSpPr txBox="1"/>
+          <p:nvPr/>
+        </p:nvSpPr>
+        <p:spPr>
+          <a:xfrm>
+            <a:off x="411480" y="5696712"/>
+            <a:ext cx="11368735" cy="566928"/>
+          </a:xfrm>
+          <a:prstGeom prst="rect">
+            <a:avLst/>
+          </a:prstGeom>
+          <a:noFill/>
+        </p:spPr>
+        <p:txBody>
+          <a:bodyPr wrap="square" anchor="ctr" lIns="164592" rIns="164592" tIns="164592" bIns="164592">
+            <a:spAutoFit/>
+          </a:bodyPr>
+          <a:lstStyle/>
+          <a:p>
+            <a:pPr algn="r">
+              <a:lnSpc>
+                <a:spcPct val="100000"/>
+              </a:lnSpc>
+            </a:pPr>
+            <a:r>
+              <a:rPr sz="2800" b="0">
+                <a:solidFill>
+                  <a:srgbClr val="4A5868"/>
+                </a:solidFill>
+                <a:latin typeface="Arial"/>
+              </a:rPr>
+              <a:t>Next: 2  COMMAND  →</a:t>
+            </a:r>
+          </a:p>
+        </p:txBody>
+      </p:sp>
+      <p:sp>
+        <p:nvSpPr>
+          <p:cNvPr id="6" name="EXEMPT_FOOTER"/>
           <p:cNvSpPr txBox="1"/>
           <p:nvPr/>
         </p:nvSpPr>
@@ -20520,7 +20871,7 @@
       </p:sp>
       <p:sp>
         <p:nvSpPr>
-          <p:cNvPr id="6" name="EXEMPT_PROGRESS"/>
+          <p:cNvPr id="7" name="EXEMPT_PROGRESS"/>
           <p:cNvSpPr txBox="1"/>
           <p:nvPr/>
         </p:nvSpPr>
@@ -21776,7 +22127,7 @@
         <p:spPr>
           <a:xfrm>
             <a:off x="411480" y="1097280"/>
-            <a:ext cx="11368735" cy="2240280"/>
+            <a:ext cx="11368735" cy="2214880"/>
           </a:xfrm>
           <a:prstGeom prst="rect">
             <a:avLst/>
@@ -21820,7 +22171,7 @@
         <p:spPr>
           <a:xfrm>
             <a:off x="557784" y="1188720"/>
-            <a:ext cx="11149279" cy="2130552"/>
+            <a:ext cx="11149279" cy="2105152"/>
           </a:xfrm>
           <a:prstGeom prst="rect">
             <a:avLst/>
@@ -21835,7 +22186,7 @@
           <a:p>
             <a:pPr algn="l">
               <a:lnSpc>
-                <a:spcPct val="100000"/>
+                <a:spcPts val="3200"/>
               </a:lnSpc>
             </a:pPr>
             <a:r>
@@ -21851,7 +22202,7 @@
           <a:p>
             <a:pPr algn="l">
               <a:lnSpc>
-                <a:spcPct val="100000"/>
+                <a:spcPts val="3200"/>
               </a:lnSpc>
             </a:pPr>
             <a:r>
@@ -21867,7 +22218,7 @@
           <a:p>
             <a:pPr algn="l">
               <a:lnSpc>
-                <a:spcPct val="100000"/>
+                <a:spcPts val="3200"/>
               </a:lnSpc>
             </a:pPr>
             <a:r>
@@ -21883,7 +22234,7 @@
           <a:p>
             <a:pPr algn="l">
               <a:lnSpc>
-                <a:spcPct val="100000"/>
+                <a:spcPts val="3200"/>
               </a:lnSpc>
             </a:pPr>
             <a:r>
@@ -21899,7 +22250,7 @@
           <a:p>
             <a:pPr algn="l">
               <a:lnSpc>
-                <a:spcPct val="100000"/>
+                <a:spcPts val="3200"/>
               </a:lnSpc>
             </a:pPr>
             <a:r>
@@ -21922,8 +22273,8 @@
         </p:nvSpPr>
         <p:spPr>
           <a:xfrm>
-            <a:off x="411480" y="3447288"/>
-            <a:ext cx="11368735" cy="1828800"/>
+            <a:off x="411480" y="3421888"/>
+            <a:ext cx="11368735" cy="1808479"/>
           </a:xfrm>
           <a:prstGeom prst="rect">
             <a:avLst/>
@@ -21991,7 +22342,46 @@
       </p:sp>
       <p:sp>
         <p:nvSpPr>
-          <p:cNvPr id="7" name="EXEMPT_FOOTER"/>
+          <p:cNvPr id="7" name="TextBox 6"/>
+          <p:cNvSpPr txBox="1"/>
+          <p:nvPr/>
+        </p:nvSpPr>
+        <p:spPr>
+          <a:xfrm>
+            <a:off x="411480" y="5696712"/>
+            <a:ext cx="11368735" cy="566928"/>
+          </a:xfrm>
+          <a:prstGeom prst="rect">
+            <a:avLst/>
+          </a:prstGeom>
+          <a:noFill/>
+        </p:spPr>
+        <p:txBody>
+          <a:bodyPr wrap="square" anchor="ctr" lIns="164592" rIns="164592" tIns="164592" bIns="164592">
+            <a:spAutoFit/>
+          </a:bodyPr>
+          <a:lstStyle/>
+          <a:p>
+            <a:pPr algn="r">
+              <a:lnSpc>
+                <a:spcPct val="100000"/>
+              </a:lnSpc>
+            </a:pPr>
+            <a:r>
+              <a:rPr sz="2800" b="0">
+                <a:solidFill>
+                  <a:srgbClr val="4A5868"/>
+                </a:solidFill>
+                <a:latin typeface="Arial"/>
+              </a:rPr>
+              <a:t>Next: 3  AFTER  →</a:t>
+            </a:r>
+          </a:p>
+        </p:txBody>
+      </p:sp>
+      <p:sp>
+        <p:nvSpPr>
+          <p:cNvPr id="8" name="EXEMPT_FOOTER"/>
           <p:cNvSpPr txBox="1"/>
           <p:nvPr/>
         </p:nvSpPr>
@@ -22030,7 +22420,7 @@
       </p:sp>
       <p:sp>
         <p:nvSpPr>
-          <p:cNvPr id="8" name="EXEMPT_PROGRESS"/>
+          <p:cNvPr id="9" name="EXEMPT_PROGRESS"/>
           <p:cNvSpPr txBox="1"/>
           <p:nvPr/>
         </p:nvSpPr>
@@ -22185,7 +22575,7 @@
         <p:spPr>
           <a:xfrm>
             <a:off x="411480" y="1097280"/>
-            <a:ext cx="11368735" cy="3886200"/>
+            <a:ext cx="11368735" cy="3840480"/>
           </a:xfrm>
           <a:prstGeom prst="rect">
             <a:avLst/>
@@ -22529,7 +22919,7 @@
         <p:spPr>
           <a:xfrm>
             <a:off x="411480" y="1097280"/>
-            <a:ext cx="11368735" cy="3886200"/>
+            <a:ext cx="11368735" cy="3840480"/>
           </a:xfrm>
           <a:prstGeom prst="rect">
             <a:avLst/>
@@ -22622,7 +23012,46 @@
       </p:sp>
       <p:sp>
         <p:nvSpPr>
-          <p:cNvPr id="5" name="EXEMPT_FOOTER"/>
+          <p:cNvPr id="5" name="TextBox 4"/>
+          <p:cNvSpPr txBox="1"/>
+          <p:nvPr/>
+        </p:nvSpPr>
+        <p:spPr>
+          <a:xfrm>
+            <a:off x="411480" y="5696712"/>
+            <a:ext cx="11368735" cy="566928"/>
+          </a:xfrm>
+          <a:prstGeom prst="rect">
+            <a:avLst/>
+          </a:prstGeom>
+          <a:noFill/>
+        </p:spPr>
+        <p:txBody>
+          <a:bodyPr wrap="square" anchor="ctr" lIns="164592" rIns="164592" tIns="164592" bIns="164592">
+            <a:spAutoFit/>
+          </a:bodyPr>
+          <a:lstStyle/>
+          <a:p>
+            <a:pPr algn="r">
+              <a:lnSpc>
+                <a:spcPct val="100000"/>
+              </a:lnSpc>
+            </a:pPr>
+            <a:r>
+              <a:rPr sz="2800" b="0">
+                <a:solidFill>
+                  <a:srgbClr val="4A5868"/>
+                </a:solidFill>
+                <a:latin typeface="Arial"/>
+              </a:rPr>
+              <a:t>Next: 2  COMMAND  →</a:t>
+            </a:r>
+          </a:p>
+        </p:txBody>
+      </p:sp>
+      <p:sp>
+        <p:nvSpPr>
+          <p:cNvPr id="6" name="EXEMPT_FOOTER"/>
           <p:cNvSpPr txBox="1"/>
           <p:nvPr/>
         </p:nvSpPr>
@@ -22661,7 +23090,7 @@
       </p:sp>
       <p:sp>
         <p:nvSpPr>
-          <p:cNvPr id="6" name="EXEMPT_PROGRESS"/>
+          <p:cNvPr id="7" name="EXEMPT_PROGRESS"/>
           <p:cNvSpPr txBox="1"/>
           <p:nvPr/>
         </p:nvSpPr>
@@ -22816,7 +23245,7 @@
         <p:spPr>
           <a:xfrm>
             <a:off x="411480" y="1097280"/>
-            <a:ext cx="11368735" cy="1417320"/>
+            <a:ext cx="11368735" cy="1402080"/>
           </a:xfrm>
           <a:prstGeom prst="rect">
             <a:avLst/>
@@ -22860,7 +23289,7 @@
         <p:spPr>
           <a:xfrm>
             <a:off x="557784" y="1188720"/>
-            <a:ext cx="11149279" cy="1307592"/>
+            <a:ext cx="11149279" cy="1292351"/>
           </a:xfrm>
           <a:prstGeom prst="rect">
             <a:avLst/>
@@ -22875,7 +23304,7 @@
           <a:p>
             <a:pPr algn="l">
               <a:lnSpc>
-                <a:spcPct val="100000"/>
+                <a:spcPts val="3200"/>
               </a:lnSpc>
             </a:pPr>
             <a:r>
@@ -22891,7 +23320,7 @@
           <a:p>
             <a:pPr algn="l">
               <a:lnSpc>
-                <a:spcPct val="100000"/>
+                <a:spcPts val="3200"/>
               </a:lnSpc>
             </a:pPr>
             <a:r>
@@ -22907,7 +23336,7 @@
           <a:p>
             <a:pPr algn="l">
               <a:lnSpc>
-                <a:spcPct val="100000"/>
+                <a:spcPts val="3200"/>
               </a:lnSpc>
             </a:pPr>
             <a:r>
@@ -22930,8 +23359,8 @@
         </p:nvSpPr>
         <p:spPr>
           <a:xfrm>
-            <a:off x="411480" y="2624328"/>
-            <a:ext cx="11368735" cy="1828800"/>
+            <a:off x="411480" y="2609088"/>
+            <a:ext cx="11368735" cy="1808479"/>
           </a:xfrm>
           <a:prstGeom prst="rect">
             <a:avLst/>
@@ -22999,7 +23428,46 @@
       </p:sp>
       <p:sp>
         <p:nvSpPr>
-          <p:cNvPr id="7" name="EXEMPT_FOOTER"/>
+          <p:cNvPr id="7" name="TextBox 6"/>
+          <p:cNvSpPr txBox="1"/>
+          <p:nvPr/>
+        </p:nvSpPr>
+        <p:spPr>
+          <a:xfrm>
+            <a:off x="411480" y="5696712"/>
+            <a:ext cx="11368735" cy="566928"/>
+          </a:xfrm>
+          <a:prstGeom prst="rect">
+            <a:avLst/>
+          </a:prstGeom>
+          <a:noFill/>
+        </p:spPr>
+        <p:txBody>
+          <a:bodyPr wrap="square" anchor="ctr" lIns="164592" rIns="164592" tIns="164592" bIns="164592">
+            <a:spAutoFit/>
+          </a:bodyPr>
+          <a:lstStyle/>
+          <a:p>
+            <a:pPr algn="r">
+              <a:lnSpc>
+                <a:spcPct val="100000"/>
+              </a:lnSpc>
+            </a:pPr>
+            <a:r>
+              <a:rPr sz="2800" b="0">
+                <a:solidFill>
+                  <a:srgbClr val="4A5868"/>
+                </a:solidFill>
+                <a:latin typeface="Arial"/>
+              </a:rPr>
+              <a:t>Next: 3  AFTER  →</a:t>
+            </a:r>
+          </a:p>
+        </p:txBody>
+      </p:sp>
+      <p:sp>
+        <p:nvSpPr>
+          <p:cNvPr id="8" name="EXEMPT_FOOTER"/>
           <p:cNvSpPr txBox="1"/>
           <p:nvPr/>
         </p:nvSpPr>
@@ -23038,7 +23506,7 @@
       </p:sp>
       <p:sp>
         <p:nvSpPr>
-          <p:cNvPr id="8" name="EXEMPT_PROGRESS"/>
+          <p:cNvPr id="9" name="EXEMPT_PROGRESS"/>
           <p:cNvSpPr txBox="1"/>
           <p:nvPr/>
         </p:nvSpPr>
@@ -23193,7 +23661,7 @@
         <p:spPr>
           <a:xfrm>
             <a:off x="411480" y="1097280"/>
-            <a:ext cx="11368735" cy="3063240"/>
+            <a:ext cx="11368735" cy="3027680"/>
           </a:xfrm>
           <a:prstGeom prst="rect">
             <a:avLst/>
@@ -23537,7 +24005,7 @@
         <p:spPr>
           <a:xfrm>
             <a:off x="411480" y="1097280"/>
-            <a:ext cx="11368735" cy="3474720"/>
+            <a:ext cx="11368735" cy="3434080"/>
           </a:xfrm>
           <a:prstGeom prst="rect">
             <a:avLst/>
@@ -23630,58 +24098,14 @@
       </p:sp>
       <p:sp>
         <p:nvSpPr>
-          <p:cNvPr id="5" name="Rectangle 4"/>
-          <p:cNvSpPr/>
-          <p:nvPr/>
-        </p:nvSpPr>
-        <p:spPr>
-          <a:xfrm>
-            <a:off x="411480" y="4681728"/>
-            <a:ext cx="11368735" cy="1417320"/>
-          </a:xfrm>
-          <a:prstGeom prst="rect">
-            <a:avLst/>
-          </a:prstGeom>
-          <a:solidFill>
-            <a:srgbClr val="16212E"/>
-          </a:solidFill>
-          <a:ln>
-            <a:noFill/>
-          </a:ln>
-          <a:effectLst/>
-        </p:spPr>
-        <p:style>
-          <a:lnRef idx="1">
-            <a:schemeClr val="accent1"/>
-          </a:lnRef>
-          <a:fillRef idx="3">
-            <a:schemeClr val="accent1"/>
-          </a:fillRef>
-          <a:effectRef idx="2">
-            <a:schemeClr val="accent1"/>
-          </a:effectRef>
-          <a:fontRef idx="minor">
-            <a:schemeClr val="lt1"/>
-          </a:fontRef>
-        </p:style>
-        <p:txBody>
-          <a:bodyPr rtlCol="0" anchor="ctr"/>
-          <a:lstStyle/>
-          <a:p>
-            <a:pPr algn="ctr"/>
-          </a:p>
-        </p:txBody>
-      </p:sp>
-      <p:sp>
-        <p:nvSpPr>
-          <p:cNvPr id="6" name="TextBox 5"/>
+          <p:cNvPr id="5" name="TextBox 4"/>
           <p:cNvSpPr txBox="1"/>
           <p:nvPr/>
         </p:nvSpPr>
         <p:spPr>
           <a:xfrm>
-            <a:off x="557784" y="4773168"/>
-            <a:ext cx="11149279" cy="1307592"/>
+            <a:off x="411480" y="5696712"/>
+            <a:ext cx="11368735" cy="566928"/>
           </a:xfrm>
           <a:prstGeom prst="rect">
             <a:avLst/>
@@ -23689,28 +24113,12 @@
           <a:noFill/>
         </p:spPr>
         <p:txBody>
-          <a:bodyPr wrap="none" anchor="t" lIns="0" rIns="0" tIns="0" bIns="0">
+          <a:bodyPr wrap="square" anchor="ctr" lIns="164592" rIns="164592" tIns="164592" bIns="164592">
             <a:spAutoFit/>
           </a:bodyPr>
           <a:lstStyle/>
           <a:p>
-            <a:pPr algn="l">
-              <a:lnSpc>
-                <a:spcPct val="100000"/>
-              </a:lnSpc>
-            </a:pPr>
-            <a:r>
-              <a:rPr sz="2800" b="1">
-                <a:solidFill>
-                  <a:srgbClr val="F2B27A"/>
-                </a:solidFill>
-                <a:latin typeface="Arial"/>
-              </a:rPr>
-              <a:t>2  COMMAND</a:t>
-            </a:r>
-          </a:p>
-          <a:p>
-            <a:pPr algn="l">
+            <a:pPr algn="r">
               <a:lnSpc>
                 <a:spcPct val="100000"/>
               </a:lnSpc>
@@ -23718,34 +24126,18 @@
             <a:r>
               <a:rPr sz="2800" b="0">
                 <a:solidFill>
-                  <a:srgbClr val="E6ECF2"/>
-                </a:solidFill>
-                <a:latin typeface="Courier New"/>
-              </a:rPr>
-              <a:t>db.books.updateOne({"author.name" : "Nicole"},</a:t>
-            </a:r>
-          </a:p>
-          <a:p>
-            <a:pPr algn="l">
-              <a:lnSpc>
-                <a:spcPct val="100000"/>
-              </a:lnSpc>
-            </a:pPr>
-            <a:r>
-              <a:rPr sz="2800" b="0">
-                <a:solidFill>
-                  <a:srgbClr val="E6ECF2"/>
-                </a:solidFill>
-                <a:latin typeface="Courier New"/>
-              </a:rPr>
-              <a:t>  {"$set" : {"author.name" : "Nicole Tagayon"}})</a:t>
-            </a:r>
-          </a:p>
-        </p:txBody>
-      </p:sp>
-      <p:sp>
-        <p:nvSpPr>
-          <p:cNvPr id="7" name="EXEMPT_FOOTER"/>
+                  <a:srgbClr val="4A5868"/>
+                </a:solidFill>
+                <a:latin typeface="Arial"/>
+              </a:rPr>
+              <a:t>Next: 2  COMMAND  →</a:t>
+            </a:r>
+          </a:p>
+        </p:txBody>
+      </p:sp>
+      <p:sp>
+        <p:nvSpPr>
+          <p:cNvPr id="6" name="EXEMPT_FOOTER"/>
           <p:cNvSpPr txBox="1"/>
           <p:nvPr/>
         </p:nvSpPr>
@@ -23784,7 +24176,7 @@
       </p:sp>
       <p:sp>
         <p:nvSpPr>
-          <p:cNvPr id="8" name="EXEMPT_PROGRESS"/>
+          <p:cNvPr id="7" name="EXEMPT_PROGRESS"/>
           <p:cNvSpPr txBox="1"/>
           <p:nvPr/>
         </p:nvSpPr>
@@ -23932,14 +24324,129 @@
       </p:sp>
       <p:sp>
         <p:nvSpPr>
-          <p:cNvPr id="4" name="EXEMPT_PASTE"/>
+          <p:cNvPr id="4" name="Rectangle 3"/>
           <p:cNvSpPr/>
           <p:nvPr/>
         </p:nvSpPr>
         <p:spPr>
           <a:xfrm>
             <a:off x="411480" y="1097280"/>
-            <a:ext cx="11368735" cy="1828800"/>
+            <a:ext cx="11368735" cy="1402080"/>
+          </a:xfrm>
+          <a:prstGeom prst="rect">
+            <a:avLst/>
+          </a:prstGeom>
+          <a:solidFill>
+            <a:srgbClr val="16212E"/>
+          </a:solidFill>
+          <a:ln>
+            <a:noFill/>
+          </a:ln>
+          <a:effectLst/>
+        </p:spPr>
+        <p:style>
+          <a:lnRef idx="1">
+            <a:schemeClr val="accent1"/>
+          </a:lnRef>
+          <a:fillRef idx="3">
+            <a:schemeClr val="accent1"/>
+          </a:fillRef>
+          <a:effectRef idx="2">
+            <a:schemeClr val="accent1"/>
+          </a:effectRef>
+          <a:fontRef idx="minor">
+            <a:schemeClr val="lt1"/>
+          </a:fontRef>
+        </p:style>
+        <p:txBody>
+          <a:bodyPr rtlCol="0" anchor="ctr"/>
+          <a:lstStyle/>
+          <a:p>
+            <a:pPr algn="ctr"/>
+          </a:p>
+        </p:txBody>
+      </p:sp>
+      <p:sp>
+        <p:nvSpPr>
+          <p:cNvPr id="5" name="TextBox 4"/>
+          <p:cNvSpPr txBox="1"/>
+          <p:nvPr/>
+        </p:nvSpPr>
+        <p:spPr>
+          <a:xfrm>
+            <a:off x="557784" y="1188720"/>
+            <a:ext cx="11149279" cy="1292351"/>
+          </a:xfrm>
+          <a:prstGeom prst="rect">
+            <a:avLst/>
+          </a:prstGeom>
+          <a:noFill/>
+        </p:spPr>
+        <p:txBody>
+          <a:bodyPr wrap="none" anchor="t" lIns="0" rIns="0" tIns="0" bIns="0">
+            <a:spAutoFit/>
+          </a:bodyPr>
+          <a:lstStyle/>
+          <a:p>
+            <a:pPr algn="l">
+              <a:lnSpc>
+                <a:spcPts val="3200"/>
+              </a:lnSpc>
+            </a:pPr>
+            <a:r>
+              <a:rPr sz="2800" b="1">
+                <a:solidFill>
+                  <a:srgbClr val="F2B27A"/>
+                </a:solidFill>
+                <a:latin typeface="Arial"/>
+              </a:rPr>
+              <a:t>2  COMMAND</a:t>
+            </a:r>
+          </a:p>
+          <a:p>
+            <a:pPr algn="l">
+              <a:lnSpc>
+                <a:spcPts val="3200"/>
+              </a:lnSpc>
+            </a:pPr>
+            <a:r>
+              <a:rPr sz="2800" b="0">
+                <a:solidFill>
+                  <a:srgbClr val="E6ECF2"/>
+                </a:solidFill>
+                <a:latin typeface="Courier New"/>
+              </a:rPr>
+              <a:t>db.books.updateOne({"author.name" : "Nicole"},</a:t>
+            </a:r>
+          </a:p>
+          <a:p>
+            <a:pPr algn="l">
+              <a:lnSpc>
+                <a:spcPts val="3200"/>
+              </a:lnSpc>
+            </a:pPr>
+            <a:r>
+              <a:rPr sz="2800" b="0">
+                <a:solidFill>
+                  <a:srgbClr val="E6ECF2"/>
+                </a:solidFill>
+                <a:latin typeface="Courier New"/>
+              </a:rPr>
+              <a:t>  {"$set" : {"author.name" : "Nicole Tagayon"}})</a:t>
+            </a:r>
+          </a:p>
+        </p:txBody>
+      </p:sp>
+      <p:sp>
+        <p:nvSpPr>
+          <p:cNvPr id="6" name="EXEMPT_PASTE"/>
+          <p:cNvSpPr/>
+          <p:nvPr/>
+        </p:nvSpPr>
+        <p:spPr>
+          <a:xfrm>
+            <a:off x="411480" y="2609088"/>
+            <a:ext cx="11368735" cy="1808479"/>
           </a:xfrm>
           <a:prstGeom prst="rect">
             <a:avLst/>
@@ -24007,7 +24514,46 @@
       </p:sp>
       <p:sp>
         <p:nvSpPr>
-          <p:cNvPr id="5" name="EXEMPT_FOOTER"/>
+          <p:cNvPr id="7" name="TextBox 6"/>
+          <p:cNvSpPr txBox="1"/>
+          <p:nvPr/>
+        </p:nvSpPr>
+        <p:spPr>
+          <a:xfrm>
+            <a:off x="411480" y="5696712"/>
+            <a:ext cx="11368735" cy="566928"/>
+          </a:xfrm>
+          <a:prstGeom prst="rect">
+            <a:avLst/>
+          </a:prstGeom>
+          <a:noFill/>
+        </p:spPr>
+        <p:txBody>
+          <a:bodyPr wrap="square" anchor="ctr" lIns="164592" rIns="164592" tIns="164592" bIns="164592">
+            <a:spAutoFit/>
+          </a:bodyPr>
+          <a:lstStyle/>
+          <a:p>
+            <a:pPr algn="r">
+              <a:lnSpc>
+                <a:spcPct val="100000"/>
+              </a:lnSpc>
+            </a:pPr>
+            <a:r>
+              <a:rPr sz="2800" b="0">
+                <a:solidFill>
+                  <a:srgbClr val="4A5868"/>
+                </a:solidFill>
+                <a:latin typeface="Arial"/>
+              </a:rPr>
+              <a:t>Next: 3  AFTER  →</a:t>
+            </a:r>
+          </a:p>
+        </p:txBody>
+      </p:sp>
+      <p:sp>
+        <p:nvSpPr>
+          <p:cNvPr id="8" name="EXEMPT_FOOTER"/>
           <p:cNvSpPr txBox="1"/>
           <p:nvPr/>
         </p:nvSpPr>
@@ -24046,7 +24592,7 @@
       </p:sp>
       <p:sp>
         <p:nvSpPr>
-          <p:cNvPr id="6" name="EXEMPT_PROGRESS"/>
+          <p:cNvPr id="9" name="EXEMPT_PROGRESS"/>
           <p:cNvSpPr txBox="1"/>
           <p:nvPr/>
         </p:nvSpPr>
@@ -24201,7 +24747,7 @@
         <p:spPr>
           <a:xfrm>
             <a:off x="411480" y="1097280"/>
-            <a:ext cx="11368735" cy="3474720"/>
+            <a:ext cx="11368735" cy="3434080"/>
           </a:xfrm>
           <a:prstGeom prst="rect">
             <a:avLst/>
@@ -24545,7 +25091,7 @@
         <p:spPr>
           <a:xfrm>
             <a:off x="411480" y="1097280"/>
-            <a:ext cx="11368735" cy="2651760"/>
+            <a:ext cx="11368735" cy="2621280"/>
           </a:xfrm>
           <a:prstGeom prst="rect">
             <a:avLst/>
@@ -24638,58 +25184,14 @@
       </p:sp>
       <p:sp>
         <p:nvSpPr>
-          <p:cNvPr id="5" name="Rectangle 4"/>
-          <p:cNvSpPr/>
-          <p:nvPr/>
-        </p:nvSpPr>
-        <p:spPr>
-          <a:xfrm>
-            <a:off x="411480" y="3858768"/>
-            <a:ext cx="11368735" cy="1417320"/>
-          </a:xfrm>
-          <a:prstGeom prst="rect">
-            <a:avLst/>
-          </a:prstGeom>
-          <a:solidFill>
-            <a:srgbClr val="16212E"/>
-          </a:solidFill>
-          <a:ln>
-            <a:noFill/>
-          </a:ln>
-          <a:effectLst/>
-        </p:spPr>
-        <p:style>
-          <a:lnRef idx="1">
-            <a:schemeClr val="accent1"/>
-          </a:lnRef>
-          <a:fillRef idx="3">
-            <a:schemeClr val="accent1"/>
-          </a:fillRef>
-          <a:effectRef idx="2">
-            <a:schemeClr val="accent1"/>
-          </a:effectRef>
-          <a:fontRef idx="minor">
-            <a:schemeClr val="lt1"/>
-          </a:fontRef>
-        </p:style>
-        <p:txBody>
-          <a:bodyPr rtlCol="0" anchor="ctr"/>
-          <a:lstStyle/>
-          <a:p>
-            <a:pPr algn="ctr"/>
-          </a:p>
-        </p:txBody>
-      </p:sp>
-      <p:sp>
-        <p:nvSpPr>
-          <p:cNvPr id="6" name="TextBox 5"/>
+          <p:cNvPr id="5" name="TextBox 4"/>
           <p:cNvSpPr txBox="1"/>
           <p:nvPr/>
         </p:nvSpPr>
         <p:spPr>
           <a:xfrm>
-            <a:off x="557784" y="3950208"/>
-            <a:ext cx="11149279" cy="1307592"/>
+            <a:off x="411480" y="5696712"/>
+            <a:ext cx="11368735" cy="566928"/>
           </a:xfrm>
           <a:prstGeom prst="rect">
             <a:avLst/>
@@ -24697,28 +25199,12 @@
           <a:noFill/>
         </p:spPr>
         <p:txBody>
-          <a:bodyPr wrap="none" anchor="t" lIns="0" rIns="0" tIns="0" bIns="0">
+          <a:bodyPr wrap="square" anchor="ctr" lIns="164592" rIns="164592" tIns="164592" bIns="164592">
             <a:spAutoFit/>
           </a:bodyPr>
           <a:lstStyle/>
           <a:p>
-            <a:pPr algn="l">
-              <a:lnSpc>
-                <a:spcPct val="100000"/>
-              </a:lnSpc>
-            </a:pPr>
-            <a:r>
-              <a:rPr sz="2800" b="1">
-                <a:solidFill>
-                  <a:srgbClr val="F2B27A"/>
-                </a:solidFill>
-                <a:latin typeface="Arial"/>
-              </a:rPr>
-              <a:t>2  COMMAND</a:t>
-            </a:r>
-          </a:p>
-          <a:p>
-            <a:pPr algn="l">
+            <a:pPr algn="r">
               <a:lnSpc>
                 <a:spcPct val="100000"/>
               </a:lnSpc>
@@ -24726,34 +25212,18 @@
             <a:r>
               <a:rPr sz="2800" b="0">
                 <a:solidFill>
-                  <a:srgbClr val="E6ECF2"/>
-                </a:solidFill>
-                <a:latin typeface="Courier New"/>
-              </a:rPr>
-              <a:t>db.users.updateMany({"birthday" : "10/13/1978"},</a:t>
-            </a:r>
-          </a:p>
-          <a:p>
-            <a:pPr algn="l">
-              <a:lnSpc>
-                <a:spcPct val="100000"/>
-              </a:lnSpc>
-            </a:pPr>
-            <a:r>
-              <a:rPr sz="2800" b="0">
-                <a:solidFill>
-                  <a:srgbClr val="E6ECF2"/>
-                </a:solidFill>
-                <a:latin typeface="Courier New"/>
-              </a:rPr>
-              <a:t>  {"$set" : {"gift" : "Happy Birthday!"}})</a:t>
-            </a:r>
-          </a:p>
-        </p:txBody>
-      </p:sp>
-      <p:sp>
-        <p:nvSpPr>
-          <p:cNvPr id="7" name="EXEMPT_FOOTER"/>
+                  <a:srgbClr val="4A5868"/>
+                </a:solidFill>
+                <a:latin typeface="Arial"/>
+              </a:rPr>
+              <a:t>Next: 2  COMMAND  →</a:t>
+            </a:r>
+          </a:p>
+        </p:txBody>
+      </p:sp>
+      <p:sp>
+        <p:nvSpPr>
+          <p:cNvPr id="6" name="EXEMPT_FOOTER"/>
           <p:cNvSpPr txBox="1"/>
           <p:nvPr/>
         </p:nvSpPr>
@@ -24792,7 +25262,7 @@
       </p:sp>
       <p:sp>
         <p:nvSpPr>
-          <p:cNvPr id="8" name="EXEMPT_PROGRESS"/>
+          <p:cNvPr id="7" name="EXEMPT_PROGRESS"/>
           <p:cNvSpPr txBox="1"/>
           <p:nvPr/>
         </p:nvSpPr>
@@ -24940,14 +25410,129 @@
       </p:sp>
       <p:sp>
         <p:nvSpPr>
-          <p:cNvPr id="4" name="EXEMPT_PASTE"/>
+          <p:cNvPr id="4" name="Rectangle 3"/>
           <p:cNvSpPr/>
           <p:nvPr/>
         </p:nvSpPr>
         <p:spPr>
           <a:xfrm>
             <a:off x="411480" y="1097280"/>
-            <a:ext cx="11368735" cy="1828800"/>
+            <a:ext cx="11368735" cy="1402080"/>
+          </a:xfrm>
+          <a:prstGeom prst="rect">
+            <a:avLst/>
+          </a:prstGeom>
+          <a:solidFill>
+            <a:srgbClr val="16212E"/>
+          </a:solidFill>
+          <a:ln>
+            <a:noFill/>
+          </a:ln>
+          <a:effectLst/>
+        </p:spPr>
+        <p:style>
+          <a:lnRef idx="1">
+            <a:schemeClr val="accent1"/>
+          </a:lnRef>
+          <a:fillRef idx="3">
+            <a:schemeClr val="accent1"/>
+          </a:fillRef>
+          <a:effectRef idx="2">
+            <a:schemeClr val="accent1"/>
+          </a:effectRef>
+          <a:fontRef idx="minor">
+            <a:schemeClr val="lt1"/>
+          </a:fontRef>
+        </p:style>
+        <p:txBody>
+          <a:bodyPr rtlCol="0" anchor="ctr"/>
+          <a:lstStyle/>
+          <a:p>
+            <a:pPr algn="ctr"/>
+          </a:p>
+        </p:txBody>
+      </p:sp>
+      <p:sp>
+        <p:nvSpPr>
+          <p:cNvPr id="5" name="TextBox 4"/>
+          <p:cNvSpPr txBox="1"/>
+          <p:nvPr/>
+        </p:nvSpPr>
+        <p:spPr>
+          <a:xfrm>
+            <a:off x="557784" y="1188720"/>
+            <a:ext cx="11149279" cy="1292351"/>
+          </a:xfrm>
+          <a:prstGeom prst="rect">
+            <a:avLst/>
+          </a:prstGeom>
+          <a:noFill/>
+        </p:spPr>
+        <p:txBody>
+          <a:bodyPr wrap="none" anchor="t" lIns="0" rIns="0" tIns="0" bIns="0">
+            <a:spAutoFit/>
+          </a:bodyPr>
+          <a:lstStyle/>
+          <a:p>
+            <a:pPr algn="l">
+              <a:lnSpc>
+                <a:spcPts val="3200"/>
+              </a:lnSpc>
+            </a:pPr>
+            <a:r>
+              <a:rPr sz="2800" b="1">
+                <a:solidFill>
+                  <a:srgbClr val="F2B27A"/>
+                </a:solidFill>
+                <a:latin typeface="Arial"/>
+              </a:rPr>
+              <a:t>2  COMMAND</a:t>
+            </a:r>
+          </a:p>
+          <a:p>
+            <a:pPr algn="l">
+              <a:lnSpc>
+                <a:spcPts val="3200"/>
+              </a:lnSpc>
+            </a:pPr>
+            <a:r>
+              <a:rPr sz="2800" b="0">
+                <a:solidFill>
+                  <a:srgbClr val="E6ECF2"/>
+                </a:solidFill>
+                <a:latin typeface="Courier New"/>
+              </a:rPr>
+              <a:t>db.users.updateMany({"birthday" : "10/13/1978"},</a:t>
+            </a:r>
+          </a:p>
+          <a:p>
+            <a:pPr algn="l">
+              <a:lnSpc>
+                <a:spcPts val="3200"/>
+              </a:lnSpc>
+            </a:pPr>
+            <a:r>
+              <a:rPr sz="2800" b="0">
+                <a:solidFill>
+                  <a:srgbClr val="E6ECF2"/>
+                </a:solidFill>
+                <a:latin typeface="Courier New"/>
+              </a:rPr>
+              <a:t>  {"$set" : {"gift" : "Happy Birthday!"}})</a:t>
+            </a:r>
+          </a:p>
+        </p:txBody>
+      </p:sp>
+      <p:sp>
+        <p:nvSpPr>
+          <p:cNvPr id="6" name="EXEMPT_PASTE"/>
+          <p:cNvSpPr/>
+          <p:nvPr/>
+        </p:nvSpPr>
+        <p:spPr>
+          <a:xfrm>
+            <a:off x="411480" y="2609088"/>
+            <a:ext cx="11368735" cy="1808479"/>
           </a:xfrm>
           <a:prstGeom prst="rect">
             <a:avLst/>
@@ -25015,7 +25600,46 @@
       </p:sp>
       <p:sp>
         <p:nvSpPr>
-          <p:cNvPr id="5" name="EXEMPT_FOOTER"/>
+          <p:cNvPr id="7" name="TextBox 6"/>
+          <p:cNvSpPr txBox="1"/>
+          <p:nvPr/>
+        </p:nvSpPr>
+        <p:spPr>
+          <a:xfrm>
+            <a:off x="411480" y="5696712"/>
+            <a:ext cx="11368735" cy="566928"/>
+          </a:xfrm>
+          <a:prstGeom prst="rect">
+            <a:avLst/>
+          </a:prstGeom>
+          <a:noFill/>
+        </p:spPr>
+        <p:txBody>
+          <a:bodyPr wrap="square" anchor="ctr" lIns="164592" rIns="164592" tIns="164592" bIns="164592">
+            <a:spAutoFit/>
+          </a:bodyPr>
+          <a:lstStyle/>
+          <a:p>
+            <a:pPr algn="r">
+              <a:lnSpc>
+                <a:spcPct val="100000"/>
+              </a:lnSpc>
+            </a:pPr>
+            <a:r>
+              <a:rPr sz="2800" b="0">
+                <a:solidFill>
+                  <a:srgbClr val="4A5868"/>
+                </a:solidFill>
+                <a:latin typeface="Arial"/>
+              </a:rPr>
+              <a:t>Next: 3  AFTER  →</a:t>
+            </a:r>
+          </a:p>
+        </p:txBody>
+      </p:sp>
+      <p:sp>
+        <p:nvSpPr>
+          <p:cNvPr id="8" name="EXEMPT_FOOTER"/>
           <p:cNvSpPr txBox="1"/>
           <p:nvPr/>
         </p:nvSpPr>
@@ -25054,7 +25678,7 @@
       </p:sp>
       <p:sp>
         <p:nvSpPr>
-          <p:cNvPr id="6" name="EXEMPT_PROGRESS"/>
+          <p:cNvPr id="9" name="EXEMPT_PROGRESS"/>
           <p:cNvSpPr txBox="1"/>
           <p:nvPr/>
         </p:nvSpPr>
@@ -25430,7 +26054,7 @@
         <p:spPr>
           <a:xfrm>
             <a:off x="411480" y="1097280"/>
-            <a:ext cx="11368735" cy="3886200"/>
+            <a:ext cx="11368735" cy="3840480"/>
           </a:xfrm>
           <a:prstGeom prst="rect">
             <a:avLst/>
@@ -26362,7 +26986,7 @@
         </p:nvGraphicFramePr>
         <p:xfrm>
           <a:off x="411480" y="1234439"/>
-          <a:ext cx="11368735" cy="3566160"/>
+          <a:ext cx="11368735" cy="4352540"/>
         </p:xfrm>
         <a:graphic>
           <a:graphicData uri="http://schemas.openxmlformats.org/drawingml/2006/table">
@@ -26375,7 +26999,7 @@
                 <a:gridCol w="5882335"/>
                 <a:gridCol w="2743200"/>
               </a:tblGrid>
-              <a:tr h="713232">
+              <a:tr h="870508">
                 <a:tc>
                   <a:txBody>
                     <a:bodyPr wrap="square" anchor="ctr" lIns="109728" rIns="109728" tIns="109728" bIns="109728"/>
@@ -26458,7 +27082,7 @@
                   </a:tcPr>
                 </a:tc>
               </a:tr>
-              <a:tr h="713232">
+              <a:tr h="870508">
                 <a:tc>
                   <a:txBody>
                     <a:bodyPr wrap="square" anchor="ctr" lIns="109728" rIns="109728" tIns="109728" bIns="109728"/>
@@ -26541,7 +27165,7 @@
                   </a:tcPr>
                 </a:tc>
               </a:tr>
-              <a:tr h="713232">
+              <a:tr h="870508">
                 <a:tc>
                   <a:txBody>
                     <a:bodyPr wrap="square" anchor="ctr" lIns="109728" rIns="109728" tIns="109728" bIns="109728"/>
@@ -26624,7 +27248,7 @@
                   </a:tcPr>
                 </a:tc>
               </a:tr>
-              <a:tr h="713232">
+              <a:tr h="870508">
                 <a:tc>
                   <a:txBody>
                     <a:bodyPr wrap="square" anchor="ctr" lIns="109728" rIns="109728" tIns="109728" bIns="109728"/>
@@ -26707,7 +27331,7 @@
                   </a:tcPr>
                 </a:tc>
               </a:tr>
-              <a:tr h="713232">
+              <a:tr h="870508">
                 <a:tc>
                   <a:txBody>
                     <a:bodyPr wrap="square" anchor="ctr" lIns="109728" rIns="109728" tIns="109728" bIns="109728"/>
@@ -27047,7 +27671,7 @@
         <p:spPr>
           <a:xfrm>
             <a:off x="411480" y="1097280"/>
-            <a:ext cx="11368735" cy="1005840"/>
+            <a:ext cx="11368735" cy="995679"/>
           </a:xfrm>
           <a:prstGeom prst="rect">
             <a:avLst/>
@@ -27091,7 +27715,7 @@
         <p:spPr>
           <a:xfrm>
             <a:off x="557784" y="1188720"/>
-            <a:ext cx="11149279" cy="896112"/>
+            <a:ext cx="11149279" cy="885951"/>
           </a:xfrm>
           <a:prstGeom prst="rect">
             <a:avLst/>
@@ -27106,7 +27730,7 @@
           <a:p>
             <a:pPr algn="l">
               <a:lnSpc>
-                <a:spcPct val="100000"/>
+                <a:spcPts val="3200"/>
               </a:lnSpc>
             </a:pPr>
             <a:r>
@@ -27122,7 +27746,7 @@
           <a:p>
             <a:pPr algn="l">
               <a:lnSpc>
-                <a:spcPct val="100000"/>
+                <a:spcPts val="3200"/>
               </a:lnSpc>
             </a:pPr>
             <a:r>
@@ -27139,7 +27763,46 @@
       </p:sp>
       <p:sp>
         <p:nvSpPr>
-          <p:cNvPr id="6" name="EXEMPT_FOOTER"/>
+          <p:cNvPr id="6" name="TextBox 5"/>
+          <p:cNvSpPr txBox="1"/>
+          <p:nvPr/>
+        </p:nvSpPr>
+        <p:spPr>
+          <a:xfrm>
+            <a:off x="411480" y="5696712"/>
+            <a:ext cx="11368735" cy="566928"/>
+          </a:xfrm>
+          <a:prstGeom prst="rect">
+            <a:avLst/>
+          </a:prstGeom>
+          <a:noFill/>
+        </p:spPr>
+        <p:txBody>
+          <a:bodyPr wrap="square" anchor="ctr" lIns="164592" rIns="164592" tIns="164592" bIns="164592">
+            <a:spAutoFit/>
+          </a:bodyPr>
+          <a:lstStyle/>
+          <a:p>
+            <a:pPr algn="r">
+              <a:lnSpc>
+                <a:spcPct val="100000"/>
+              </a:lnSpc>
+            </a:pPr>
+            <a:r>
+              <a:rPr sz="2800" b="0">
+                <a:solidFill>
+                  <a:srgbClr val="4A5868"/>
+                </a:solidFill>
+                <a:latin typeface="Arial"/>
+              </a:rPr>
+              <a:t>Next: RESULT  →</a:t>
+            </a:r>
+          </a:p>
+        </p:txBody>
+      </p:sp>
+      <p:sp>
+        <p:nvSpPr>
+          <p:cNvPr id="7" name="EXEMPT_FOOTER"/>
           <p:cNvSpPr txBox="1"/>
           <p:nvPr/>
         </p:nvSpPr>
@@ -27178,7 +27841,7 @@
       </p:sp>
       <p:sp>
         <p:nvSpPr>
-          <p:cNvPr id="7" name="EXEMPT_PROGRESS"/>
+          <p:cNvPr id="8" name="EXEMPT_PROGRESS"/>
           <p:cNvSpPr txBox="1"/>
           <p:nvPr/>
         </p:nvSpPr>
@@ -27333,7 +27996,7 @@
         <p:spPr>
           <a:xfrm>
             <a:off x="411480" y="1097280"/>
-            <a:ext cx="11368735" cy="3474720"/>
+            <a:ext cx="11368735" cy="3434080"/>
           </a:xfrm>
           <a:prstGeom prst="rect">
             <a:avLst/>
@@ -27652,7 +28315,7 @@
         <p:spPr>
           <a:xfrm>
             <a:off x="411480" y="1097280"/>
-            <a:ext cx="11368735" cy="1005840"/>
+            <a:ext cx="11368735" cy="995679"/>
           </a:xfrm>
           <a:prstGeom prst="rect">
             <a:avLst/>
@@ -27696,7 +28359,7 @@
         <p:spPr>
           <a:xfrm>
             <a:off x="557784" y="1188720"/>
-            <a:ext cx="11149279" cy="896112"/>
+            <a:ext cx="11149279" cy="885951"/>
           </a:xfrm>
           <a:prstGeom prst="rect">
             <a:avLst/>
@@ -27711,7 +28374,7 @@
           <a:p>
             <a:pPr algn="l">
               <a:lnSpc>
-                <a:spcPct val="100000"/>
+                <a:spcPts val="3200"/>
               </a:lnSpc>
             </a:pPr>
             <a:r>
@@ -27727,7 +28390,7 @@
           <a:p>
             <a:pPr algn="l">
               <a:lnSpc>
-                <a:spcPct val="100000"/>
+                <a:spcPts val="3200"/>
               </a:lnSpc>
             </a:pPr>
             <a:r>
@@ -27750,8 +28413,8 @@
         </p:nvSpPr>
         <p:spPr>
           <a:xfrm>
-            <a:off x="411480" y="2212848"/>
-            <a:ext cx="11368735" cy="1417320"/>
+            <a:off x="411480" y="2202688"/>
+            <a:ext cx="11368735" cy="1402080"/>
           </a:xfrm>
           <a:prstGeom prst="rect">
             <a:avLst/>
@@ -27825,8 +28488,8 @@
         </p:nvSpPr>
         <p:spPr>
           <a:xfrm>
-            <a:off x="411480" y="3739896"/>
-            <a:ext cx="11368735" cy="1005840"/>
+            <a:off x="411480" y="3714496"/>
+            <a:ext cx="11368735" cy="995679"/>
           </a:xfrm>
           <a:prstGeom prst="rect">
             <a:avLst/>
@@ -27869,8 +28532,8 @@
         </p:nvSpPr>
         <p:spPr>
           <a:xfrm>
-            <a:off x="557784" y="3831335"/>
-            <a:ext cx="11149279" cy="896112"/>
+            <a:off x="557784" y="3805935"/>
+            <a:ext cx="11149279" cy="885951"/>
           </a:xfrm>
           <a:prstGeom prst="rect">
             <a:avLst/>
@@ -27885,7 +28548,7 @@
           <a:p>
             <a:pPr algn="l">
               <a:lnSpc>
-                <a:spcPct val="100000"/>
+                <a:spcPts val="3200"/>
               </a:lnSpc>
             </a:pPr>
             <a:r>
@@ -27901,7 +28564,7 @@
           <a:p>
             <a:pPr algn="l">
               <a:lnSpc>
-                <a:spcPct val="100000"/>
+                <a:spcPts val="3200"/>
               </a:lnSpc>
             </a:pPr>
             <a:r>
@@ -27918,7 +28581,46 @@
       </p:sp>
       <p:sp>
         <p:nvSpPr>
-          <p:cNvPr id="9" name="EXEMPT_FOOTER"/>
+          <p:cNvPr id="9" name="TextBox 8"/>
+          <p:cNvSpPr txBox="1"/>
+          <p:nvPr/>
+        </p:nvSpPr>
+        <p:spPr>
+          <a:xfrm>
+            <a:off x="411480" y="5696712"/>
+            <a:ext cx="11368735" cy="566928"/>
+          </a:xfrm>
+          <a:prstGeom prst="rect">
+            <a:avLst/>
+          </a:prstGeom>
+          <a:noFill/>
+        </p:spPr>
+        <p:txBody>
+          <a:bodyPr wrap="square" anchor="ctr" lIns="164592" rIns="164592" tIns="164592" bIns="164592">
+            <a:spAutoFit/>
+          </a:bodyPr>
+          <a:lstStyle/>
+          <a:p>
+            <a:pPr algn="r">
+              <a:lnSpc>
+                <a:spcPct val="100000"/>
+              </a:lnSpc>
+            </a:pPr>
+            <a:r>
+              <a:rPr sz="2800" b="0">
+                <a:solidFill>
+                  <a:srgbClr val="4A5868"/>
+                </a:solidFill>
+                <a:latin typeface="Arial"/>
+              </a:rPr>
+              <a:t>Next: RESULT  →</a:t>
+            </a:r>
+          </a:p>
+        </p:txBody>
+      </p:sp>
+      <p:sp>
+        <p:nvSpPr>
+          <p:cNvPr id="10" name="EXEMPT_FOOTER"/>
           <p:cNvSpPr txBox="1"/>
           <p:nvPr/>
         </p:nvSpPr>
@@ -27957,7 +28659,7 @@
       </p:sp>
       <p:sp>
         <p:nvSpPr>
-          <p:cNvPr id="10" name="EXEMPT_PROGRESS"/>
+          <p:cNvPr id="11" name="EXEMPT_PROGRESS"/>
           <p:cNvSpPr txBox="1"/>
           <p:nvPr/>
         </p:nvSpPr>
@@ -28112,7 +28814,7 @@
         <p:spPr>
           <a:xfrm>
             <a:off x="411480" y="1097280"/>
-            <a:ext cx="11368735" cy="2240280"/>
+            <a:ext cx="11368735" cy="2214880"/>
           </a:xfrm>
           <a:prstGeom prst="rect">
             <a:avLst/>
@@ -28431,7 +29133,7 @@
         <p:spPr>
           <a:xfrm>
             <a:off x="411480" y="1097280"/>
-            <a:ext cx="11368735" cy="1005840"/>
+            <a:ext cx="11368735" cy="995679"/>
           </a:xfrm>
           <a:prstGeom prst="rect">
             <a:avLst/>
@@ -28475,7 +29177,7 @@
         <p:spPr>
           <a:xfrm>
             <a:off x="557784" y="1188720"/>
-            <a:ext cx="11149279" cy="896112"/>
+            <a:ext cx="11149279" cy="885951"/>
           </a:xfrm>
           <a:prstGeom prst="rect">
             <a:avLst/>
@@ -28490,7 +29192,7 @@
           <a:p>
             <a:pPr algn="l">
               <a:lnSpc>
-                <a:spcPct val="100000"/>
+                <a:spcPts val="3200"/>
               </a:lnSpc>
             </a:pPr>
             <a:r>
@@ -28506,7 +29208,7 @@
           <a:p>
             <a:pPr algn="l">
               <a:lnSpc>
-                <a:spcPct val="100000"/>
+                <a:spcPts val="3200"/>
               </a:lnSpc>
             </a:pPr>
             <a:r>
@@ -28529,8 +29231,8 @@
         </p:nvSpPr>
         <p:spPr>
           <a:xfrm>
-            <a:off x="411480" y="2212848"/>
-            <a:ext cx="11368735" cy="1417320"/>
+            <a:off x="411480" y="2202688"/>
+            <a:ext cx="11368735" cy="1402080"/>
           </a:xfrm>
           <a:prstGeom prst="rect">
             <a:avLst/>
@@ -28604,8 +29306,8 @@
         </p:nvSpPr>
         <p:spPr>
           <a:xfrm>
-            <a:off x="411480" y="3739896"/>
-            <a:ext cx="11368735" cy="1005840"/>
+            <a:off x="411480" y="3714496"/>
+            <a:ext cx="11368735" cy="995679"/>
           </a:xfrm>
           <a:prstGeom prst="rect">
             <a:avLst/>
@@ -28648,8 +29350,8 @@
         </p:nvSpPr>
         <p:spPr>
           <a:xfrm>
-            <a:off x="557784" y="3831335"/>
-            <a:ext cx="11149279" cy="896112"/>
+            <a:off x="557784" y="3805935"/>
+            <a:ext cx="11149279" cy="885951"/>
           </a:xfrm>
           <a:prstGeom prst="rect">
             <a:avLst/>
@@ -28664,7 +29366,7 @@
           <a:p>
             <a:pPr algn="l">
               <a:lnSpc>
-                <a:spcPct val="100000"/>
+                <a:spcPts val="3200"/>
               </a:lnSpc>
             </a:pPr>
             <a:r>
@@ -28680,7 +29382,7 @@
           <a:p>
             <a:pPr algn="l">
               <a:lnSpc>
-                <a:spcPct val="100000"/>
+                <a:spcPts val="3200"/>
               </a:lnSpc>
             </a:pPr>
             <a:r>
@@ -28697,7 +29399,46 @@
       </p:sp>
       <p:sp>
         <p:nvSpPr>
-          <p:cNvPr id="9" name="EXEMPT_FOOTER"/>
+          <p:cNvPr id="9" name="TextBox 8"/>
+          <p:cNvSpPr txBox="1"/>
+          <p:nvPr/>
+        </p:nvSpPr>
+        <p:spPr>
+          <a:xfrm>
+            <a:off x="411480" y="5696712"/>
+            <a:ext cx="11368735" cy="566928"/>
+          </a:xfrm>
+          <a:prstGeom prst="rect">
+            <a:avLst/>
+          </a:prstGeom>
+          <a:noFill/>
+        </p:spPr>
+        <p:txBody>
+          <a:bodyPr wrap="square" anchor="ctr" lIns="164592" rIns="164592" tIns="164592" bIns="164592">
+            <a:spAutoFit/>
+          </a:bodyPr>
+          <a:lstStyle/>
+          <a:p>
+            <a:pPr algn="r">
+              <a:lnSpc>
+                <a:spcPct val="100000"/>
+              </a:lnSpc>
+            </a:pPr>
+            <a:r>
+              <a:rPr sz="2800" b="0">
+                <a:solidFill>
+                  <a:srgbClr val="4A5868"/>
+                </a:solidFill>
+                <a:latin typeface="Arial"/>
+              </a:rPr>
+              <a:t>Next: RESULT  →</a:t>
+            </a:r>
+          </a:p>
+        </p:txBody>
+      </p:sp>
+      <p:sp>
+        <p:nvSpPr>
+          <p:cNvPr id="10" name="EXEMPT_FOOTER"/>
           <p:cNvSpPr txBox="1"/>
           <p:nvPr/>
         </p:nvSpPr>
@@ -28736,7 +29477,7 @@
       </p:sp>
       <p:sp>
         <p:nvSpPr>
-          <p:cNvPr id="10" name="EXEMPT_PROGRESS"/>
+          <p:cNvPr id="11" name="EXEMPT_PROGRESS"/>
           <p:cNvSpPr txBox="1"/>
           <p:nvPr/>
         </p:nvSpPr>
@@ -28891,7 +29632,7 @@
         <p:spPr>
           <a:xfrm>
             <a:off x="411480" y="1097280"/>
-            <a:ext cx="11368735" cy="2240280"/>
+            <a:ext cx="11368735" cy="2214880"/>
           </a:xfrm>
           <a:prstGeom prst="rect">
             <a:avLst/>
@@ -29210,7 +29951,7 @@
         <p:spPr>
           <a:xfrm>
             <a:off x="411480" y="1097280"/>
-            <a:ext cx="11368735" cy="1417320"/>
+            <a:ext cx="11368735" cy="1402080"/>
           </a:xfrm>
           <a:prstGeom prst="rect">
             <a:avLst/>
@@ -29309,8 +30050,8 @@
         </p:nvSpPr>
         <p:spPr>
           <a:xfrm>
-            <a:off x="411480" y="2624328"/>
-            <a:ext cx="11368735" cy="1005840"/>
+            <a:off x="411480" y="2609088"/>
+            <a:ext cx="11368735" cy="995679"/>
           </a:xfrm>
           <a:prstGeom prst="rect">
             <a:avLst/>
@@ -29353,8 +30094,8 @@
         </p:nvSpPr>
         <p:spPr>
           <a:xfrm>
-            <a:off x="557784" y="2715768"/>
-            <a:ext cx="11149279" cy="896112"/>
+            <a:off x="557784" y="2700528"/>
+            <a:ext cx="11149279" cy="885951"/>
           </a:xfrm>
           <a:prstGeom prst="rect">
             <a:avLst/>
@@ -29369,7 +30110,7 @@
           <a:p>
             <a:pPr algn="l">
               <a:lnSpc>
-                <a:spcPct val="100000"/>
+                <a:spcPts val="3200"/>
               </a:lnSpc>
             </a:pPr>
             <a:r>
@@ -29385,7 +30126,7 @@
           <a:p>
             <a:pPr algn="l">
               <a:lnSpc>
-                <a:spcPct val="100000"/>
+                <a:spcPts val="3200"/>
               </a:lnSpc>
             </a:pPr>
             <a:r>
@@ -29402,75 +30143,39 @@
       </p:sp>
       <p:sp>
         <p:nvSpPr>
-          <p:cNvPr id="7" name="EXEMPT_PASTE"/>
-          <p:cNvSpPr/>
-          <p:nvPr/>
-        </p:nvSpPr>
-        <p:spPr>
-          <a:xfrm>
-            <a:off x="411480" y="3739896"/>
-            <a:ext cx="11368735" cy="1417320"/>
-          </a:xfrm>
-          <a:prstGeom prst="rect">
-            <a:avLst/>
-          </a:prstGeom>
-          <a:solidFill>
-            <a:srgbClr val="FFF4E5"/>
-          </a:solidFill>
-          <a:ln w="25400">
-            <a:solidFill>
-              <a:srgbClr val="C2410C"/>
-            </a:solidFill>
-          </a:ln>
-          <a:effectLst/>
-        </p:spPr>
-        <p:style>
-          <a:lnRef idx="1">
-            <a:schemeClr val="accent1"/>
-          </a:lnRef>
-          <a:fillRef idx="3">
-            <a:schemeClr val="accent1"/>
-          </a:fillRef>
-          <a:effectRef idx="2">
-            <a:schemeClr val="accent1"/>
-          </a:effectRef>
-          <a:fontRef idx="minor">
-            <a:schemeClr val="lt1"/>
-          </a:fontRef>
-        </p:style>
-        <p:txBody>
-          <a:bodyPr rtlCol="0" anchor="t" wrap="square" lIns="137160" rIns="137160" tIns="137160" bIns="137160"/>
-          <a:lstStyle/>
-          <a:p>
-            <a:pPr algn="l">
-              <a:lnSpc>
-                <a:spcPct val="100000"/>
-              </a:lnSpc>
-            </a:pPr>
-            <a:r>
-              <a:rPr sz="2200" b="1">
-                <a:solidFill>
-                  <a:srgbClr val="C2410C"/>
-                </a:solidFill>
-                <a:latin typeface="Arial"/>
-              </a:rPr>
-              <a:t>2  REPLY  ·  PASTE YOUR SCREENSHOT HERE</a:t>
-            </a:r>
-          </a:p>
-          <a:p>
-            <a:pPr algn="l">
-              <a:lnSpc>
-                <a:spcPct val="100000"/>
-              </a:lnSpc>
-            </a:pPr>
-            <a:r>
-              <a:rPr sz="1800" b="0">
-                <a:solidFill>
-                  <a:srgbClr val="14202E"/>
-                </a:solidFill>
-                <a:latin typeface="Arial"/>
-              </a:rPr>
-              <a:t>Screenshot the shell's reply to the command above (Win + Shift + S). Click this box's edge, press Delete, then Ctrl + V.</a:t>
+          <p:cNvPr id="7" name="TextBox 6"/>
+          <p:cNvSpPr txBox="1"/>
+          <p:nvPr/>
+        </p:nvSpPr>
+        <p:spPr>
+          <a:xfrm>
+            <a:off x="411480" y="5696712"/>
+            <a:ext cx="11368735" cy="566928"/>
+          </a:xfrm>
+          <a:prstGeom prst="rect">
+            <a:avLst/>
+          </a:prstGeom>
+          <a:noFill/>
+        </p:spPr>
+        <p:txBody>
+          <a:bodyPr wrap="square" anchor="ctr" lIns="164592" rIns="164592" tIns="164592" bIns="164592">
+            <a:spAutoFit/>
+          </a:bodyPr>
+          <a:lstStyle/>
+          <a:p>
+            <a:pPr algn="r">
+              <a:lnSpc>
+                <a:spcPct val="100000"/>
+              </a:lnSpc>
+            </a:pPr>
+            <a:r>
+              <a:rPr sz="2800" b="0">
+                <a:solidFill>
+                  <a:srgbClr val="4A5868"/>
+                </a:solidFill>
+                <a:latin typeface="Arial"/>
+              </a:rPr>
+              <a:t>Next: 2  REPLY  →</a:t>
             </a:r>
           </a:p>
         </p:txBody>
@@ -29710,7 +30415,7 @@
         <p:spPr>
           <a:xfrm>
             <a:off x="411480" y="1097280"/>
-            <a:ext cx="11368735" cy="1005840"/>
+            <a:ext cx="11368735" cy="995679"/>
           </a:xfrm>
           <a:prstGeom prst="rect">
             <a:avLst/>
@@ -29754,7 +30459,7 @@
         <p:spPr>
           <a:xfrm>
             <a:off x="557784" y="1188720"/>
-            <a:ext cx="11149279" cy="896112"/>
+            <a:ext cx="11149279" cy="885951"/>
           </a:xfrm>
           <a:prstGeom prst="rect">
             <a:avLst/>
@@ -29769,7 +30474,7 @@
           <a:p>
             <a:pPr algn="l">
               <a:lnSpc>
-                <a:spcPct val="100000"/>
+                <a:spcPts val="3200"/>
               </a:lnSpc>
             </a:pPr>
             <a:r>
@@ -29785,7 +30490,7 @@
           <a:p>
             <a:pPr algn="l">
               <a:lnSpc>
-                <a:spcPct val="100000"/>
+                <a:spcPts val="3200"/>
               </a:lnSpc>
             </a:pPr>
             <a:r>
@@ -29808,8 +30513,8 @@
         </p:nvSpPr>
         <p:spPr>
           <a:xfrm>
-            <a:off x="411480" y="2212848"/>
-            <a:ext cx="11368735" cy="2651760"/>
+            <a:off x="411480" y="2202688"/>
+            <a:ext cx="11368735" cy="2621280"/>
           </a:xfrm>
           <a:prstGeom prst="rect">
             <a:avLst/>
@@ -30763,7 +31468,7 @@
         <p:spPr>
           <a:xfrm>
             <a:off x="411480" y="1097280"/>
-            <a:ext cx="11368735" cy="1005840"/>
+            <a:ext cx="11368735" cy="995679"/>
           </a:xfrm>
           <a:prstGeom prst="rect">
             <a:avLst/>
@@ -30807,7 +31512,7 @@
         <p:spPr>
           <a:xfrm>
             <a:off x="557784" y="1188720"/>
-            <a:ext cx="11149279" cy="896112"/>
+            <a:ext cx="11149279" cy="885951"/>
           </a:xfrm>
           <a:prstGeom prst="rect">
             <a:avLst/>
@@ -30822,7 +31527,7 @@
           <a:p>
             <a:pPr algn="l">
               <a:lnSpc>
-                <a:spcPct val="100000"/>
+                <a:spcPts val="3200"/>
               </a:lnSpc>
             </a:pPr>
             <a:r>
@@ -30838,7 +31543,7 @@
           <a:p>
             <a:pPr algn="l">
               <a:lnSpc>
-                <a:spcPct val="100000"/>
+                <a:spcPts val="3200"/>
               </a:lnSpc>
             </a:pPr>
             <a:r>
@@ -30855,7 +31560,46 @@
       </p:sp>
       <p:sp>
         <p:nvSpPr>
-          <p:cNvPr id="6" name="EXEMPT_FOOTER"/>
+          <p:cNvPr id="6" name="TextBox 5"/>
+          <p:cNvSpPr txBox="1"/>
+          <p:nvPr/>
+        </p:nvSpPr>
+        <p:spPr>
+          <a:xfrm>
+            <a:off x="411480" y="5696712"/>
+            <a:ext cx="11368735" cy="566928"/>
+          </a:xfrm>
+          <a:prstGeom prst="rect">
+            <a:avLst/>
+          </a:prstGeom>
+          <a:noFill/>
+        </p:spPr>
+        <p:txBody>
+          <a:bodyPr wrap="square" anchor="ctr" lIns="164592" rIns="164592" tIns="164592" bIns="164592">
+            <a:spAutoFit/>
+          </a:bodyPr>
+          <a:lstStyle/>
+          <a:p>
+            <a:pPr algn="r">
+              <a:lnSpc>
+                <a:spcPct val="100000"/>
+              </a:lnSpc>
+            </a:pPr>
+            <a:r>
+              <a:rPr sz="2800" b="0">
+                <a:solidFill>
+                  <a:srgbClr val="4A5868"/>
+                </a:solidFill>
+                <a:latin typeface="Arial"/>
+              </a:rPr>
+              <a:t>Next: RESULT  →</a:t>
+            </a:r>
+          </a:p>
+        </p:txBody>
+      </p:sp>
+      <p:sp>
+        <p:nvSpPr>
+          <p:cNvPr id="7" name="EXEMPT_FOOTER"/>
           <p:cNvSpPr txBox="1"/>
           <p:nvPr/>
         </p:nvSpPr>
@@ -30894,7 +31638,7 @@
       </p:sp>
       <p:sp>
         <p:nvSpPr>
-          <p:cNvPr id="7" name="EXEMPT_PROGRESS"/>
+          <p:cNvPr id="8" name="EXEMPT_PROGRESS"/>
           <p:cNvSpPr txBox="1"/>
           <p:nvPr/>
         </p:nvSpPr>
@@ -31049,7 +31793,7 @@
         <p:spPr>
           <a:xfrm>
             <a:off x="411480" y="1097280"/>
-            <a:ext cx="11368735" cy="3474720"/>
+            <a:ext cx="11368735" cy="3434080"/>
           </a:xfrm>
           <a:prstGeom prst="rect">
             <a:avLst/>
@@ -31368,7 +32112,7 @@
         <p:spPr>
           <a:xfrm>
             <a:off x="411480" y="1097280"/>
-            <a:ext cx="11368735" cy="1417320"/>
+            <a:ext cx="11368735" cy="1402080"/>
           </a:xfrm>
           <a:prstGeom prst="rect">
             <a:avLst/>
@@ -31412,7 +32156,7 @@
         <p:spPr>
           <a:xfrm>
             <a:off x="557784" y="1188720"/>
-            <a:ext cx="11149279" cy="1307592"/>
+            <a:ext cx="11149279" cy="1292351"/>
           </a:xfrm>
           <a:prstGeom prst="rect">
             <a:avLst/>
@@ -31427,7 +32171,7 @@
           <a:p>
             <a:pPr algn="l">
               <a:lnSpc>
-                <a:spcPct val="100000"/>
+                <a:spcPts val="3200"/>
               </a:lnSpc>
             </a:pPr>
             <a:r>
@@ -31443,7 +32187,7 @@
           <a:p>
             <a:pPr algn="l">
               <a:lnSpc>
-                <a:spcPct val="100000"/>
+                <a:spcPts val="3200"/>
               </a:lnSpc>
             </a:pPr>
             <a:r>
@@ -31459,7 +32203,7 @@
           <a:p>
             <a:pPr algn="l">
               <a:lnSpc>
-                <a:spcPct val="100000"/>
+                <a:spcPts val="3200"/>
               </a:lnSpc>
             </a:pPr>
             <a:r>
@@ -31482,8 +32226,8 @@
         </p:nvSpPr>
         <p:spPr>
           <a:xfrm>
-            <a:off x="411480" y="2624328"/>
-            <a:ext cx="11368735" cy="2651760"/>
+            <a:off x="411480" y="2609088"/>
+            <a:ext cx="11368735" cy="2621280"/>
           </a:xfrm>
           <a:prstGeom prst="rect">
             <a:avLst/>
@@ -31802,7 +32546,7 @@
         <p:spPr>
           <a:xfrm>
             <a:off x="411480" y="1097280"/>
-            <a:ext cx="11368735" cy="1417320"/>
+            <a:ext cx="11368735" cy="1402080"/>
           </a:xfrm>
           <a:prstGeom prst="rect">
             <a:avLst/>
@@ -31846,7 +32590,7 @@
         <p:spPr>
           <a:xfrm>
             <a:off x="557784" y="1188720"/>
-            <a:ext cx="11149279" cy="1307592"/>
+            <a:ext cx="11149279" cy="1292351"/>
           </a:xfrm>
           <a:prstGeom prst="rect">
             <a:avLst/>
@@ -31861,7 +32605,7 @@
           <a:p>
             <a:pPr algn="l">
               <a:lnSpc>
-                <a:spcPct val="100000"/>
+                <a:spcPts val="3200"/>
               </a:lnSpc>
             </a:pPr>
             <a:r>
@@ -31877,7 +32621,7 @@
           <a:p>
             <a:pPr algn="l">
               <a:lnSpc>
-                <a:spcPct val="100000"/>
+                <a:spcPts val="3200"/>
               </a:lnSpc>
             </a:pPr>
             <a:r>
@@ -31893,7 +32637,7 @@
           <a:p>
             <a:pPr algn="l">
               <a:lnSpc>
-                <a:spcPct val="100000"/>
+                <a:spcPts val="3200"/>
               </a:lnSpc>
             </a:pPr>
             <a:r>
@@ -31916,8 +32660,8 @@
         </p:nvSpPr>
         <p:spPr>
           <a:xfrm>
-            <a:off x="411480" y="2624328"/>
-            <a:ext cx="11368735" cy="2240280"/>
+            <a:off x="411480" y="2609088"/>
+            <a:ext cx="11368735" cy="2214880"/>
           </a:xfrm>
           <a:prstGeom prst="rect">
             <a:avLst/>
@@ -32236,7 +32980,7 @@
         <p:spPr>
           <a:xfrm>
             <a:off x="411480" y="1097280"/>
-            <a:ext cx="11368735" cy="1005840"/>
+            <a:ext cx="11368735" cy="995679"/>
           </a:xfrm>
           <a:prstGeom prst="rect">
             <a:avLst/>
@@ -32280,7 +33024,7 @@
         <p:spPr>
           <a:xfrm>
             <a:off x="557784" y="1188720"/>
-            <a:ext cx="11149279" cy="896112"/>
+            <a:ext cx="11149279" cy="885951"/>
           </a:xfrm>
           <a:prstGeom prst="rect">
             <a:avLst/>
@@ -32295,7 +33039,7 @@
           <a:p>
             <a:pPr algn="l">
               <a:lnSpc>
-                <a:spcPct val="100000"/>
+                <a:spcPts val="3200"/>
               </a:lnSpc>
             </a:pPr>
             <a:r>
@@ -32311,7 +33055,7 @@
           <a:p>
             <a:pPr algn="l">
               <a:lnSpc>
-                <a:spcPct val="100000"/>
+                <a:spcPts val="3200"/>
               </a:lnSpc>
             </a:pPr>
             <a:r>
@@ -32334,8 +33078,8 @@
         </p:nvSpPr>
         <p:spPr>
           <a:xfrm>
-            <a:off x="411480" y="2212848"/>
-            <a:ext cx="11368735" cy="2651760"/>
+            <a:off x="411480" y="2202688"/>
+            <a:ext cx="11368735" cy="2621280"/>
           </a:xfrm>
           <a:prstGeom prst="rect">
             <a:avLst/>
@@ -32654,7 +33398,7 @@
         <p:spPr>
           <a:xfrm>
             <a:off x="411480" y="1097280"/>
-            <a:ext cx="11368735" cy="1417320"/>
+            <a:ext cx="11368735" cy="1402080"/>
           </a:xfrm>
           <a:prstGeom prst="rect">
             <a:avLst/>
@@ -32698,7 +33442,7 @@
         <p:spPr>
           <a:xfrm>
             <a:off x="557784" y="1188720"/>
-            <a:ext cx="11149279" cy="1307592"/>
+            <a:ext cx="11149279" cy="1292351"/>
           </a:xfrm>
           <a:prstGeom prst="rect">
             <a:avLst/>
@@ -32713,7 +33457,7 @@
           <a:p>
             <a:pPr algn="l">
               <a:lnSpc>
-                <a:spcPct val="100000"/>
+                <a:spcPts val="3200"/>
               </a:lnSpc>
             </a:pPr>
             <a:r>
@@ -32729,7 +33473,7 @@
           <a:p>
             <a:pPr algn="l">
               <a:lnSpc>
-                <a:spcPct val="100000"/>
+                <a:spcPts val="3200"/>
               </a:lnSpc>
             </a:pPr>
             <a:r>
@@ -32745,7 +33489,7 @@
           <a:p>
             <a:pPr algn="l">
               <a:lnSpc>
-                <a:spcPct val="100000"/>
+                <a:spcPts val="3200"/>
               </a:lnSpc>
             </a:pPr>
             <a:r>
@@ -32768,8 +33512,8 @@
         </p:nvSpPr>
         <p:spPr>
           <a:xfrm>
-            <a:off x="411480" y="2624328"/>
-            <a:ext cx="11368735" cy="2240280"/>
+            <a:off x="411480" y="2609088"/>
+            <a:ext cx="11368735" cy="2214880"/>
           </a:xfrm>
           <a:prstGeom prst="rect">
             <a:avLst/>
@@ -33309,7 +34053,7 @@
         <p:spPr>
           <a:xfrm>
             <a:off x="411480" y="1097280"/>
-            <a:ext cx="11368735" cy="1417320"/>
+            <a:ext cx="11368735" cy="1402080"/>
           </a:xfrm>
           <a:prstGeom prst="rect">
             <a:avLst/>
@@ -33354,6 +34098,81 @@
                 </a:solidFill>
                 <a:latin typeface="Arial"/>
               </a:rPr>
+              <a:t>2  REPLY  ·  PASTE YOUR SCREENSHOT HERE</a:t>
+            </a:r>
+          </a:p>
+          <a:p>
+            <a:pPr algn="l">
+              <a:lnSpc>
+                <a:spcPct val="100000"/>
+              </a:lnSpc>
+            </a:pPr>
+            <a:r>
+              <a:rPr sz="1800" b="0">
+                <a:solidFill>
+                  <a:srgbClr val="14202E"/>
+                </a:solidFill>
+                <a:latin typeface="Arial"/>
+              </a:rPr>
+              <a:t>Screenshot the shell's reply to the command above (Win + Shift + S). Click this box's edge, press Delete, then Ctrl + V.</a:t>
+            </a:r>
+          </a:p>
+        </p:txBody>
+      </p:sp>
+      <p:sp>
+        <p:nvSpPr>
+          <p:cNvPr id="5" name="EXEMPT_PASTE"/>
+          <p:cNvSpPr/>
+          <p:nvPr/>
+        </p:nvSpPr>
+        <p:spPr>
+          <a:xfrm>
+            <a:off x="411480" y="2609088"/>
+            <a:ext cx="11368735" cy="1402080"/>
+          </a:xfrm>
+          <a:prstGeom prst="rect">
+            <a:avLst/>
+          </a:prstGeom>
+          <a:solidFill>
+            <a:srgbClr val="FFF4E5"/>
+          </a:solidFill>
+          <a:ln w="25400">
+            <a:solidFill>
+              <a:srgbClr val="C2410C"/>
+            </a:solidFill>
+          </a:ln>
+          <a:effectLst/>
+        </p:spPr>
+        <p:style>
+          <a:lnRef idx="1">
+            <a:schemeClr val="accent1"/>
+          </a:lnRef>
+          <a:fillRef idx="3">
+            <a:schemeClr val="accent1"/>
+          </a:fillRef>
+          <a:effectRef idx="2">
+            <a:schemeClr val="accent1"/>
+          </a:effectRef>
+          <a:fontRef idx="minor">
+            <a:schemeClr val="lt1"/>
+          </a:fontRef>
+        </p:style>
+        <p:txBody>
+          <a:bodyPr rtlCol="0" anchor="t" wrap="square" lIns="137160" rIns="137160" tIns="137160" bIns="137160"/>
+          <a:lstStyle/>
+          <a:p>
+            <a:pPr algn="l">
+              <a:lnSpc>
+                <a:spcPct val="100000"/>
+              </a:lnSpc>
+            </a:pPr>
+            <a:r>
+              <a:rPr sz="2200" b="1">
+                <a:solidFill>
+                  <a:srgbClr val="C2410C"/>
+                </a:solidFill>
+                <a:latin typeface="Arial"/>
+              </a:rPr>
               <a:t>3  AFTER  ·  PASTE YOUR SCREENSHOT HERE</a:t>
             </a:r>
           </a:p>
@@ -33402,7 +34221,7 @@
       </p:sp>
       <p:sp>
         <p:nvSpPr>
-          <p:cNvPr id="5" name="Rectangle 4"/>
+          <p:cNvPr id="6" name="Rectangle 5"/>
           <p:cNvSpPr/>
           <p:nvPr/>
         </p:nvSpPr>
@@ -33459,7 +34278,7 @@
       </p:sp>
       <p:sp>
         <p:nvSpPr>
-          <p:cNvPr id="6" name="EXEMPT_FOOTER"/>
+          <p:cNvPr id="7" name="EXEMPT_FOOTER"/>
           <p:cNvSpPr txBox="1"/>
           <p:nvPr/>
         </p:nvSpPr>
@@ -33498,7 +34317,7 @@
       </p:sp>
       <p:sp>
         <p:nvSpPr>
-          <p:cNvPr id="7" name="EXEMPT_FOOTER"/>
+          <p:cNvPr id="8" name="EXEMPT_FOOTER"/>
           <p:cNvSpPr txBox="1"/>
           <p:nvPr/>
         </p:nvSpPr>
@@ -33537,7 +34356,7 @@
       </p:sp>
       <p:sp>
         <p:nvSpPr>
-          <p:cNvPr id="8" name="EXEMPT_PROGRESS"/>
+          <p:cNvPr id="9" name="EXEMPT_PROGRESS"/>
           <p:cNvSpPr txBox="1"/>
           <p:nvPr/>
         </p:nvSpPr>
@@ -33978,7 +34797,7 @@
         <p:spPr>
           <a:xfrm>
             <a:off x="411480" y="1097280"/>
-            <a:ext cx="11368735" cy="1417320"/>
+            <a:ext cx="11368735" cy="1402080"/>
           </a:xfrm>
           <a:prstGeom prst="rect">
             <a:avLst/>
@@ -34071,58 +34890,14 @@
       </p:sp>
       <p:sp>
         <p:nvSpPr>
-          <p:cNvPr id="5" name="Rectangle 4"/>
-          <p:cNvSpPr/>
-          <p:nvPr/>
-        </p:nvSpPr>
-        <p:spPr>
-          <a:xfrm>
-            <a:off x="411480" y="2624328"/>
-            <a:ext cx="11368735" cy="3063240"/>
-          </a:xfrm>
-          <a:prstGeom prst="rect">
-            <a:avLst/>
-          </a:prstGeom>
-          <a:solidFill>
-            <a:srgbClr val="16212E"/>
-          </a:solidFill>
-          <a:ln>
-            <a:noFill/>
-          </a:ln>
-          <a:effectLst/>
-        </p:spPr>
-        <p:style>
-          <a:lnRef idx="1">
-            <a:schemeClr val="accent1"/>
-          </a:lnRef>
-          <a:fillRef idx="3">
-            <a:schemeClr val="accent1"/>
-          </a:fillRef>
-          <a:effectRef idx="2">
-            <a:schemeClr val="accent1"/>
-          </a:effectRef>
-          <a:fontRef idx="minor">
-            <a:schemeClr val="lt1"/>
-          </a:fontRef>
-        </p:style>
-        <p:txBody>
-          <a:bodyPr rtlCol="0" anchor="ctr"/>
-          <a:lstStyle/>
-          <a:p>
-            <a:pPr algn="ctr"/>
-          </a:p>
-        </p:txBody>
-      </p:sp>
-      <p:sp>
-        <p:nvSpPr>
-          <p:cNvPr id="6" name="TextBox 5"/>
+          <p:cNvPr id="5" name="TextBox 4"/>
           <p:cNvSpPr txBox="1"/>
           <p:nvPr/>
         </p:nvSpPr>
         <p:spPr>
           <a:xfrm>
-            <a:off x="557784" y="2715768"/>
-            <a:ext cx="11149279" cy="2953512"/>
+            <a:off x="411480" y="5696712"/>
+            <a:ext cx="11368735" cy="566928"/>
           </a:xfrm>
           <a:prstGeom prst="rect">
             <a:avLst/>
@@ -34130,28 +34905,12 @@
           <a:noFill/>
         </p:spPr>
         <p:txBody>
-          <a:bodyPr wrap="none" anchor="t" lIns="0" rIns="0" tIns="0" bIns="0">
+          <a:bodyPr wrap="square" anchor="ctr" lIns="164592" rIns="164592" tIns="164592" bIns="164592">
             <a:spAutoFit/>
           </a:bodyPr>
           <a:lstStyle/>
           <a:p>
-            <a:pPr algn="l">
-              <a:lnSpc>
-                <a:spcPct val="100000"/>
-              </a:lnSpc>
-            </a:pPr>
-            <a:r>
-              <a:rPr sz="2800" b="1">
-                <a:solidFill>
-                  <a:srgbClr val="F2B27A"/>
-                </a:solidFill>
-                <a:latin typeface="Arial"/>
-              </a:rPr>
-              <a:t>2  COMMAND</a:t>
-            </a:r>
-          </a:p>
-          <a:p>
-            <a:pPr algn="l">
+            <a:pPr algn="r">
               <a:lnSpc>
                 <a:spcPct val="100000"/>
               </a:lnSpc>
@@ -34159,98 +34918,18 @@
             <a:r>
               <a:rPr sz="2800" b="0">
                 <a:solidFill>
-                  <a:srgbClr val="E6ECF2"/>
-                </a:solidFill>
-                <a:latin typeface="Courier New"/>
-              </a:rPr>
-              <a:t>db.food.insertOne({"_id" : 1,</a:t>
-            </a:r>
-          </a:p>
-          <a:p>
-            <a:pPr algn="l">
-              <a:lnSpc>
-                <a:spcPct val="100000"/>
-              </a:lnSpc>
-            </a:pPr>
-            <a:r>
-              <a:rPr sz="2800" b="0">
-                <a:solidFill>
-                  <a:srgbClr val="E6ECF2"/>
-                </a:solidFill>
-                <a:latin typeface="Courier New"/>
-              </a:rPr>
-              <a:t>  "fruit" : ["apple", "banana", "peach"]})</a:t>
-            </a:r>
-          </a:p>
-          <a:p>
-            <a:pPr algn="l">
-              <a:lnSpc>
-                <a:spcPct val="100000"/>
-              </a:lnSpc>
-            </a:pPr>
-            <a:r>
-              <a:rPr sz="2800" b="0">
-                <a:solidFill>
-                  <a:srgbClr val="E6ECF2"/>
-                </a:solidFill>
-                <a:latin typeface="Courier New"/>
-              </a:rPr>
-              <a:t>db.food.insertOne({"_id" : 2,</a:t>
-            </a:r>
-          </a:p>
-          <a:p>
-            <a:pPr algn="l">
-              <a:lnSpc>
-                <a:spcPct val="100000"/>
-              </a:lnSpc>
-            </a:pPr>
-            <a:r>
-              <a:rPr sz="2800" b="0">
-                <a:solidFill>
-                  <a:srgbClr val="E6ECF2"/>
-                </a:solidFill>
-                <a:latin typeface="Courier New"/>
-              </a:rPr>
-              <a:t>  "fruit" : ["apple", "kumquat", "orange"]})</a:t>
-            </a:r>
-          </a:p>
-          <a:p>
-            <a:pPr algn="l">
-              <a:lnSpc>
-                <a:spcPct val="100000"/>
-              </a:lnSpc>
-            </a:pPr>
-            <a:r>
-              <a:rPr sz="2800" b="0">
-                <a:solidFill>
-                  <a:srgbClr val="E6ECF2"/>
-                </a:solidFill>
-                <a:latin typeface="Courier New"/>
-              </a:rPr>
-              <a:t>db.food.insertOne({"_id" : 3,</a:t>
-            </a:r>
-          </a:p>
-          <a:p>
-            <a:pPr algn="l">
-              <a:lnSpc>
-                <a:spcPct val="100000"/>
-              </a:lnSpc>
-            </a:pPr>
-            <a:r>
-              <a:rPr sz="2800" b="0">
-                <a:solidFill>
-                  <a:srgbClr val="E6ECF2"/>
-                </a:solidFill>
-                <a:latin typeface="Courier New"/>
-              </a:rPr>
-              <a:t>  "fruit" : ["cherry", "banana", "apple"]})</a:t>
-            </a:r>
-          </a:p>
-        </p:txBody>
-      </p:sp>
-      <p:sp>
-        <p:nvSpPr>
-          <p:cNvPr id="7" name="EXEMPT_FOOTER"/>
+                  <a:srgbClr val="4A5868"/>
+                </a:solidFill>
+                <a:latin typeface="Arial"/>
+              </a:rPr>
+              <a:t>Next: 2  COMMAND  →</a:t>
+            </a:r>
+          </a:p>
+        </p:txBody>
+      </p:sp>
+      <p:sp>
+        <p:nvSpPr>
+          <p:cNvPr id="6" name="EXEMPT_FOOTER"/>
           <p:cNvSpPr txBox="1"/>
           <p:nvPr/>
         </p:nvSpPr>
@@ -34289,7 +34968,7 @@
       </p:sp>
       <p:sp>
         <p:nvSpPr>
-          <p:cNvPr id="8" name="EXEMPT_PROGRESS"/>
+          <p:cNvPr id="7" name="EXEMPT_PROGRESS"/>
           <p:cNvSpPr txBox="1"/>
           <p:nvPr/>
         </p:nvSpPr>
@@ -34437,14 +35116,193 @@
       </p:sp>
       <p:sp>
         <p:nvSpPr>
-          <p:cNvPr id="4" name="EXEMPT_PASTE"/>
+          <p:cNvPr id="4" name="Rectangle 3"/>
           <p:cNvSpPr/>
           <p:nvPr/>
         </p:nvSpPr>
         <p:spPr>
           <a:xfrm>
             <a:off x="411480" y="1097280"/>
-            <a:ext cx="11368735" cy="1417320"/>
+            <a:ext cx="11368735" cy="3027680"/>
+          </a:xfrm>
+          <a:prstGeom prst="rect">
+            <a:avLst/>
+          </a:prstGeom>
+          <a:solidFill>
+            <a:srgbClr val="16212E"/>
+          </a:solidFill>
+          <a:ln>
+            <a:noFill/>
+          </a:ln>
+          <a:effectLst/>
+        </p:spPr>
+        <p:style>
+          <a:lnRef idx="1">
+            <a:schemeClr val="accent1"/>
+          </a:lnRef>
+          <a:fillRef idx="3">
+            <a:schemeClr val="accent1"/>
+          </a:fillRef>
+          <a:effectRef idx="2">
+            <a:schemeClr val="accent1"/>
+          </a:effectRef>
+          <a:fontRef idx="minor">
+            <a:schemeClr val="lt1"/>
+          </a:fontRef>
+        </p:style>
+        <p:txBody>
+          <a:bodyPr rtlCol="0" anchor="ctr"/>
+          <a:lstStyle/>
+          <a:p>
+            <a:pPr algn="ctr"/>
+          </a:p>
+        </p:txBody>
+      </p:sp>
+      <p:sp>
+        <p:nvSpPr>
+          <p:cNvPr id="5" name="TextBox 4"/>
+          <p:cNvSpPr txBox="1"/>
+          <p:nvPr/>
+        </p:nvSpPr>
+        <p:spPr>
+          <a:xfrm>
+            <a:off x="557784" y="1188720"/>
+            <a:ext cx="11149279" cy="2917951"/>
+          </a:xfrm>
+          <a:prstGeom prst="rect">
+            <a:avLst/>
+          </a:prstGeom>
+          <a:noFill/>
+        </p:spPr>
+        <p:txBody>
+          <a:bodyPr wrap="none" anchor="t" lIns="0" rIns="0" tIns="0" bIns="0">
+            <a:spAutoFit/>
+          </a:bodyPr>
+          <a:lstStyle/>
+          <a:p>
+            <a:pPr algn="l">
+              <a:lnSpc>
+                <a:spcPts val="3200"/>
+              </a:lnSpc>
+            </a:pPr>
+            <a:r>
+              <a:rPr sz="2800" b="1">
+                <a:solidFill>
+                  <a:srgbClr val="F2B27A"/>
+                </a:solidFill>
+                <a:latin typeface="Arial"/>
+              </a:rPr>
+              <a:t>2  COMMAND</a:t>
+            </a:r>
+          </a:p>
+          <a:p>
+            <a:pPr algn="l">
+              <a:lnSpc>
+                <a:spcPts val="3200"/>
+              </a:lnSpc>
+            </a:pPr>
+            <a:r>
+              <a:rPr sz="2800" b="0">
+                <a:solidFill>
+                  <a:srgbClr val="E6ECF2"/>
+                </a:solidFill>
+                <a:latin typeface="Courier New"/>
+              </a:rPr>
+              <a:t>db.food.insertOne({"_id" : 1,</a:t>
+            </a:r>
+          </a:p>
+          <a:p>
+            <a:pPr algn="l">
+              <a:lnSpc>
+                <a:spcPts val="3200"/>
+              </a:lnSpc>
+            </a:pPr>
+            <a:r>
+              <a:rPr sz="2800" b="0">
+                <a:solidFill>
+                  <a:srgbClr val="E6ECF2"/>
+                </a:solidFill>
+                <a:latin typeface="Courier New"/>
+              </a:rPr>
+              <a:t>  "fruit" : ["apple", "banana", "peach"]})</a:t>
+            </a:r>
+          </a:p>
+          <a:p>
+            <a:pPr algn="l">
+              <a:lnSpc>
+                <a:spcPts val="3200"/>
+              </a:lnSpc>
+            </a:pPr>
+            <a:r>
+              <a:rPr sz="2800" b="0">
+                <a:solidFill>
+                  <a:srgbClr val="E6ECF2"/>
+                </a:solidFill>
+                <a:latin typeface="Courier New"/>
+              </a:rPr>
+              <a:t>db.food.insertOne({"_id" : 2,</a:t>
+            </a:r>
+          </a:p>
+          <a:p>
+            <a:pPr algn="l">
+              <a:lnSpc>
+                <a:spcPts val="3200"/>
+              </a:lnSpc>
+            </a:pPr>
+            <a:r>
+              <a:rPr sz="2800" b="0">
+                <a:solidFill>
+                  <a:srgbClr val="E6ECF2"/>
+                </a:solidFill>
+                <a:latin typeface="Courier New"/>
+              </a:rPr>
+              <a:t>  "fruit" : ["apple", "kumquat", "orange"]})</a:t>
+            </a:r>
+          </a:p>
+          <a:p>
+            <a:pPr algn="l">
+              <a:lnSpc>
+                <a:spcPts val="3200"/>
+              </a:lnSpc>
+            </a:pPr>
+            <a:r>
+              <a:rPr sz="2800" b="0">
+                <a:solidFill>
+                  <a:srgbClr val="E6ECF2"/>
+                </a:solidFill>
+                <a:latin typeface="Courier New"/>
+              </a:rPr>
+              <a:t>db.food.insertOne({"_id" : 3,</a:t>
+            </a:r>
+          </a:p>
+          <a:p>
+            <a:pPr algn="l">
+              <a:lnSpc>
+                <a:spcPts val="3200"/>
+              </a:lnSpc>
+            </a:pPr>
+            <a:r>
+              <a:rPr sz="2800" b="0">
+                <a:solidFill>
+                  <a:srgbClr val="E6ECF2"/>
+                </a:solidFill>
+                <a:latin typeface="Courier New"/>
+              </a:rPr>
+              <a:t>  "fruit" : ["cherry", "banana", "apple"]})</a:t>
+            </a:r>
+          </a:p>
+        </p:txBody>
+      </p:sp>
+      <p:sp>
+        <p:nvSpPr>
+          <p:cNvPr id="6" name="EXEMPT_PASTE"/>
+          <p:cNvSpPr/>
+          <p:nvPr/>
+        </p:nvSpPr>
+        <p:spPr>
+          <a:xfrm>
+            <a:off x="411480" y="4234688"/>
+            <a:ext cx="11368735" cy="1402080"/>
           </a:xfrm>
           <a:prstGeom prst="rect">
             <a:avLst/>
@@ -34512,7 +35370,7 @@
       </p:sp>
       <p:sp>
         <p:nvSpPr>
-          <p:cNvPr id="5" name="EXEMPT_FOOTER"/>
+          <p:cNvPr id="7" name="EXEMPT_FOOTER"/>
           <p:cNvSpPr txBox="1"/>
           <p:nvPr/>
         </p:nvSpPr>
@@ -34551,7 +35409,7 @@
       </p:sp>
       <p:sp>
         <p:nvSpPr>
-          <p:cNvPr id="6" name="EXEMPT_PROGRESS"/>
+          <p:cNvPr id="8" name="EXEMPT_PROGRESS"/>
           <p:cNvSpPr txBox="1"/>
           <p:nvPr/>
         </p:nvSpPr>
@@ -34706,7 +35564,7 @@
         <p:spPr>
           <a:xfrm>
             <a:off x="411480" y="1097280"/>
-            <a:ext cx="11368735" cy="3886200"/>
+            <a:ext cx="11368735" cy="3840480"/>
           </a:xfrm>
           <a:prstGeom prst="rect">
             <a:avLst/>
@@ -35050,7 +35908,7 @@
         <p:spPr>
           <a:xfrm>
             <a:off x="411480" y="1097280"/>
-            <a:ext cx="11368735" cy="1005840"/>
+            <a:ext cx="11368735" cy="995679"/>
           </a:xfrm>
           <a:prstGeom prst="rect">
             <a:avLst/>
@@ -35094,7 +35952,7 @@
         <p:spPr>
           <a:xfrm>
             <a:off x="557784" y="1188720"/>
-            <a:ext cx="11149279" cy="896112"/>
+            <a:ext cx="11149279" cy="885951"/>
           </a:xfrm>
           <a:prstGeom prst="rect">
             <a:avLst/>
@@ -35109,7 +35967,7 @@
           <a:p>
             <a:pPr algn="l">
               <a:lnSpc>
-                <a:spcPct val="100000"/>
+                <a:spcPts val="3200"/>
               </a:lnSpc>
             </a:pPr>
             <a:r>
@@ -35125,7 +35983,7 @@
           <a:p>
             <a:pPr algn="l">
               <a:lnSpc>
-                <a:spcPct val="100000"/>
+                <a:spcPts val="3200"/>
               </a:lnSpc>
             </a:pPr>
             <a:r>
@@ -35148,8 +36006,8 @@
         </p:nvSpPr>
         <p:spPr>
           <a:xfrm>
-            <a:off x="411480" y="2212848"/>
-            <a:ext cx="11368735" cy="2240280"/>
+            <a:off x="411480" y="2202688"/>
+            <a:ext cx="11368735" cy="2214880"/>
           </a:xfrm>
           <a:prstGeom prst="rect">
             <a:avLst/>
@@ -35468,7 +36326,7 @@
         <p:spPr>
           <a:xfrm>
             <a:off x="411480" y="1097280"/>
-            <a:ext cx="11368735" cy="1005840"/>
+            <a:ext cx="11368735" cy="995679"/>
           </a:xfrm>
           <a:prstGeom prst="rect">
             <a:avLst/>
@@ -35512,7 +36370,7 @@
         <p:spPr>
           <a:xfrm>
             <a:off x="557784" y="1188720"/>
-            <a:ext cx="11149279" cy="896112"/>
+            <a:ext cx="11149279" cy="885951"/>
           </a:xfrm>
           <a:prstGeom prst="rect">
             <a:avLst/>
@@ -35527,7 +36385,7 @@
           <a:p>
             <a:pPr algn="l">
               <a:lnSpc>
-                <a:spcPct val="100000"/>
+                <a:spcPts val="3200"/>
               </a:lnSpc>
             </a:pPr>
             <a:r>
@@ -35543,7 +36401,7 @@
           <a:p>
             <a:pPr algn="l">
               <a:lnSpc>
-                <a:spcPct val="100000"/>
+                <a:spcPts val="3200"/>
               </a:lnSpc>
             </a:pPr>
             <a:r>
@@ -35566,8 +36424,8 @@
         </p:nvSpPr>
         <p:spPr>
           <a:xfrm>
-            <a:off x="411480" y="2212848"/>
-            <a:ext cx="11368735" cy="2240280"/>
+            <a:off x="411480" y="2202688"/>
+            <a:ext cx="11368735" cy="2214880"/>
           </a:xfrm>
           <a:prstGeom prst="rect">
             <a:avLst/>
@@ -35886,7 +36744,7 @@
         <p:spPr>
           <a:xfrm>
             <a:off x="411480" y="1097280"/>
-            <a:ext cx="11368735" cy="1005840"/>
+            <a:ext cx="11368735" cy="995679"/>
           </a:xfrm>
           <a:prstGeom prst="rect">
             <a:avLst/>
@@ -35930,7 +36788,7 @@
         <p:spPr>
           <a:xfrm>
             <a:off x="557784" y="1188720"/>
-            <a:ext cx="11149279" cy="896112"/>
+            <a:ext cx="11149279" cy="885951"/>
           </a:xfrm>
           <a:prstGeom prst="rect">
             <a:avLst/>
@@ -35945,7 +36803,7 @@
           <a:p>
             <a:pPr algn="l">
               <a:lnSpc>
-                <a:spcPct val="100000"/>
+                <a:spcPts val="3200"/>
               </a:lnSpc>
             </a:pPr>
             <a:r>
@@ -35961,7 +36819,7 @@
           <a:p>
             <a:pPr algn="l">
               <a:lnSpc>
-                <a:spcPct val="100000"/>
+                <a:spcPts val="3200"/>
               </a:lnSpc>
             </a:pPr>
             <a:r>
@@ -35984,8 +36842,8 @@
         </p:nvSpPr>
         <p:spPr>
           <a:xfrm>
-            <a:off x="411480" y="2212848"/>
-            <a:ext cx="11368735" cy="1828800"/>
+            <a:off x="411480" y="2202688"/>
+            <a:ext cx="11368735" cy="1808479"/>
           </a:xfrm>
           <a:prstGeom prst="rect">
             <a:avLst/>
@@ -36304,7 +37162,7 @@
         <p:spPr>
           <a:xfrm>
             <a:off x="411480" y="1097280"/>
-            <a:ext cx="11368735" cy="1005840"/>
+            <a:ext cx="11368735" cy="995679"/>
           </a:xfrm>
           <a:prstGeom prst="rect">
             <a:avLst/>
@@ -36348,7 +37206,7 @@
         <p:spPr>
           <a:xfrm>
             <a:off x="557784" y="1188720"/>
-            <a:ext cx="11149279" cy="896112"/>
+            <a:ext cx="11149279" cy="885951"/>
           </a:xfrm>
           <a:prstGeom prst="rect">
             <a:avLst/>
@@ -36363,7 +37221,7 @@
           <a:p>
             <a:pPr algn="l">
               <a:lnSpc>
-                <a:spcPct val="100000"/>
+                <a:spcPts val="3200"/>
               </a:lnSpc>
             </a:pPr>
             <a:r>
@@ -36379,7 +37237,7 @@
           <a:p>
             <a:pPr algn="l">
               <a:lnSpc>
-                <a:spcPct val="100000"/>
+                <a:spcPts val="3200"/>
               </a:lnSpc>
             </a:pPr>
             <a:r>
@@ -36396,7 +37254,46 @@
       </p:sp>
       <p:sp>
         <p:nvSpPr>
-          <p:cNvPr id="6" name="EXEMPT_FOOTER"/>
+          <p:cNvPr id="6" name="TextBox 5"/>
+          <p:cNvSpPr txBox="1"/>
+          <p:nvPr/>
+        </p:nvSpPr>
+        <p:spPr>
+          <a:xfrm>
+            <a:off x="411480" y="5696712"/>
+            <a:ext cx="11368735" cy="566928"/>
+          </a:xfrm>
+          <a:prstGeom prst="rect">
+            <a:avLst/>
+          </a:prstGeom>
+          <a:noFill/>
+        </p:spPr>
+        <p:txBody>
+          <a:bodyPr wrap="square" anchor="ctr" lIns="164592" rIns="164592" tIns="164592" bIns="164592">
+            <a:spAutoFit/>
+          </a:bodyPr>
+          <a:lstStyle/>
+          <a:p>
+            <a:pPr algn="r">
+              <a:lnSpc>
+                <a:spcPct val="100000"/>
+              </a:lnSpc>
+            </a:pPr>
+            <a:r>
+              <a:rPr sz="2800" b="0">
+                <a:solidFill>
+                  <a:srgbClr val="4A5868"/>
+                </a:solidFill>
+                <a:latin typeface="Arial"/>
+              </a:rPr>
+              <a:t>Next: RESULT  →</a:t>
+            </a:r>
+          </a:p>
+        </p:txBody>
+      </p:sp>
+      <p:sp>
+        <p:nvSpPr>
+          <p:cNvPr id="7" name="EXEMPT_FOOTER"/>
           <p:cNvSpPr txBox="1"/>
           <p:nvPr/>
         </p:nvSpPr>
@@ -36435,7 +37332,7 @@
       </p:sp>
       <p:sp>
         <p:nvSpPr>
-          <p:cNvPr id="7" name="EXEMPT_PROGRESS"/>
+          <p:cNvPr id="8" name="EXEMPT_PROGRESS"/>
           <p:cNvSpPr txBox="1"/>
           <p:nvPr/>
         </p:nvSpPr>
@@ -36590,7 +37487,7 @@
         <p:spPr>
           <a:xfrm>
             <a:off x="411480" y="1097280"/>
-            <a:ext cx="11368735" cy="3886200"/>
+            <a:ext cx="11368735" cy="3840480"/>
           </a:xfrm>
           <a:prstGeom prst="rect">
             <a:avLst/>
@@ -37130,7 +38027,7 @@
         <p:spPr>
           <a:xfrm>
             <a:off x="411480" y="1097280"/>
-            <a:ext cx="11368735" cy="1417320"/>
+            <a:ext cx="11368735" cy="1402080"/>
           </a:xfrm>
           <a:prstGeom prst="rect">
             <a:avLst/>
@@ -37229,8 +38126,8 @@
         </p:nvSpPr>
         <p:spPr>
           <a:xfrm>
-            <a:off x="411480" y="2624328"/>
-            <a:ext cx="11368735" cy="1828800"/>
+            <a:off x="411480" y="2609088"/>
+            <a:ext cx="11368735" cy="1808479"/>
           </a:xfrm>
           <a:prstGeom prst="rect">
             <a:avLst/>
@@ -37273,8 +38170,8 @@
         </p:nvSpPr>
         <p:spPr>
           <a:xfrm>
-            <a:off x="557784" y="2715768"/>
-            <a:ext cx="11149279" cy="1719072"/>
+            <a:off x="557784" y="2700528"/>
+            <a:ext cx="11149279" cy="1698752"/>
           </a:xfrm>
           <a:prstGeom prst="rect">
             <a:avLst/>
@@ -37289,7 +38186,7 @@
           <a:p>
             <a:pPr algn="l">
               <a:lnSpc>
-                <a:spcPct val="100000"/>
+                <a:spcPts val="3200"/>
               </a:lnSpc>
             </a:pPr>
             <a:r>
@@ -37305,7 +38202,7 @@
           <a:p>
             <a:pPr algn="l">
               <a:lnSpc>
-                <a:spcPct val="100000"/>
+                <a:spcPts val="3200"/>
               </a:lnSpc>
             </a:pPr>
             <a:r>
@@ -37321,7 +38218,7 @@
           <a:p>
             <a:pPr algn="l">
               <a:lnSpc>
-                <a:spcPct val="100000"/>
+                <a:spcPts val="3200"/>
               </a:lnSpc>
             </a:pPr>
             <a:r>
@@ -37337,7 +38234,7 @@
           <a:p>
             <a:pPr algn="l">
               <a:lnSpc>
-                <a:spcPct val="100000"/>
+                <a:spcPts val="3200"/>
               </a:lnSpc>
             </a:pPr>
             <a:r>
@@ -37354,7 +38251,46 @@
       </p:sp>
       <p:sp>
         <p:nvSpPr>
-          <p:cNvPr id="7" name="EXEMPT_FOOTER"/>
+          <p:cNvPr id="7" name="TextBox 6"/>
+          <p:cNvSpPr txBox="1"/>
+          <p:nvPr/>
+        </p:nvSpPr>
+        <p:spPr>
+          <a:xfrm>
+            <a:off x="411480" y="5696712"/>
+            <a:ext cx="11368735" cy="566928"/>
+          </a:xfrm>
+          <a:prstGeom prst="rect">
+            <a:avLst/>
+          </a:prstGeom>
+          <a:noFill/>
+        </p:spPr>
+        <p:txBody>
+          <a:bodyPr wrap="square" anchor="ctr" lIns="164592" rIns="164592" tIns="164592" bIns="164592">
+            <a:spAutoFit/>
+          </a:bodyPr>
+          <a:lstStyle/>
+          <a:p>
+            <a:pPr algn="r">
+              <a:lnSpc>
+                <a:spcPct val="100000"/>
+              </a:lnSpc>
+            </a:pPr>
+            <a:r>
+              <a:rPr sz="2800" b="0">
+                <a:solidFill>
+                  <a:srgbClr val="4A5868"/>
+                </a:solidFill>
+                <a:latin typeface="Arial"/>
+              </a:rPr>
+              <a:t>Next: 2  REPLY  →</a:t>
+            </a:r>
+          </a:p>
+        </p:txBody>
+      </p:sp>
+      <p:sp>
+        <p:nvSpPr>
+          <p:cNvPr id="8" name="EXEMPT_FOOTER"/>
           <p:cNvSpPr txBox="1"/>
           <p:nvPr/>
         </p:nvSpPr>
@@ -37393,7 +38329,7 @@
       </p:sp>
       <p:sp>
         <p:nvSpPr>
-          <p:cNvPr id="8" name="EXEMPT_FOOTER"/>
+          <p:cNvPr id="9" name="EXEMPT_FOOTER"/>
           <p:cNvSpPr txBox="1"/>
           <p:nvPr/>
         </p:nvSpPr>
@@ -37432,7 +38368,7 @@
       </p:sp>
       <p:sp>
         <p:nvSpPr>
-          <p:cNvPr id="9" name="EXEMPT_PROGRESS"/>
+          <p:cNvPr id="10" name="EXEMPT_PROGRESS"/>
           <p:cNvSpPr txBox="1"/>
           <p:nvPr/>
         </p:nvSpPr>
@@ -37937,7 +38873,7 @@
         <p:spPr>
           <a:xfrm>
             <a:off x="411480" y="1097280"/>
-            <a:ext cx="11368735" cy="1828800"/>
+            <a:ext cx="11368735" cy="1808479"/>
           </a:xfrm>
           <a:prstGeom prst="rect">
             <a:avLst/>
@@ -37981,7 +38917,7 @@
         <p:spPr>
           <a:xfrm>
             <a:off x="557784" y="1188720"/>
-            <a:ext cx="11149279" cy="1719072"/>
+            <a:ext cx="11149279" cy="1698752"/>
           </a:xfrm>
           <a:prstGeom prst="rect">
             <a:avLst/>
@@ -37996,7 +38932,7 @@
           <a:p>
             <a:pPr algn="l">
               <a:lnSpc>
-                <a:spcPct val="100000"/>
+                <a:spcPts val="3200"/>
               </a:lnSpc>
             </a:pPr>
             <a:r>
@@ -38012,7 +38948,7 @@
           <a:p>
             <a:pPr algn="l">
               <a:lnSpc>
-                <a:spcPct val="100000"/>
+                <a:spcPts val="3200"/>
               </a:lnSpc>
             </a:pPr>
             <a:r>
@@ -38028,7 +38964,7 @@
           <a:p>
             <a:pPr algn="l">
               <a:lnSpc>
-                <a:spcPct val="100000"/>
+                <a:spcPts val="3200"/>
               </a:lnSpc>
             </a:pPr>
             <a:r>
@@ -38044,7 +38980,7 @@
           <a:p>
             <a:pPr algn="l">
               <a:lnSpc>
-                <a:spcPct val="100000"/>
+                <a:spcPts val="3200"/>
               </a:lnSpc>
             </a:pPr>
             <a:r>
@@ -38061,7 +38997,46 @@
       </p:sp>
       <p:sp>
         <p:nvSpPr>
-          <p:cNvPr id="6" name="EXEMPT_FOOTER"/>
+          <p:cNvPr id="6" name="TextBox 5"/>
+          <p:cNvSpPr txBox="1"/>
+          <p:nvPr/>
+        </p:nvSpPr>
+        <p:spPr>
+          <a:xfrm>
+            <a:off x="411480" y="5696712"/>
+            <a:ext cx="11368735" cy="566928"/>
+          </a:xfrm>
+          <a:prstGeom prst="rect">
+            <a:avLst/>
+          </a:prstGeom>
+          <a:noFill/>
+        </p:spPr>
+        <p:txBody>
+          <a:bodyPr wrap="square" anchor="ctr" lIns="164592" rIns="164592" tIns="164592" bIns="164592">
+            <a:spAutoFit/>
+          </a:bodyPr>
+          <a:lstStyle/>
+          <a:p>
+            <a:pPr algn="r">
+              <a:lnSpc>
+                <a:spcPct val="100000"/>
+              </a:lnSpc>
+            </a:pPr>
+            <a:r>
+              <a:rPr sz="2800" b="0">
+                <a:solidFill>
+                  <a:srgbClr val="4A5868"/>
+                </a:solidFill>
+                <a:latin typeface="Arial"/>
+              </a:rPr>
+              <a:t>Next: RESULT  →</a:t>
+            </a:r>
+          </a:p>
+        </p:txBody>
+      </p:sp>
+      <p:sp>
+        <p:nvSpPr>
+          <p:cNvPr id="7" name="EXEMPT_FOOTER"/>
           <p:cNvSpPr txBox="1"/>
           <p:nvPr/>
         </p:nvSpPr>
@@ -38100,7 +39075,7 @@
       </p:sp>
       <p:sp>
         <p:nvSpPr>
-          <p:cNvPr id="7" name="EXEMPT_PROGRESS"/>
+          <p:cNvPr id="8" name="EXEMPT_PROGRESS"/>
           <p:cNvSpPr txBox="1"/>
           <p:nvPr/>
         </p:nvSpPr>
@@ -38255,7 +39230,7 @@
         <p:spPr>
           <a:xfrm>
             <a:off x="411480" y="1097280"/>
-            <a:ext cx="11368735" cy="3063240"/>
+            <a:ext cx="11368735" cy="3027680"/>
           </a:xfrm>
           <a:prstGeom prst="rect">
             <a:avLst/>
@@ -38574,7 +39549,7 @@
         <p:spPr>
           <a:xfrm>
             <a:off x="411480" y="1097280"/>
-            <a:ext cx="11368735" cy="1417320"/>
+            <a:ext cx="11368735" cy="1402080"/>
           </a:xfrm>
           <a:prstGeom prst="rect">
             <a:avLst/>
@@ -38618,7 +39593,7 @@
         <p:spPr>
           <a:xfrm>
             <a:off x="557784" y="1188720"/>
-            <a:ext cx="11149279" cy="1307592"/>
+            <a:ext cx="11149279" cy="1292351"/>
           </a:xfrm>
           <a:prstGeom prst="rect">
             <a:avLst/>
@@ -38633,7 +39608,7 @@
           <a:p>
             <a:pPr algn="l">
               <a:lnSpc>
-                <a:spcPct val="100000"/>
+                <a:spcPts val="3200"/>
               </a:lnSpc>
             </a:pPr>
             <a:r>
@@ -38649,7 +39624,7 @@
           <a:p>
             <a:pPr algn="l">
               <a:lnSpc>
-                <a:spcPct val="100000"/>
+                <a:spcPts val="3200"/>
               </a:lnSpc>
             </a:pPr>
             <a:r>
@@ -38665,7 +39640,7 @@
           <a:p>
             <a:pPr algn="l">
               <a:lnSpc>
-                <a:spcPct val="100000"/>
+                <a:spcPts val="3200"/>
               </a:lnSpc>
             </a:pPr>
             <a:r>
@@ -38682,7 +39657,46 @@
       </p:sp>
       <p:sp>
         <p:nvSpPr>
-          <p:cNvPr id="6" name="EXEMPT_FOOTER"/>
+          <p:cNvPr id="6" name="TextBox 5"/>
+          <p:cNvSpPr txBox="1"/>
+          <p:nvPr/>
+        </p:nvSpPr>
+        <p:spPr>
+          <a:xfrm>
+            <a:off x="411480" y="5696712"/>
+            <a:ext cx="11368735" cy="566928"/>
+          </a:xfrm>
+          <a:prstGeom prst="rect">
+            <a:avLst/>
+          </a:prstGeom>
+          <a:noFill/>
+        </p:spPr>
+        <p:txBody>
+          <a:bodyPr wrap="square" anchor="ctr" lIns="164592" rIns="164592" tIns="164592" bIns="164592">
+            <a:spAutoFit/>
+          </a:bodyPr>
+          <a:lstStyle/>
+          <a:p>
+            <a:pPr algn="r">
+              <a:lnSpc>
+                <a:spcPct val="100000"/>
+              </a:lnSpc>
+            </a:pPr>
+            <a:r>
+              <a:rPr sz="2800" b="0">
+                <a:solidFill>
+                  <a:srgbClr val="4A5868"/>
+                </a:solidFill>
+                <a:latin typeface="Arial"/>
+              </a:rPr>
+              <a:t>Next: RESULT  →</a:t>
+            </a:r>
+          </a:p>
+        </p:txBody>
+      </p:sp>
+      <p:sp>
+        <p:nvSpPr>
+          <p:cNvPr id="7" name="EXEMPT_FOOTER"/>
           <p:cNvSpPr txBox="1"/>
           <p:nvPr/>
         </p:nvSpPr>
@@ -38721,7 +39735,7 @@
       </p:sp>
       <p:sp>
         <p:nvSpPr>
-          <p:cNvPr id="7" name="EXEMPT_PROGRESS"/>
+          <p:cNvPr id="8" name="EXEMPT_PROGRESS"/>
           <p:cNvSpPr txBox="1"/>
           <p:nvPr/>
         </p:nvSpPr>
@@ -38876,7 +39890,7 @@
         <p:spPr>
           <a:xfrm>
             <a:off x="411480" y="1097280"/>
-            <a:ext cx="11368735" cy="3063240"/>
+            <a:ext cx="11368735" cy="3027680"/>
           </a:xfrm>
           <a:prstGeom prst="rect">
             <a:avLst/>
@@ -39195,7 +40209,7 @@
         <p:spPr>
           <a:xfrm>
             <a:off x="411480" y="1097280"/>
-            <a:ext cx="11368735" cy="1417320"/>
+            <a:ext cx="11368735" cy="1402080"/>
           </a:xfrm>
           <a:prstGeom prst="rect">
             <a:avLst/>
@@ -39239,7 +40253,7 @@
         <p:spPr>
           <a:xfrm>
             <a:off x="557784" y="1188720"/>
-            <a:ext cx="11149279" cy="1307592"/>
+            <a:ext cx="11149279" cy="1292351"/>
           </a:xfrm>
           <a:prstGeom prst="rect">
             <a:avLst/>
@@ -39254,7 +40268,7 @@
           <a:p>
             <a:pPr algn="l">
               <a:lnSpc>
-                <a:spcPct val="100000"/>
+                <a:spcPts val="3200"/>
               </a:lnSpc>
             </a:pPr>
             <a:r>
@@ -39270,7 +40284,7 @@
           <a:p>
             <a:pPr algn="l">
               <a:lnSpc>
-                <a:spcPct val="100000"/>
+                <a:spcPts val="3200"/>
               </a:lnSpc>
             </a:pPr>
             <a:r>
@@ -39286,7 +40300,7 @@
           <a:p>
             <a:pPr algn="l">
               <a:lnSpc>
-                <a:spcPct val="100000"/>
+                <a:spcPts val="3200"/>
               </a:lnSpc>
             </a:pPr>
             <a:r>
@@ -39303,7 +40317,46 @@
       </p:sp>
       <p:sp>
         <p:nvSpPr>
-          <p:cNvPr id="6" name="EXEMPT_FOOTER"/>
+          <p:cNvPr id="6" name="TextBox 5"/>
+          <p:cNvSpPr txBox="1"/>
+          <p:nvPr/>
+        </p:nvSpPr>
+        <p:spPr>
+          <a:xfrm>
+            <a:off x="411480" y="5696712"/>
+            <a:ext cx="11368735" cy="566928"/>
+          </a:xfrm>
+          <a:prstGeom prst="rect">
+            <a:avLst/>
+          </a:prstGeom>
+          <a:noFill/>
+        </p:spPr>
+        <p:txBody>
+          <a:bodyPr wrap="square" anchor="ctr" lIns="164592" rIns="164592" tIns="164592" bIns="164592">
+            <a:spAutoFit/>
+          </a:bodyPr>
+          <a:lstStyle/>
+          <a:p>
+            <a:pPr algn="r">
+              <a:lnSpc>
+                <a:spcPct val="100000"/>
+              </a:lnSpc>
+            </a:pPr>
+            <a:r>
+              <a:rPr sz="2800" b="0">
+                <a:solidFill>
+                  <a:srgbClr val="4A5868"/>
+                </a:solidFill>
+                <a:latin typeface="Arial"/>
+              </a:rPr>
+              <a:t>Next: RESULT  →</a:t>
+            </a:r>
+          </a:p>
+        </p:txBody>
+      </p:sp>
+      <p:sp>
+        <p:nvSpPr>
+          <p:cNvPr id="7" name="EXEMPT_FOOTER"/>
           <p:cNvSpPr txBox="1"/>
           <p:nvPr/>
         </p:nvSpPr>
@@ -39342,7 +40395,7 @@
       </p:sp>
       <p:sp>
         <p:nvSpPr>
-          <p:cNvPr id="7" name="EXEMPT_PROGRESS"/>
+          <p:cNvPr id="8" name="EXEMPT_PROGRESS"/>
           <p:cNvSpPr txBox="1"/>
           <p:nvPr/>
         </p:nvSpPr>
@@ -39497,7 +40550,7 @@
         <p:spPr>
           <a:xfrm>
             <a:off x="411480" y="1097280"/>
-            <a:ext cx="11368735" cy="3063240"/>
+            <a:ext cx="11368735" cy="3027680"/>
           </a:xfrm>
           <a:prstGeom prst="rect">
             <a:avLst/>
@@ -39816,7 +40869,7 @@
         <p:spPr>
           <a:xfrm>
             <a:off x="411480" y="1097280"/>
-            <a:ext cx="11368735" cy="1417320"/>
+            <a:ext cx="11368735" cy="1402080"/>
           </a:xfrm>
           <a:prstGeom prst="rect">
             <a:avLst/>
@@ -39860,7 +40913,7 @@
         <p:spPr>
           <a:xfrm>
             <a:off x="557784" y="1188720"/>
-            <a:ext cx="11149279" cy="1307592"/>
+            <a:ext cx="11149279" cy="1292351"/>
           </a:xfrm>
           <a:prstGeom prst="rect">
             <a:avLst/>
@@ -39875,7 +40928,7 @@
           <a:p>
             <a:pPr algn="l">
               <a:lnSpc>
-                <a:spcPct val="100000"/>
+                <a:spcPts val="3200"/>
               </a:lnSpc>
             </a:pPr>
             <a:r>
@@ -39891,7 +40944,7 @@
           <a:p>
             <a:pPr algn="l">
               <a:lnSpc>
-                <a:spcPct val="100000"/>
+                <a:spcPts val="3200"/>
               </a:lnSpc>
             </a:pPr>
             <a:r>
@@ -39907,7 +40960,7 @@
           <a:p>
             <a:pPr algn="l">
               <a:lnSpc>
-                <a:spcPct val="100000"/>
+                <a:spcPts val="3200"/>
               </a:lnSpc>
             </a:pPr>
             <a:r>
@@ -39924,7 +40977,46 @@
       </p:sp>
       <p:sp>
         <p:nvSpPr>
-          <p:cNvPr id="6" name="EXEMPT_FOOTER"/>
+          <p:cNvPr id="6" name="TextBox 5"/>
+          <p:cNvSpPr txBox="1"/>
+          <p:nvPr/>
+        </p:nvSpPr>
+        <p:spPr>
+          <a:xfrm>
+            <a:off x="411480" y="5696712"/>
+            <a:ext cx="11368735" cy="566928"/>
+          </a:xfrm>
+          <a:prstGeom prst="rect">
+            <a:avLst/>
+          </a:prstGeom>
+          <a:noFill/>
+        </p:spPr>
+        <p:txBody>
+          <a:bodyPr wrap="square" anchor="ctr" lIns="164592" rIns="164592" tIns="164592" bIns="164592">
+            <a:spAutoFit/>
+          </a:bodyPr>
+          <a:lstStyle/>
+          <a:p>
+            <a:pPr algn="r">
+              <a:lnSpc>
+                <a:spcPct val="100000"/>
+              </a:lnSpc>
+            </a:pPr>
+            <a:r>
+              <a:rPr sz="2800" b="0">
+                <a:solidFill>
+                  <a:srgbClr val="4A5868"/>
+                </a:solidFill>
+                <a:latin typeface="Arial"/>
+              </a:rPr>
+              <a:t>Next: RESULT  →</a:t>
+            </a:r>
+          </a:p>
+        </p:txBody>
+      </p:sp>
+      <p:sp>
+        <p:nvSpPr>
+          <p:cNvPr id="7" name="EXEMPT_FOOTER"/>
           <p:cNvSpPr txBox="1"/>
           <p:nvPr/>
         </p:nvSpPr>
@@ -39963,7 +41055,7 @@
       </p:sp>
       <p:sp>
         <p:nvSpPr>
-          <p:cNvPr id="7" name="EXEMPT_PROGRESS"/>
+          <p:cNvPr id="8" name="EXEMPT_PROGRESS"/>
           <p:cNvSpPr txBox="1"/>
           <p:nvPr/>
         </p:nvSpPr>
@@ -40118,7 +41210,7 @@
         <p:spPr>
           <a:xfrm>
             <a:off x="411480" y="1097280"/>
-            <a:ext cx="11368735" cy="3474720"/>
+            <a:ext cx="11368735" cy="3434080"/>
           </a:xfrm>
           <a:prstGeom prst="rect">
             <a:avLst/>
@@ -40658,7 +41750,7 @@
         <p:spPr>
           <a:xfrm>
             <a:off x="411480" y="1097280"/>
-            <a:ext cx="11368735" cy="3886200"/>
+            <a:ext cx="11368735" cy="3840480"/>
           </a:xfrm>
           <a:prstGeom prst="rect">
             <a:avLst/>
@@ -40726,7 +41818,46 @@
       </p:sp>
       <p:sp>
         <p:nvSpPr>
-          <p:cNvPr id="5" name="EXEMPT_FOOTER"/>
+          <p:cNvPr id="5" name="TextBox 4"/>
+          <p:cNvSpPr txBox="1"/>
+          <p:nvPr/>
+        </p:nvSpPr>
+        <p:spPr>
+          <a:xfrm>
+            <a:off x="411480" y="5696712"/>
+            <a:ext cx="11368735" cy="566928"/>
+          </a:xfrm>
+          <a:prstGeom prst="rect">
+            <a:avLst/>
+          </a:prstGeom>
+          <a:noFill/>
+        </p:spPr>
+        <p:txBody>
+          <a:bodyPr wrap="square" anchor="ctr" lIns="164592" rIns="164592" tIns="164592" bIns="164592">
+            <a:spAutoFit/>
+          </a:bodyPr>
+          <a:lstStyle/>
+          <a:p>
+            <a:pPr algn="r">
+              <a:lnSpc>
+                <a:spcPct val="100000"/>
+              </a:lnSpc>
+            </a:pPr>
+            <a:r>
+              <a:rPr sz="2800" b="0">
+                <a:solidFill>
+                  <a:srgbClr val="4A5868"/>
+                </a:solidFill>
+                <a:latin typeface="Arial"/>
+              </a:rPr>
+              <a:t>Next: 3  AFTER  →</a:t>
+            </a:r>
+          </a:p>
+        </p:txBody>
+      </p:sp>
+      <p:sp>
+        <p:nvSpPr>
+          <p:cNvPr id="6" name="EXEMPT_FOOTER"/>
           <p:cNvSpPr txBox="1"/>
           <p:nvPr/>
         </p:nvSpPr>
@@ -40765,7 +41896,7 @@
       </p:sp>
       <p:sp>
         <p:nvSpPr>
-          <p:cNvPr id="6" name="EXEMPT_FOOTER"/>
+          <p:cNvPr id="7" name="EXEMPT_FOOTER"/>
           <p:cNvSpPr txBox="1"/>
           <p:nvPr/>
         </p:nvSpPr>
@@ -40804,7 +41935,7 @@
       </p:sp>
       <p:sp>
         <p:nvSpPr>
-          <p:cNvPr id="7" name="EXEMPT_PROGRESS"/>
+          <p:cNvPr id="8" name="EXEMPT_PROGRESS"/>
           <p:cNvSpPr txBox="1"/>
           <p:nvPr/>
         </p:nvSpPr>
@@ -41302,7 +42433,7 @@
         </p:nvGraphicFramePr>
         <p:xfrm>
           <a:off x="411480" y="1234439"/>
-          <a:ext cx="11368735" cy="2852928"/>
+          <a:ext cx="11368735" cy="3657600"/>
         </p:xfrm>
         <a:graphic>
           <a:graphicData uri="http://schemas.openxmlformats.org/drawingml/2006/table">
@@ -41314,7 +42445,7 @@
                 <a:gridCol w="3291840"/>
                 <a:gridCol w="8076895"/>
               </a:tblGrid>
-              <a:tr h="713232">
+              <a:tr h="914400">
                 <a:tc>
                   <a:txBody>
                     <a:bodyPr wrap="square" anchor="ctr" lIns="109728" rIns="109728" tIns="109728" bIns="109728"/>
@@ -41370,7 +42501,7 @@
                   </a:tcPr>
                 </a:tc>
               </a:tr>
-              <a:tr h="713232">
+              <a:tr h="914400">
                 <a:tc>
                   <a:txBody>
                     <a:bodyPr wrap="square" anchor="ctr" lIns="109728" rIns="109728" tIns="109728" bIns="109728"/>
@@ -41426,7 +42557,7 @@
                   </a:tcPr>
                 </a:tc>
               </a:tr>
-              <a:tr h="713232">
+              <a:tr h="914400">
                 <a:tc>
                   <a:txBody>
                     <a:bodyPr wrap="square" anchor="ctr" lIns="109728" rIns="109728" tIns="109728" bIns="109728"/>
@@ -41482,7 +42613,7 @@
                   </a:tcPr>
                 </a:tc>
               </a:tr>
-              <a:tr h="713232">
+              <a:tr h="914400">
                 <a:tc>
                   <a:txBody>
                     <a:bodyPr wrap="square" anchor="ctr" lIns="109728" rIns="109728" tIns="109728" bIns="109728"/>
@@ -44113,7 +45244,7 @@
         </p:nvGraphicFramePr>
         <p:xfrm>
           <a:off x="411480" y="1234439"/>
-          <a:ext cx="11368735" cy="2852928"/>
+          <a:ext cx="11368735" cy="3657600"/>
         </p:xfrm>
         <a:graphic>
           <a:graphicData uri="http://schemas.openxmlformats.org/drawingml/2006/table">
@@ -44125,7 +45256,7 @@
                 <a:gridCol w="3291840"/>
                 <a:gridCol w="8076895"/>
               </a:tblGrid>
-              <a:tr h="713232">
+              <a:tr h="914400">
                 <a:tc>
                   <a:txBody>
                     <a:bodyPr wrap="square" anchor="ctr" lIns="109728" rIns="109728" tIns="109728" bIns="109728"/>
@@ -44181,7 +45312,7 @@
                   </a:tcPr>
                 </a:tc>
               </a:tr>
-              <a:tr h="713232">
+              <a:tr h="914400">
                 <a:tc>
                   <a:txBody>
                     <a:bodyPr wrap="square" anchor="ctr" lIns="109728" rIns="109728" tIns="109728" bIns="109728"/>
@@ -44237,7 +45368,7 @@
                   </a:tcPr>
                 </a:tc>
               </a:tr>
-              <a:tr h="713232">
+              <a:tr h="914400">
                 <a:tc>
                   <a:txBody>
                     <a:bodyPr wrap="square" anchor="ctr" lIns="109728" rIns="109728" tIns="109728" bIns="109728"/>
@@ -44293,7 +45424,7 @@
                   </a:tcPr>
                 </a:tc>
               </a:tr>
-              <a:tr h="713232">
+              <a:tr h="914400">
                 <a:tc>
                   <a:txBody>
                     <a:bodyPr wrap="square" anchor="ctr" lIns="109728" rIns="109728" tIns="109728" bIns="109728"/>
@@ -46454,7 +47585,7 @@
         <p:spPr>
           <a:xfrm>
             <a:off x="411480" y="1097280"/>
-            <a:ext cx="11368735" cy="3063240"/>
+            <a:ext cx="11368735" cy="3027680"/>
           </a:xfrm>
           <a:prstGeom prst="rect">
             <a:avLst/>

</xml_diff>